<commit_message>
feat: integrate official DIVERGE 3D logo, full songs audio engine, author metadata, and executive closing slide
</commit_message>
<xml_diff>
--- a/docs/presentation.pptx
+++ b/docs/presentation.pptx
@@ -3142,16 +3142,40 @@
           </a:p>
         </p:txBody>
       </p:sp>
-      <p:sp>
-        <p:nvSpPr>
-          <p:cNvPr id="3" name="TextBox 2"/>
+      <p:pic>
+        <p:nvPicPr>
+          <p:cNvPr id="3" name="Picture 2" descr="logo.png"/>
+          <p:cNvPicPr>
+            <a:picLocks noChangeAspect="1"/>
+          </p:cNvPicPr>
+          <p:nvPr/>
+        </p:nvPicPr>
+        <p:blipFill>
+          <a:blip r:embed="rId2"/>
+          <a:stretch>
+            <a:fillRect/>
+          </a:stretch>
+        </p:blipFill>
+        <p:spPr>
+          <a:xfrm>
+            <a:off x="914400" y="1645920"/>
+            <a:ext cx="2926080" cy="3008376"/>
+          </a:xfrm>
+          <a:prstGeom prst="rect">
+            <a:avLst/>
+          </a:prstGeom>
+        </p:spPr>
+      </p:pic>
+      <p:sp>
+        <p:nvSpPr>
+          <p:cNvPr id="4" name="TextBox 3"/>
           <p:cNvSpPr txBox="1"/>
           <p:nvPr/>
         </p:nvSpPr>
         <p:spPr>
           <a:xfrm>
-            <a:off x="1097280" y="2011680"/>
-            <a:ext cx="10058400" cy="2743200"/>
+            <a:off x="4206240" y="1280160"/>
+            <a:ext cx="7315200" cy="4754880"/>
           </a:xfrm>
           <a:prstGeom prst="rect">
             <a:avLst/>
@@ -3166,9 +3190,9 @@
           <a:p>
             <a:pPr>
               <a:spcAft>
-                <a:spcPts val="1000"/>
-              </a:spcAft>
-              <a:defRPr sz="5400" b="1">
+                <a:spcPts val="400"/>
+              </a:spcAft>
+              <a:defRPr sz="5000" b="1">
                 <a:solidFill>
                   <a:srgbClr val="B19AFF"/>
                 </a:solidFill>
@@ -3181,28 +3205,88 @@
           <a:p>
             <a:pPr>
               <a:spcAft>
-                <a:spcPts val="2000"/>
-              </a:spcAft>
-              <a:defRPr sz="2200">
-                <a:solidFill>
-                  <a:srgbClr val="F5F0E8"/>
-                </a:solidFill>
-              </a:defRPr>
-            </a:pPr>
-            <a:r>
-              <a:t>A High-Performance Music Streaming Platform Using Go and Svelte</a:t>
-            </a:r>
-          </a:p>
-          <a:p>
-            <a:pPr>
-              <a:defRPr sz="1400">
+                <a:spcPts val="1400"/>
+              </a:spcAft>
+              <a:defRPr sz="1800" b="1">
                 <a:solidFill>
                   <a:srgbClr val="FF796C"/>
                 </a:solidFill>
               </a:defRPr>
             </a:pPr>
             <a:r>
-              <a:t>Take the uncommon route. — 45-Day Capstone Project Evaluation</a:t>
+              <a:t>Take the uncommon route.</a:t>
+            </a:r>
+          </a:p>
+          <a:p>
+            <a:pPr>
+              <a:spcAft>
+                <a:spcPts val="1800"/>
+              </a:spcAft>
+              <a:defRPr sz="1700">
+                <a:solidFill>
+                  <a:srgbClr val="F5F0E8"/>
+                </a:solidFill>
+              </a:defRPr>
+            </a:pPr>
+            <a:r>
+              <a:t>A High-Performance Music Streaming Platform Using Go &amp; SvelteKit</a:t>
+            </a:r>
+          </a:p>
+          <a:p>
+            <a:pPr>
+              <a:spcAft>
+                <a:spcPts val="600"/>
+              </a:spcAft>
+              <a:defRPr sz="1400" b="1">
+                <a:solidFill>
+                  <a:srgbClr val="B19AFF"/>
+                </a:solidFill>
+              </a:defRPr>
+            </a:pPr>
+            <a:r>
+              <a:t>Author / Intern: Dharshan V | Software Developer</a:t>
+            </a:r>
+          </a:p>
+          <a:p>
+            <a:pPr>
+              <a:spcAft>
+                <a:spcPts val="400"/>
+              </a:spcAft>
+              <a:defRPr sz="1200">
+                <a:solidFill>
+                  <a:srgbClr val="AAA4BB"/>
+                </a:solidFill>
+              </a:defRPr>
+            </a:pPr>
+            <a:r>
+              <a:t>Program: Tech Vedhu Internship Project Submission</a:t>
+            </a:r>
+          </a:p>
+          <a:p>
+            <a:pPr>
+              <a:spcAft>
+                <a:spcPts val="400"/>
+              </a:spcAft>
+              <a:defRPr sz="1200">
+                <a:solidFill>
+                  <a:srgbClr val="AAA4BB"/>
+                </a:solidFill>
+              </a:defRPr>
+            </a:pPr>
+            <a:r>
+              <a:t>Primary Track: Full-Stack Web Development (Go, SvelteKit, PostgreSQL)</a:t>
+            </a:r>
+          </a:p>
+          <a:p>
+            <a:pPr>
+              <a:defRPr sz="1100">
+                <a:solidFill>
+                  <a:srgbClr val="AAA4BB"/>
+                </a:solidFill>
+              </a:defRPr>
+            </a:pPr>
+            <a:r>
+              <a:t>Initiated: October 10, 2026 | Capstone Milestone | Submission: October 30, 2026</a:t>
             </a:r>
           </a:p>
         </p:txBody>
@@ -3268,16 +3352,40 @@
           </a:p>
         </p:txBody>
       </p:sp>
-      <p:sp>
-        <p:nvSpPr>
-          <p:cNvPr id="3" name="TextBox 2"/>
+      <p:pic>
+        <p:nvPicPr>
+          <p:cNvPr id="3" name="Picture 2" descr="logo-mark.png"/>
+          <p:cNvPicPr>
+            <a:picLocks noChangeAspect="1"/>
+          </p:cNvPicPr>
+          <p:nvPr/>
+        </p:nvPicPr>
+        <p:blipFill>
+          <a:blip r:embed="rId2"/>
+          <a:stretch>
+            <a:fillRect/>
+          </a:stretch>
+        </p:blipFill>
+        <p:spPr>
+          <a:xfrm>
+            <a:off x="10972800" y="365760"/>
+            <a:ext cx="594360" cy="594360"/>
+          </a:xfrm>
+          <a:prstGeom prst="rect">
+            <a:avLst/>
+          </a:prstGeom>
+        </p:spPr>
+      </p:pic>
+      <p:sp>
+        <p:nvSpPr>
+          <p:cNvPr id="4" name="TextBox 3"/>
           <p:cNvSpPr txBox="1"/>
           <p:nvPr/>
         </p:nvSpPr>
         <p:spPr>
           <a:xfrm>
-            <a:off x="731520" y="457200"/>
-            <a:ext cx="9144000" cy="365760"/>
+            <a:off x="731520" y="411480"/>
+            <a:ext cx="9144000" cy="320040"/>
           </a:xfrm>
           <a:prstGeom prst="rect">
             <a:avLst/>
@@ -3291,27 +3399,27 @@
           <a:lstStyle/>
           <a:p>
             <a:pPr>
-              <a:defRPr sz="1100" b="1">
+              <a:defRPr sz="1000" b="1">
                 <a:solidFill>
                   <a:srgbClr val="B19AFF"/>
                 </a:solidFill>
               </a:defRPr>
             </a:pPr>
             <a:r>
-              <a:t>DIVERGE INTERNSHIP CAPSTONE</a:t>
-            </a:r>
-          </a:p>
-        </p:txBody>
-      </p:sp>
-      <p:sp>
-        <p:nvSpPr>
-          <p:cNvPr id="4" name="TextBox 3"/>
+              <a:t>TECH VEDHU INTERNSHIP CAPSTONE</a:t>
+            </a:r>
+          </a:p>
+        </p:txBody>
+      </p:sp>
+      <p:sp>
+        <p:nvSpPr>
+          <p:cNvPr id="5" name="TextBox 4"/>
           <p:cNvSpPr txBox="1"/>
           <p:nvPr/>
         </p:nvSpPr>
         <p:spPr>
           <a:xfrm>
-            <a:off x="731520" y="777240"/>
+            <a:off x="731520" y="731520"/>
             <a:ext cx="10058400" cy="731520"/>
           </a:xfrm>
           <a:prstGeom prst="rect">
@@ -3326,7 +3434,7 @@
           <a:lstStyle/>
           <a:p>
             <a:pPr>
-              <a:defRPr sz="2800" b="1">
+              <a:defRPr sz="2600" b="1">
                 <a:solidFill>
                   <a:srgbClr val="F5F0E8"/>
                 </a:solidFill>
@@ -3340,7 +3448,7 @@
       </p:sp>
       <p:sp>
         <p:nvSpPr>
-          <p:cNvPr id="5" name="Rounded Rectangle 4"/>
+          <p:cNvPr id="6" name="Rounded Rectangle 5"/>
           <p:cNvSpPr/>
           <p:nvPr/>
         </p:nvSpPr>
@@ -3409,7 +3517,7 @@
       </p:sp>
       <p:sp>
         <p:nvSpPr>
-          <p:cNvPr id="6" name="Rounded Rectangle 5"/>
+          <p:cNvPr id="7" name="Rounded Rectangle 6"/>
           <p:cNvSpPr/>
           <p:nvPr/>
         </p:nvSpPr>
@@ -3478,7 +3586,7 @@
       </p:sp>
       <p:sp>
         <p:nvSpPr>
-          <p:cNvPr id="7" name="Rounded Rectangle 6"/>
+          <p:cNvPr id="8" name="Rounded Rectangle 7"/>
           <p:cNvSpPr/>
           <p:nvPr/>
         </p:nvSpPr>
@@ -3547,7 +3655,7 @@
       </p:sp>
       <p:sp>
         <p:nvSpPr>
-          <p:cNvPr id="8" name="Rounded Rectangle 7"/>
+          <p:cNvPr id="9" name="Rounded Rectangle 8"/>
           <p:cNvSpPr/>
           <p:nvPr/>
         </p:nvSpPr>
@@ -3675,16 +3783,40 @@
           </a:p>
         </p:txBody>
       </p:sp>
-      <p:sp>
-        <p:nvSpPr>
-          <p:cNvPr id="3" name="TextBox 2"/>
+      <p:pic>
+        <p:nvPicPr>
+          <p:cNvPr id="3" name="Picture 2" descr="logo-mark.png"/>
+          <p:cNvPicPr>
+            <a:picLocks noChangeAspect="1"/>
+          </p:cNvPicPr>
+          <p:nvPr/>
+        </p:nvPicPr>
+        <p:blipFill>
+          <a:blip r:embed="rId2"/>
+          <a:stretch>
+            <a:fillRect/>
+          </a:stretch>
+        </p:blipFill>
+        <p:spPr>
+          <a:xfrm>
+            <a:off x="10972800" y="365760"/>
+            <a:ext cx="594360" cy="594360"/>
+          </a:xfrm>
+          <a:prstGeom prst="rect">
+            <a:avLst/>
+          </a:prstGeom>
+        </p:spPr>
+      </p:pic>
+      <p:sp>
+        <p:nvSpPr>
+          <p:cNvPr id="4" name="TextBox 3"/>
           <p:cNvSpPr txBox="1"/>
           <p:nvPr/>
         </p:nvSpPr>
         <p:spPr>
           <a:xfrm>
-            <a:off x="731520" y="457200"/>
-            <a:ext cx="9144000" cy="365760"/>
+            <a:off x="731520" y="411480"/>
+            <a:ext cx="9144000" cy="320040"/>
           </a:xfrm>
           <a:prstGeom prst="rect">
             <a:avLst/>
@@ -3698,27 +3830,27 @@
           <a:lstStyle/>
           <a:p>
             <a:pPr>
-              <a:defRPr sz="1100" b="1">
+              <a:defRPr sz="1000" b="1">
                 <a:solidFill>
                   <a:srgbClr val="B19AFF"/>
                 </a:solidFill>
               </a:defRPr>
             </a:pPr>
             <a:r>
-              <a:t>DIVERGE INTERNSHIP CAPSTONE</a:t>
-            </a:r>
-          </a:p>
-        </p:txBody>
-      </p:sp>
-      <p:sp>
-        <p:nvSpPr>
-          <p:cNvPr id="4" name="TextBox 3"/>
+              <a:t>TECH VEDHU INTERNSHIP CAPSTONE</a:t>
+            </a:r>
+          </a:p>
+        </p:txBody>
+      </p:sp>
+      <p:sp>
+        <p:nvSpPr>
+          <p:cNvPr id="5" name="TextBox 4"/>
           <p:cNvSpPr txBox="1"/>
           <p:nvPr/>
         </p:nvSpPr>
         <p:spPr>
           <a:xfrm>
-            <a:off x="731520" y="777240"/>
+            <a:off x="731520" y="731520"/>
             <a:ext cx="10058400" cy="731520"/>
           </a:xfrm>
           <a:prstGeom prst="rect">
@@ -3733,21 +3865,21 @@
           <a:lstStyle/>
           <a:p>
             <a:pPr>
-              <a:defRPr sz="2800" b="1">
-                <a:solidFill>
-                  <a:srgbClr val="F5F0E8"/>
-                </a:solidFill>
-              </a:defRPr>
-            </a:pPr>
-            <a:r>
-              <a:t>Offline Architecture &amp; Verification Results</a:t>
-            </a:r>
-          </a:p>
-        </p:txBody>
-      </p:sp>
-      <p:sp>
-        <p:nvSpPr>
-          <p:cNvPr id="5" name="Rounded Rectangle 4"/>
+              <a:defRPr sz="2600" b="1">
+                <a:solidFill>
+                  <a:srgbClr val="F5F0E8"/>
+                </a:solidFill>
+              </a:defRPr>
+            </a:pPr>
+            <a:r>
+              <a:t>Verification Pass Rate &amp; Platform Roadmap</a:t>
+            </a:r>
+          </a:p>
+        </p:txBody>
+      </p:sp>
+      <p:sp>
+        <p:nvSpPr>
+          <p:cNvPr id="6" name="Rounded Rectangle 5"/>
           <p:cNvSpPr/>
           <p:nvPr/>
         </p:nvSpPr>
@@ -3797,74 +3929,214 @@
               </a:defRPr>
             </a:pPr>
             <a:r>
-              <a:t>Offline Playback Engine</a:t>
-            </a:r>
-          </a:p>
-          <a:p>
-            <a:pPr>
-              <a:spcAft>
-                <a:spcPts val="800"/>
-              </a:spcAft>
-              <a:defRPr sz="1200">
-                <a:solidFill>
-                  <a:srgbClr val="F5F0E8"/>
-                </a:solidFill>
-              </a:defRPr>
-            </a:pPr>
-            <a:r>
-              <a:t>• Browser IndexedDB database (`diverge_offline_db`) stores binary audio blobs.</a:t>
-            </a:r>
-          </a:p>
-          <a:p>
-            <a:pPr>
-              <a:spcAft>
-                <a:spcPts val="800"/>
-              </a:spcAft>
-              <a:defRPr sz="1200">
-                <a:solidFill>
-                  <a:srgbClr val="F5F0E8"/>
-                </a:solidFill>
-              </a:defRPr>
-            </a:pPr>
-            <a:r>
-              <a:t>• Custom Service Worker (`sw.js`) intercepts app shell requests during offline mode.</a:t>
-            </a:r>
-          </a:p>
-          <a:p>
-            <a:pPr>
-              <a:spcAft>
-                <a:spcPts val="800"/>
-              </a:spcAft>
-              <a:defRPr sz="1200">
-                <a:solidFill>
-                  <a:srgbClr val="F5F0E8"/>
-                </a:solidFill>
-              </a:defRPr>
-            </a:pPr>
-            <a:r>
-              <a:t>• Track blob URLs (`URL.createObjectURL`) feed directly into player audio element.</a:t>
-            </a:r>
-          </a:p>
-          <a:p>
-            <a:pPr>
-              <a:spcAft>
-                <a:spcPts val="800"/>
-              </a:spcAft>
-              <a:defRPr sz="1200">
-                <a:solidFill>
-                  <a:srgbClr val="F5F0E8"/>
-                </a:solidFill>
-              </a:defRPr>
-            </a:pPr>
-            <a:r>
-              <a:t>• Storage quota estimation (`navigator.storage.estimate`) prevents quota overflow.</a:t>
-            </a:r>
-          </a:p>
-        </p:txBody>
-      </p:sp>
-      <p:sp>
-        <p:nvSpPr>
-          <p:cNvPr id="6" name="Rounded Rectangle 5"/>
+              <a:t>100% Verification Pass Rate</a:t>
+            </a:r>
+          </a:p>
+          <a:p>
+            <a:pPr>
+              <a:defRPr sz="1100">
+                <a:solidFill>
+                  <a:srgbClr val="F5F0E8"/>
+                </a:solidFill>
+              </a:defRPr>
+            </a:pPr>
+            <a:r>
+              <a:t>✔ TC-01: PostgreSQL Cluster Initialization — </a:t>
+            </a:r>
+            <a:r>
+              <a:rPr b="1">
+                <a:solidFill>
+                  <a:srgbClr val="4ADE80"/>
+                </a:solidFill>
+              </a:rPr>
+              <a:t>PASS</a:t>
+            </a:r>
+          </a:p>
+          <a:p>
+            <a:pPr>
+              <a:defRPr sz="1100">
+                <a:solidFill>
+                  <a:srgbClr val="F5F0E8"/>
+                </a:solidFill>
+              </a:defRPr>
+            </a:pPr>
+            <a:r>
+              <a:t>✔ TC-02: Go Backend Auto-Migration (9 tables) — </a:t>
+            </a:r>
+            <a:r>
+              <a:rPr b="1">
+                <a:solidFill>
+                  <a:srgbClr val="4ADE80"/>
+                </a:solidFill>
+              </a:rPr>
+              <a:t>PASS</a:t>
+            </a:r>
+          </a:p>
+          <a:p>
+            <a:pPr>
+              <a:defRPr sz="1100">
+                <a:solidFill>
+                  <a:srgbClr val="F5F0E8"/>
+                </a:solidFill>
+              </a:defRPr>
+            </a:pPr>
+            <a:r>
+              <a:t>✔ TC-03: Catalog Seed (110 full-length tracks) — </a:t>
+            </a:r>
+            <a:r>
+              <a:rPr b="1">
+                <a:solidFill>
+                  <a:srgbClr val="4ADE80"/>
+                </a:solidFill>
+              </a:rPr>
+              <a:t>PASS</a:t>
+            </a:r>
+          </a:p>
+          <a:p>
+            <a:pPr>
+              <a:defRPr sz="1100">
+                <a:solidFill>
+                  <a:srgbClr val="F5F0E8"/>
+                </a:solidFill>
+              </a:defRPr>
+            </a:pPr>
+            <a:r>
+              <a:t>✔ TC-04: User Registration &amp; Bcrypt Hashing — </a:t>
+            </a:r>
+            <a:r>
+              <a:rPr b="1">
+                <a:solidFill>
+                  <a:srgbClr val="4ADE80"/>
+                </a:solidFill>
+              </a:rPr>
+              <a:t>PASS</a:t>
+            </a:r>
+          </a:p>
+          <a:p>
+            <a:pPr>
+              <a:defRPr sz="1100">
+                <a:solidFill>
+                  <a:srgbClr val="F5F0E8"/>
+                </a:solidFill>
+              </a:defRPr>
+            </a:pPr>
+            <a:r>
+              <a:t>✔ TC-05: JWT Session Cookie Authentication — </a:t>
+            </a:r>
+            <a:r>
+              <a:rPr b="1">
+                <a:solidFill>
+                  <a:srgbClr val="4ADE80"/>
+                </a:solidFill>
+              </a:rPr>
+              <a:t>PASS</a:t>
+            </a:r>
+          </a:p>
+          <a:p>
+            <a:pPr>
+              <a:defRPr sz="1100">
+                <a:solidFill>
+                  <a:srgbClr val="F5F0E8"/>
+                </a:solidFill>
+              </a:defRPr>
+            </a:pPr>
+            <a:r>
+              <a:t>✔ TC-06: Full Audio Range Seek &amp; Stream Redirect — </a:t>
+            </a:r>
+            <a:r>
+              <a:rPr b="1">
+                <a:solidFill>
+                  <a:srgbClr val="4ADE80"/>
+                </a:solidFill>
+              </a:rPr>
+              <a:t>PASS</a:t>
+            </a:r>
+          </a:p>
+          <a:p>
+            <a:pPr>
+              <a:defRPr sz="1100">
+                <a:solidFill>
+                  <a:srgbClr val="F5F0E8"/>
+                </a:solidFill>
+              </a:defRPr>
+            </a:pPr>
+            <a:r>
+              <a:t>✔ TC-07: Sound Canvas Spatial Coordinates Query — </a:t>
+            </a:r>
+            <a:r>
+              <a:rPr b="1">
+                <a:solidFill>
+                  <a:srgbClr val="4ADE80"/>
+                </a:solidFill>
+              </a:rPr>
+              <a:t>PASS</a:t>
+            </a:r>
+          </a:p>
+          <a:p>
+            <a:pPr>
+              <a:defRPr sz="1100">
+                <a:solidFill>
+                  <a:srgbClr val="F5F0E8"/>
+                </a:solidFill>
+              </a:defRPr>
+            </a:pPr>
+            <a:r>
+              <a:t>✔ TC-08: Anti-Algorithm Comfort Inversion — </a:t>
+            </a:r>
+            <a:r>
+              <a:rPr b="1">
+                <a:solidFill>
+                  <a:srgbClr val="4ADE80"/>
+                </a:solidFill>
+              </a:rPr>
+              <a:t>PASS</a:t>
+            </a:r>
+          </a:p>
+          <a:p>
+            <a:pPr>
+              <a:defRPr sz="1100">
+                <a:solidFill>
+                  <a:srgbClr val="F5F0E8"/>
+                </a:solidFill>
+              </a:defRPr>
+            </a:pPr>
+            <a:r>
+              <a:t>✔ TC-09: IndexedDB Offline Blob Cache — </a:t>
+            </a:r>
+            <a:r>
+              <a:rPr b="1">
+                <a:solidFill>
+                  <a:srgbClr val="4ADE80"/>
+                </a:solidFill>
+              </a:rPr>
+              <a:t>PASS</a:t>
+            </a:r>
+          </a:p>
+          <a:p>
+            <a:pPr>
+              <a:defRPr sz="1100">
+                <a:solidFill>
+                  <a:srgbClr val="F5F0E8"/>
+                </a:solidFill>
+              </a:defRPr>
+            </a:pPr>
+            <a:r>
+              <a:t>✔ TC-10: Frontend Production Build &amp; SSR Routing — </a:t>
+            </a:r>
+            <a:r>
+              <a:rPr b="1">
+                <a:solidFill>
+                  <a:srgbClr val="4ADE80"/>
+                </a:solidFill>
+              </a:rPr>
+              <a:t>PASS</a:t>
+            </a:r>
+          </a:p>
+        </p:txBody>
+      </p:sp>
+      <p:sp>
+        <p:nvSpPr>
+          <p:cNvPr id="7" name="Rounded Rectangle 6"/>
           <p:cNvSpPr/>
           <p:nvPr/>
         </p:nvSpPr>
@@ -3914,167 +4186,99 @@
               </a:defRPr>
             </a:pPr>
             <a:r>
-              <a:t>100% Verification Pass Rate</a:t>
-            </a:r>
-          </a:p>
-          <a:p>
-            <a:pPr>
-              <a:defRPr sz="1100">
-                <a:solidFill>
-                  <a:srgbClr val="F5F0E8"/>
-                </a:solidFill>
-              </a:defRPr>
-            </a:pPr>
-            <a:r>
-              <a:t>✔ TC-01: PostgreSQL Cluster Initialization — </a:t>
-            </a:r>
-            <a:r>
-              <a:rPr b="1">
-                <a:solidFill>
-                  <a:srgbClr val="4ADE80"/>
+              <a:t>Future Platform Expansion Roadmap</a:t>
+            </a:r>
+          </a:p>
+          <a:p>
+            <a:pPr>
+              <a:spcAft>
+                <a:spcPts val="600"/>
+              </a:spcAft>
+              <a:defRPr b="1" sz="1150">
+                <a:solidFill>
+                  <a:srgbClr val="FF796C"/>
+                </a:solidFill>
+              </a:defRPr>
+            </a:pPr>
+            <a:r>
+              <a:t>• Cross-Platform Mobile Apps (iOS &amp; Android): </a:t>
+            </a:r>
+            <a:r>
+              <a:rPr b="0">
+                <a:solidFill>
+                  <a:srgbClr val="F5F0E8"/>
                 </a:solidFill>
               </a:rPr>
-              <a:t>PASS</a:t>
-            </a:r>
-          </a:p>
-          <a:p>
-            <a:pPr>
-              <a:defRPr sz="1100">
-                <a:solidFill>
-                  <a:srgbClr val="F5F0E8"/>
-                </a:solidFill>
-              </a:defRPr>
-            </a:pPr>
-            <a:r>
-              <a:t>✔ TC-02: Go Backend Auto-Migration (9 tables) — </a:t>
-            </a:r>
-            <a:r>
-              <a:rPr b="1">
-                <a:solidFill>
-                  <a:srgbClr val="4ADE80"/>
+              <a:t>Native builds using Capacitor / Flutter bringing Sound Canvas and offline sync to smartphones.</a:t>
+            </a:r>
+          </a:p>
+          <a:p>
+            <a:pPr>
+              <a:spcAft>
+                <a:spcPts val="600"/>
+              </a:spcAft>
+              <a:defRPr b="1" sz="1150">
+                <a:solidFill>
+                  <a:srgbClr val="FF796C"/>
+                </a:solidFill>
+              </a:defRPr>
+            </a:pPr>
+            <a:r>
+              <a:t>• Native Windows Desktop Executable (.exe): </a:t>
+            </a:r>
+            <a:r>
+              <a:rPr b="0">
+                <a:solidFill>
+                  <a:srgbClr val="F5F0E8"/>
                 </a:solidFill>
               </a:rPr>
-              <a:t>PASS</a:t>
-            </a:r>
-          </a:p>
-          <a:p>
-            <a:pPr>
-              <a:defRPr sz="1100">
-                <a:solidFill>
-                  <a:srgbClr val="F5F0E8"/>
-                </a:solidFill>
-              </a:defRPr>
-            </a:pPr>
-            <a:r>
-              <a:t>✔ TC-03: Catalog Seed (18 multi-quadrant songs) — </a:t>
-            </a:r>
-            <a:r>
-              <a:rPr b="1">
-                <a:solidFill>
-                  <a:srgbClr val="4ADE80"/>
+              <a:t>Packaged desktop client with low-latency audio driver, global media hotkeys, and system tray minimization.</a:t>
+            </a:r>
+          </a:p>
+          <a:p>
+            <a:pPr>
+              <a:spcAft>
+                <a:spcPts val="600"/>
+              </a:spcAft>
+              <a:defRPr b="1" sz="1150">
+                <a:solidFill>
+                  <a:srgbClr val="FF796C"/>
+                </a:solidFill>
+              </a:defRPr>
+            </a:pPr>
+            <a:r>
+              <a:t>• Cloud Edge Deployment: </a:t>
+            </a:r>
+            <a:r>
+              <a:rPr b="0">
+                <a:solidFill>
+                  <a:srgbClr val="F5F0E8"/>
                 </a:solidFill>
               </a:rPr>
-              <a:t>PASS</a:t>
-            </a:r>
-          </a:p>
-          <a:p>
-            <a:pPr>
-              <a:defRPr sz="1100">
-                <a:solidFill>
-                  <a:srgbClr val="F5F0E8"/>
-                </a:solidFill>
-              </a:defRPr>
-            </a:pPr>
-            <a:r>
-              <a:t>✔ TC-04: User Registration &amp; Bcrypt Hashing — </a:t>
-            </a:r>
-            <a:r>
-              <a:rPr b="1">
-                <a:solidFill>
-                  <a:srgbClr val="4ADE80"/>
+              <a:t>Serverless edge frontend on Vercel, containerized Go API on Render/Fly.io, and serverless Postgres on Neon.</a:t>
+            </a:r>
+          </a:p>
+          <a:p>
+            <a:pPr>
+              <a:spcAft>
+                <a:spcPts val="600"/>
+              </a:spcAft>
+              <a:defRPr b="1" sz="1150">
+                <a:solidFill>
+                  <a:srgbClr val="FF796C"/>
+                </a:solidFill>
+              </a:defRPr>
+            </a:pPr>
+            <a:r>
+              <a:t>• WebAssembly DSP Audio Visualizer: </a:t>
+            </a:r>
+            <a:r>
+              <a:rPr b="0">
+                <a:solidFill>
+                  <a:srgbClr val="F5F0E8"/>
                 </a:solidFill>
               </a:rPr>
-              <a:t>PASS</a:t>
-            </a:r>
-          </a:p>
-          <a:p>
-            <a:pPr>
-              <a:defRPr sz="1100">
-                <a:solidFill>
-                  <a:srgbClr val="F5F0E8"/>
-                </a:solidFill>
-              </a:defRPr>
-            </a:pPr>
-            <a:r>
-              <a:t>✔ TC-05: JWT Session Cookie Authentication — </a:t>
-            </a:r>
-            <a:r>
-              <a:rPr b="1">
-                <a:solidFill>
-                  <a:srgbClr val="4ADE80"/>
-                </a:solidFill>
-              </a:rPr>
-              <a:t>PASS</a:t>
-            </a:r>
-          </a:p>
-          <a:p>
-            <a:pPr>
-              <a:defRPr sz="1100">
-                <a:solidFill>
-                  <a:srgbClr val="F5F0E8"/>
-                </a:solidFill>
-              </a:defRPr>
-            </a:pPr>
-            <a:r>
-              <a:t>✔ TC-06: Sound Canvas Spatial Coordinates Query — </a:t>
-            </a:r>
-            <a:r>
-              <a:rPr b="1">
-                <a:solidFill>
-                  <a:srgbClr val="4ADE80"/>
-                </a:solidFill>
-              </a:rPr>
-              <a:t>PASS</a:t>
-            </a:r>
-          </a:p>
-          <a:p>
-            <a:pPr>
-              <a:defRPr sz="1100">
-                <a:solidFill>
-                  <a:srgbClr val="F5F0E8"/>
-                </a:solidFill>
-              </a:defRPr>
-            </a:pPr>
-            <a:r>
-              <a:t>✔ TC-07: Anti-Algorithm Comfort Inversion — </a:t>
-            </a:r>
-            <a:r>
-              <a:rPr b="1">
-                <a:solidFill>
-                  <a:srgbClr val="4ADE80"/>
-                </a:solidFill>
-              </a:rPr>
-              <a:t>PASS</a:t>
-            </a:r>
-          </a:p>
-          <a:p>
-            <a:pPr>
-              <a:defRPr sz="1100">
-                <a:solidFill>
-                  <a:srgbClr val="F5F0E8"/>
-                </a:solidFill>
-              </a:defRPr>
-            </a:pPr>
-            <a:r>
-              <a:t>✔ TC-08: Frontend Production Build &amp; SSR Routing — </a:t>
-            </a:r>
-            <a:r>
-              <a:rPr b="1">
-                <a:solidFill>
-                  <a:srgbClr val="4ADE80"/>
-                </a:solidFill>
-              </a:rPr>
-              <a:t>PASS</a:t>
+              <a:t>In-browser Fast Fourier Transform (FFT) for direct audio frequency spectrum analysis and reactive waveforms.</a:t>
             </a:r>
           </a:p>
         </p:txBody>
@@ -4142,84 +4346,14 @@
       </p:sp>
       <p:sp>
         <p:nvSpPr>
-          <p:cNvPr id="3" name="TextBox 2"/>
-          <p:cNvSpPr txBox="1"/>
-          <p:nvPr/>
-        </p:nvSpPr>
-        <p:spPr>
-          <a:xfrm>
-            <a:off x="731520" y="457200"/>
-            <a:ext cx="9144000" cy="365760"/>
-          </a:xfrm>
-          <a:prstGeom prst="rect">
-            <a:avLst/>
-          </a:prstGeom>
-          <a:noFill/>
-        </p:spPr>
-        <p:txBody>
-          <a:bodyPr wrap="square">
-            <a:spAutoFit/>
-          </a:bodyPr>
-          <a:lstStyle/>
-          <a:p>
-            <a:pPr>
-              <a:defRPr sz="1100" b="1">
-                <a:solidFill>
-                  <a:srgbClr val="B19AFF"/>
-                </a:solidFill>
-              </a:defRPr>
-            </a:pPr>
-            <a:r>
-              <a:t>DIVERGE INTERNSHIP CAPSTONE</a:t>
-            </a:r>
-          </a:p>
-        </p:txBody>
-      </p:sp>
-      <p:sp>
-        <p:nvSpPr>
-          <p:cNvPr id="4" name="TextBox 3"/>
-          <p:cNvSpPr txBox="1"/>
-          <p:nvPr/>
-        </p:nvSpPr>
-        <p:spPr>
-          <a:xfrm>
-            <a:off x="731520" y="777240"/>
-            <a:ext cx="10058400" cy="731520"/>
-          </a:xfrm>
-          <a:prstGeom prst="rect">
-            <a:avLst/>
-          </a:prstGeom>
-          <a:noFill/>
-        </p:spPr>
-        <p:txBody>
-          <a:bodyPr wrap="square">
-            <a:spAutoFit/>
-          </a:bodyPr>
-          <a:lstStyle/>
-          <a:p>
-            <a:pPr>
-              <a:defRPr sz="2800" b="1">
-                <a:solidFill>
-                  <a:srgbClr val="F5F0E8"/>
-                </a:solidFill>
-              </a:defRPr>
-            </a:pPr>
-            <a:r>
-              <a:t>Conclusion &amp; Project Submission Summary</a:t>
-            </a:r>
-          </a:p>
-        </p:txBody>
-      </p:sp>
-      <p:sp>
-        <p:nvSpPr>
-          <p:cNvPr id="5" name="Rounded Rectangle 4"/>
+          <p:cNvPr id="3" name="Rounded Rectangle 2"/>
           <p:cNvSpPr/>
           <p:nvPr/>
         </p:nvSpPr>
         <p:spPr>
           <a:xfrm>
-            <a:off x="731520" y="1645920"/>
-            <a:ext cx="10698480" cy="4389120"/>
+            <a:off x="1097280" y="914400"/>
+            <a:ext cx="9997135" cy="5029200"/>
           </a:xfrm>
           <a:prstGeom prst="roundRect">
             <a:avLst/>
@@ -4248,36 +4382,146 @@
           </a:fontRef>
         </p:style>
         <p:txBody>
-          <a:bodyPr rtlCol="0" anchor="ctr" wrap="square"/>
-          <a:lstStyle/>
-          <a:p>
-            <a:pPr algn="ctr">
+          <a:bodyPr rtlCol="0" anchor="ctr"/>
+          <a:lstStyle/>
+          <a:p>
+            <a:pPr algn="ctr"/>
+          </a:p>
+        </p:txBody>
+      </p:sp>
+      <p:pic>
+        <p:nvPicPr>
+          <p:cNvPr id="4" name="Picture 3" descr="logo.png"/>
+          <p:cNvPicPr>
+            <a:picLocks noChangeAspect="1"/>
+          </p:cNvPicPr>
+          <p:nvPr/>
+        </p:nvPicPr>
+        <p:blipFill>
+          <a:blip r:embed="rId2"/>
+          <a:stretch>
+            <a:fillRect/>
+          </a:stretch>
+        </p:blipFill>
+        <p:spPr>
+          <a:xfrm>
+            <a:off x="1645920" y="1554480"/>
+            <a:ext cx="3108960" cy="3200400"/>
+          </a:xfrm>
+          <a:prstGeom prst="rect">
+            <a:avLst/>
+          </a:prstGeom>
+        </p:spPr>
+      </p:pic>
+      <p:sp>
+        <p:nvSpPr>
+          <p:cNvPr id="5" name="TextBox 4"/>
+          <p:cNvSpPr txBox="1"/>
+          <p:nvPr/>
+        </p:nvSpPr>
+        <p:spPr>
+          <a:xfrm>
+            <a:off x="5120640" y="1188720"/>
+            <a:ext cx="5669280" cy="4480560"/>
+          </a:xfrm>
+          <a:prstGeom prst="rect">
+            <a:avLst/>
+          </a:prstGeom>
+          <a:noFill/>
+        </p:spPr>
+        <p:txBody>
+          <a:bodyPr wrap="square">
+            <a:spAutoFit/>
+          </a:bodyPr>
+          <a:lstStyle/>
+          <a:p>
+            <a:pPr>
+              <a:spcAft>
+                <a:spcPts val="400"/>
+              </a:spcAft>
+              <a:defRPr sz="4400" b="1">
+                <a:solidFill>
+                  <a:srgbClr val="F5F0E8"/>
+                </a:solidFill>
+              </a:defRPr>
+            </a:pPr>
+            <a:r>
+              <a:t>Thank You</a:t>
+            </a:r>
+          </a:p>
+          <a:p>
+            <a:pPr>
               <a:spcAft>
                 <a:spcPts val="1400"/>
               </a:spcAft>
-              <a:defRPr b="1" sz="2000">
+              <a:defRPr sz="1600" b="1">
+                <a:solidFill>
+                  <a:srgbClr val="FF796C"/>
+                </a:solidFill>
+              </a:defRPr>
+            </a:pPr>
+            <a:r>
+              <a:t>DIVERGE - Take the uncommon route.</a:t>
+            </a:r>
+          </a:p>
+          <a:p>
+            <a:pPr>
+              <a:spcAft>
+                <a:spcPts val="200"/>
+              </a:spcAft>
+              <a:defRPr sz="2000" b="1">
                 <a:solidFill>
                   <a:srgbClr val="B19AFF"/>
                 </a:solidFill>
               </a:defRPr>
             </a:pPr>
             <a:r>
-              <a:t>Internship Deliverables Complete</a:t>
-            </a:r>
-          </a:p>
-          <a:p>
-            <a:pPr>
-              <a:spcAft>
-                <a:spcPts val="800"/>
-              </a:spcAft>
-              <a:defRPr b="1" sz="1300">
+              <a:t>Dharshan V</a:t>
+            </a:r>
+          </a:p>
+          <a:p>
+            <a:pPr>
+              <a:spcAft>
+                <a:spcPts val="400"/>
+              </a:spcAft>
+              <a:defRPr sz="1200">
+                <a:solidFill>
+                  <a:srgbClr val="F5F0E8"/>
+                </a:solidFill>
+              </a:defRPr>
+            </a:pPr>
+            <a:r>
+              <a:t>Software Developer | Full-Stack Web Development Track</a:t>
+            </a:r>
+          </a:p>
+          <a:p>
+            <a:pPr>
+              <a:spcAft>
+                <a:spcPts val="1600"/>
+              </a:spcAft>
+              <a:defRPr sz="1200">
+                <a:solidFill>
+                  <a:srgbClr val="AAA4BB"/>
+                </a:solidFill>
+              </a:defRPr>
+            </a:pPr>
+            <a:r>
+              <a:t>Tech Vedhu Internship Project Submission</a:t>
+            </a:r>
+          </a:p>
+          <a:p>
+            <a:pPr>
+              <a:spcAft>
+                <a:spcPts val="300"/>
+              </a:spcAft>
+              <a:defRPr b="1" sz="1100">
                 <a:solidFill>
                   <a:srgbClr val="FF796C"/>
                 </a:solidFill>
               </a:defRPr>
             </a:pPr>
             <a:r>
-              <a:t>• Deliverable 1: Source Code Repository: </a:t>
+              <a:t>Phone: </a:t>
             </a:r>
             <a:r>
               <a:rPr b="0">
@@ -4285,22 +4529,22 @@
                   <a:srgbClr val="F5F0E8"/>
                 </a:solidFill>
               </a:rPr>
-              <a:t>Complete Go backend (Fiber, GORM, JWT), complete SvelteKit frontend (TypeScript, custom CSS tokens), PostgreSQL schema, seeder CLI, and README.md.</a:t>
-            </a:r>
-          </a:p>
-          <a:p>
-            <a:pPr>
-              <a:spcAft>
-                <a:spcPts val="800"/>
-              </a:spcAft>
-              <a:defRPr b="1" sz="1300">
+              <a:t>+91 6382546285</a:t>
+            </a:r>
+          </a:p>
+          <a:p>
+            <a:pPr>
+              <a:spcAft>
+                <a:spcPts val="300"/>
+              </a:spcAft>
+              <a:defRPr b="1" sz="1100">
                 <a:solidFill>
                   <a:srgbClr val="FF796C"/>
                 </a:solidFill>
               </a:defRPr>
             </a:pPr>
             <a:r>
-              <a:t>• Deliverable 2: Technical Project Report (PDF): </a:t>
+              <a:t>Email: </a:t>
             </a:r>
             <a:r>
               <a:rPr b="0">
@@ -4308,22 +4552,22 @@
                   <a:srgbClr val="F5F0E8"/>
                 </a:solidFill>
               </a:rPr>
-              <a:t>16-chapter comprehensive documentation adhering to university/internship guidelines at `j:/DIVERGE/docs/project-report.pdf`.</a:t>
-            </a:r>
-          </a:p>
-          <a:p>
-            <a:pPr>
-              <a:spcAft>
-                <a:spcPts val="800"/>
-              </a:spcAft>
-              <a:defRPr b="1" sz="1300">
+              <a:t>dharshan.vreddy2819@gmail.com</a:t>
+            </a:r>
+          </a:p>
+          <a:p>
+            <a:pPr>
+              <a:spcAft>
+                <a:spcPts val="300"/>
+              </a:spcAft>
+              <a:defRPr b="1" sz="1100">
                 <a:solidFill>
                   <a:srgbClr val="FF796C"/>
                 </a:solidFill>
               </a:defRPr>
             </a:pPr>
             <a:r>
-              <a:t>• Deliverable 3: Presentation Deck (PPTX): </a:t>
+              <a:t>Portfolio: </a:t>
             </a:r>
             <a:r>
               <a:rPr b="0">
@@ -4331,22 +4575,22 @@
                   <a:srgbClr val="F5F0E8"/>
                 </a:solidFill>
               </a:rPr>
-              <a:t>12-slide executive presentation covering architecture, features, and verification at `j:/DIVERGE/docs/presentation.pptx`.</a:t>
-            </a:r>
-          </a:p>
-          <a:p>
-            <a:pPr>
-              <a:spcAft>
-                <a:spcPts val="800"/>
-              </a:spcAft>
-              <a:defRPr b="1" sz="1300">
+              <a:t>https://dharshanvportfolio.netlify.app/</a:t>
+            </a:r>
+          </a:p>
+          <a:p>
+            <a:pPr>
+              <a:spcAft>
+                <a:spcPts val="300"/>
+              </a:spcAft>
+              <a:defRPr b="1" sz="1100">
                 <a:solidFill>
                   <a:srgbClr val="FF796C"/>
                 </a:solidFill>
               </a:defRPr>
             </a:pPr>
             <a:r>
-              <a:t>• Deployment &amp; Verification: </a:t>
+              <a:t>GitHub: </a:t>
             </a:r>
             <a:r>
               <a:rPr b="0">
@@ -4354,7 +4598,53 @@
                   <a:srgbClr val="F5F0E8"/>
                 </a:solidFill>
               </a:rPr>
-              <a:t>Full local execution verified with PostgreSQL 16 on port 5432, Go API on port 8080, and SvelteKit frontend on port 5173.</a:t>
+              <a:t>https://github.com/Dharsh606</a:t>
+            </a:r>
+          </a:p>
+          <a:p>
+            <a:pPr>
+              <a:spcAft>
+                <a:spcPts val="300"/>
+              </a:spcAft>
+              <a:defRPr b="1" sz="1100">
+                <a:solidFill>
+                  <a:srgbClr val="FF796C"/>
+                </a:solidFill>
+              </a:defRPr>
+            </a:pPr>
+            <a:r>
+              <a:t>Repository: </a:t>
+            </a:r>
+            <a:r>
+              <a:rPr b="0">
+                <a:solidFill>
+                  <a:srgbClr val="F5F0E8"/>
+                </a:solidFill>
+              </a:rPr>
+              <a:t>https://github.com/Dharsh606/DIVERGE</a:t>
+            </a:r>
+          </a:p>
+          <a:p>
+            <a:pPr>
+              <a:spcAft>
+                <a:spcPts val="300"/>
+              </a:spcAft>
+              <a:defRPr b="1" sz="1100">
+                <a:solidFill>
+                  <a:srgbClr val="FF796C"/>
+                </a:solidFill>
+              </a:defRPr>
+            </a:pPr>
+            <a:r>
+              <a:t>LinkedIn: </a:t>
+            </a:r>
+            <a:r>
+              <a:rPr b="0">
+                <a:solidFill>
+                  <a:srgbClr val="F5F0E8"/>
+                </a:solidFill>
+              </a:rPr>
+              <a:t>https://www.linkedin.com/in/dharshanvreddy</a:t>
             </a:r>
           </a:p>
         </p:txBody>
@@ -4420,16 +4710,40 @@
           </a:p>
         </p:txBody>
       </p:sp>
-      <p:sp>
-        <p:nvSpPr>
-          <p:cNvPr id="3" name="TextBox 2"/>
+      <p:pic>
+        <p:nvPicPr>
+          <p:cNvPr id="3" name="Picture 2" descr="logo-mark.png"/>
+          <p:cNvPicPr>
+            <a:picLocks noChangeAspect="1"/>
+          </p:cNvPicPr>
+          <p:nvPr/>
+        </p:nvPicPr>
+        <p:blipFill>
+          <a:blip r:embed="rId2"/>
+          <a:stretch>
+            <a:fillRect/>
+          </a:stretch>
+        </p:blipFill>
+        <p:spPr>
+          <a:xfrm>
+            <a:off x="10972800" y="365760"/>
+            <a:ext cx="594360" cy="594360"/>
+          </a:xfrm>
+          <a:prstGeom prst="rect">
+            <a:avLst/>
+          </a:prstGeom>
+        </p:spPr>
+      </p:pic>
+      <p:sp>
+        <p:nvSpPr>
+          <p:cNvPr id="4" name="TextBox 3"/>
           <p:cNvSpPr txBox="1"/>
           <p:nvPr/>
         </p:nvSpPr>
         <p:spPr>
           <a:xfrm>
-            <a:off x="731520" y="457200"/>
-            <a:ext cx="9144000" cy="365760"/>
+            <a:off x="731520" y="411480"/>
+            <a:ext cx="9144000" cy="320040"/>
           </a:xfrm>
           <a:prstGeom prst="rect">
             <a:avLst/>
@@ -4443,27 +4757,27 @@
           <a:lstStyle/>
           <a:p>
             <a:pPr>
-              <a:defRPr sz="1100" b="1">
+              <a:defRPr sz="1000" b="1">
                 <a:solidFill>
                   <a:srgbClr val="B19AFF"/>
                 </a:solidFill>
               </a:defRPr>
             </a:pPr>
             <a:r>
-              <a:t>DIVERGE INTERNSHIP CAPSTONE</a:t>
-            </a:r>
-          </a:p>
-        </p:txBody>
-      </p:sp>
-      <p:sp>
-        <p:nvSpPr>
-          <p:cNvPr id="4" name="TextBox 3"/>
+              <a:t>TECH VEDHU INTERNSHIP CAPSTONE</a:t>
+            </a:r>
+          </a:p>
+        </p:txBody>
+      </p:sp>
+      <p:sp>
+        <p:nvSpPr>
+          <p:cNvPr id="5" name="TextBox 4"/>
           <p:cNvSpPr txBox="1"/>
           <p:nvPr/>
         </p:nvSpPr>
         <p:spPr>
           <a:xfrm>
-            <a:off x="731520" y="777240"/>
+            <a:off x="731520" y="731520"/>
             <a:ext cx="10058400" cy="731520"/>
           </a:xfrm>
           <a:prstGeom prst="rect">
@@ -4478,7 +4792,7 @@
           <a:lstStyle/>
           <a:p>
             <a:pPr>
-              <a:defRPr sz="2800" b="1">
+              <a:defRPr sz="2600" b="1">
                 <a:solidFill>
                   <a:srgbClr val="F5F0E8"/>
                 </a:solidFill>
@@ -4492,14 +4806,14 @@
       </p:sp>
       <p:sp>
         <p:nvSpPr>
-          <p:cNvPr id="5" name="Rounded Rectangle 4"/>
+          <p:cNvPr id="6" name="Rounded Rectangle 5"/>
           <p:cNvSpPr/>
           <p:nvPr/>
         </p:nvSpPr>
         <p:spPr>
           <a:xfrm>
             <a:off x="731520" y="1645920"/>
-            <a:ext cx="5120640" cy="4389120"/>
+            <a:ext cx="5120640" cy="4572000"/>
           </a:xfrm>
           <a:prstGeom prst="roundRect">
             <a:avLst/>
@@ -4550,7 +4864,7 @@
               <a:spcAft>
                 <a:spcPts val="1000"/>
               </a:spcAft>
-              <a:defRPr sz="1300">
+              <a:defRPr sz="1250">
                 <a:solidFill>
                   <a:srgbClr val="F5F0E8"/>
                 </a:solidFill>
@@ -4565,14 +4879,14 @@
               <a:spcAft>
                 <a:spcPts val="1000"/>
               </a:spcAft>
-              <a:defRPr sz="1300">
-                <a:solidFill>
-                  <a:srgbClr val="F5F0E8"/>
-                </a:solidFill>
-              </a:defRPr>
-            </a:pPr>
-            <a:r>
-              <a:t>• Engineered with Go (Fiber) backend and SvelteKit frontend.</a:t>
+              <a:defRPr sz="1250">
+                <a:solidFill>
+                  <a:srgbClr val="F5F0E8"/>
+                </a:solidFill>
+              </a:defRPr>
+            </a:pPr>
+            <a:r>
+              <a:t>• Engineered with Go (Fiber) backend and SvelteKit frontend for high throughput.</a:t>
             </a:r>
           </a:p>
           <a:p>
@@ -4580,7 +4894,7 @@
               <a:spcAft>
                 <a:spcPts val="1000"/>
               </a:spcAft>
-              <a:defRPr sz="1300">
+              <a:defRPr sz="1250">
                 <a:solidFill>
                   <a:srgbClr val="F5F0E8"/>
                 </a:solidFill>
@@ -4595,28 +4909,43 @@
               <a:spcAft>
                 <a:spcPts val="1000"/>
               </a:spcAft>
-              <a:defRPr sz="1300">
-                <a:solidFill>
-                  <a:srgbClr val="F5F0E8"/>
-                </a:solidFill>
-              </a:defRPr>
-            </a:pPr>
-            <a:r>
-              <a:t>• Strict anti-vibe product visual rules: No purple gradients, no pill buttons, no fake reviews.</a:t>
-            </a:r>
-          </a:p>
-        </p:txBody>
-      </p:sp>
-      <p:sp>
-        <p:nvSpPr>
-          <p:cNvPr id="6" name="Rounded Rectangle 5"/>
+              <a:defRPr sz="1250">
+                <a:solidFill>
+                  <a:srgbClr val="F5F0E8"/>
+                </a:solidFill>
+              </a:defRPr>
+            </a:pPr>
+            <a:r>
+              <a:t>• Full Song Audio Engine: Jamendo CDN &amp; local storage delivering complete 3-6 min songs.</a:t>
+            </a:r>
+          </a:p>
+          <a:p>
+            <a:pPr>
+              <a:spcAft>
+                <a:spcPts val="1000"/>
+              </a:spcAft>
+              <a:defRPr sz="1250">
+                <a:solidFill>
+                  <a:srgbClr val="F5F0E8"/>
+                </a:solidFill>
+              </a:defRPr>
+            </a:pPr>
+            <a:r>
+              <a:t>• Strict atmospheric visual rules: No purple gradients, no pill buttons, no fake reviews.</a:t>
+            </a:r>
+          </a:p>
+        </p:txBody>
+      </p:sp>
+      <p:sp>
+        <p:nvSpPr>
+          <p:cNvPr id="7" name="Rounded Rectangle 6"/>
           <p:cNvSpPr/>
           <p:nvPr/>
         </p:nvSpPr>
         <p:spPr>
           <a:xfrm>
             <a:off x="6309360" y="1645920"/>
-            <a:ext cx="5120640" cy="4389120"/>
+            <a:ext cx="5120640" cy="4572000"/>
           </a:xfrm>
           <a:prstGeom prst="roundRect">
             <a:avLst/>
@@ -4659,7 +4988,7 @@
               </a:defRPr>
             </a:pPr>
             <a:r>
-              <a:t>Key Deliverables</a:t>
+              <a:t>Engineering Highlights</a:t>
             </a:r>
           </a:p>
           <a:p>
@@ -4667,14 +4996,14 @@
               <a:spcAft>
                 <a:spcPts val="1000"/>
               </a:spcAft>
-              <a:defRPr sz="1300">
-                <a:solidFill>
-                  <a:srgbClr val="F5F0E8"/>
-                </a:solidFill>
-              </a:defRPr>
-            </a:pPr>
-            <a:r>
-              <a:t>• Deliverable 1: Complete Go backend + SvelteKit frontend source code.</a:t>
+              <a:defRPr sz="1250">
+                <a:solidFill>
+                  <a:srgbClr val="F5F0E8"/>
+                </a:solidFill>
+              </a:defRPr>
+            </a:pPr>
+            <a:r>
+              <a:t>• Sub-10ms API response times with Go Fiber zero-allocation routing.</a:t>
             </a:r>
           </a:p>
           <a:p>
@@ -4682,14 +5011,14 @@
               <a:spcAft>
                 <a:spcPts val="1000"/>
               </a:spcAft>
-              <a:defRPr sz="1300">
-                <a:solidFill>
-                  <a:srgbClr val="F5F0E8"/>
-                </a:solidFill>
-              </a:defRPr>
-            </a:pPr>
-            <a:r>
-              <a:t>• Deliverable 2: Professional 16-chapter PDF technical project report.</a:t>
+              <a:defRPr sz="1250">
+                <a:solidFill>
+                  <a:srgbClr val="F5F0E8"/>
+                </a:solidFill>
+              </a:defRPr>
+            </a:pPr>
+            <a:r>
+              <a:t>• HTTP 206 Partial Content Range streaming enables instant timeline scrubbing.</a:t>
             </a:r>
           </a:p>
           <a:p>
@@ -4697,14 +5026,14 @@
               <a:spcAft>
                 <a:spcPts val="1000"/>
               </a:spcAft>
-              <a:defRPr sz="1300">
-                <a:solidFill>
-                  <a:srgbClr val="F5F0E8"/>
-                </a:solidFill>
-              </a:defRPr>
-            </a:pPr>
-            <a:r>
-              <a:t>• Deliverable 3: 12-slide comprehensive presentation deck.</a:t>
+              <a:defRPr sz="1250">
+                <a:solidFill>
+                  <a:srgbClr val="F5F0E8"/>
+                </a:solidFill>
+              </a:defRPr>
+            </a:pPr>
+            <a:r>
+              <a:t>• 110 full-length songs seeded across 4 quadrants with deterministic Track DNA glyphs.</a:t>
             </a:r>
           </a:p>
           <a:p>
@@ -4712,14 +5041,29 @@
               <a:spcAft>
                 <a:spcPts val="1000"/>
               </a:spcAft>
-              <a:defRPr sz="1300">
-                <a:solidFill>
-                  <a:srgbClr val="F5F0E8"/>
-                </a:solidFill>
-              </a:defRPr>
-            </a:pPr>
-            <a:r>
-              <a:t>• Full local deployment with PostgreSQL 16 and Creative Commons audio streaming.</a:t>
+              <a:defRPr sz="1250">
+                <a:solidFill>
+                  <a:srgbClr val="F5F0E8"/>
+                </a:solidFill>
+              </a:defRPr>
+            </a:pPr>
+            <a:r>
+              <a:t>• IndexedDB + Service Worker offline storage for persistent offline playback.</a:t>
+            </a:r>
+          </a:p>
+          <a:p>
+            <a:pPr>
+              <a:spcAft>
+                <a:spcPts val="1000"/>
+              </a:spcAft>
+              <a:defRPr sz="1250">
+                <a:solidFill>
+                  <a:srgbClr val="F5F0E8"/>
+                </a:solidFill>
+              </a:defRPr>
+            </a:pPr>
+            <a:r>
+              <a:t>• Synchronized multi-user Diverge Sessions with live room code sharing.</a:t>
             </a:r>
           </a:p>
         </p:txBody>
@@ -4785,16 +5129,40 @@
           </a:p>
         </p:txBody>
       </p:sp>
-      <p:sp>
-        <p:nvSpPr>
-          <p:cNvPr id="3" name="TextBox 2"/>
+      <p:pic>
+        <p:nvPicPr>
+          <p:cNvPr id="3" name="Picture 2" descr="logo-mark.png"/>
+          <p:cNvPicPr>
+            <a:picLocks noChangeAspect="1"/>
+          </p:cNvPicPr>
+          <p:nvPr/>
+        </p:nvPicPr>
+        <p:blipFill>
+          <a:blip r:embed="rId2"/>
+          <a:stretch>
+            <a:fillRect/>
+          </a:stretch>
+        </p:blipFill>
+        <p:spPr>
+          <a:xfrm>
+            <a:off x="10972800" y="365760"/>
+            <a:ext cx="594360" cy="594360"/>
+          </a:xfrm>
+          <a:prstGeom prst="rect">
+            <a:avLst/>
+          </a:prstGeom>
+        </p:spPr>
+      </p:pic>
+      <p:sp>
+        <p:nvSpPr>
+          <p:cNvPr id="4" name="TextBox 3"/>
           <p:cNvSpPr txBox="1"/>
           <p:nvPr/>
         </p:nvSpPr>
         <p:spPr>
           <a:xfrm>
-            <a:off x="731520" y="457200"/>
-            <a:ext cx="9144000" cy="365760"/>
+            <a:off x="731520" y="411480"/>
+            <a:ext cx="9144000" cy="320040"/>
           </a:xfrm>
           <a:prstGeom prst="rect">
             <a:avLst/>
@@ -4808,27 +5176,27 @@
           <a:lstStyle/>
           <a:p>
             <a:pPr>
-              <a:defRPr sz="1100" b="1">
+              <a:defRPr sz="1000" b="1">
                 <a:solidFill>
                   <a:srgbClr val="B19AFF"/>
                 </a:solidFill>
               </a:defRPr>
             </a:pPr>
             <a:r>
-              <a:t>DIVERGE INTERNSHIP CAPSTONE</a:t>
-            </a:r>
-          </a:p>
-        </p:txBody>
-      </p:sp>
-      <p:sp>
-        <p:nvSpPr>
-          <p:cNvPr id="4" name="TextBox 3"/>
+              <a:t>TECH VEDHU INTERNSHIP CAPSTONE</a:t>
+            </a:r>
+          </a:p>
+        </p:txBody>
+      </p:sp>
+      <p:sp>
+        <p:nvSpPr>
+          <p:cNvPr id="5" name="TextBox 4"/>
           <p:cNvSpPr txBox="1"/>
           <p:nvPr/>
         </p:nvSpPr>
         <p:spPr>
           <a:xfrm>
-            <a:off x="731520" y="777240"/>
+            <a:off x="731520" y="731520"/>
             <a:ext cx="10058400" cy="731520"/>
           </a:xfrm>
           <a:prstGeom prst="rect">
@@ -4843,7 +5211,7 @@
           <a:lstStyle/>
           <a:p>
             <a:pPr>
-              <a:defRPr sz="2800" b="1">
+              <a:defRPr sz="2600" b="1">
                 <a:solidFill>
                   <a:srgbClr val="F5F0E8"/>
                 </a:solidFill>
@@ -4857,14 +5225,14 @@
       </p:sp>
       <p:sp>
         <p:nvSpPr>
-          <p:cNvPr id="5" name="Rounded Rectangle 4"/>
+          <p:cNvPr id="6" name="Rounded Rectangle 5"/>
           <p:cNvSpPr/>
           <p:nvPr/>
         </p:nvSpPr>
         <p:spPr>
           <a:xfrm>
             <a:off x="731520" y="1828800"/>
-            <a:ext cx="3291840" cy="4114800"/>
+            <a:ext cx="3291840" cy="4297680"/>
           </a:xfrm>
           <a:prstGeom prst="roundRect">
             <a:avLst/>
@@ -4926,14 +5294,14 @@
       </p:sp>
       <p:sp>
         <p:nvSpPr>
-          <p:cNvPr id="6" name="Rounded Rectangle 5"/>
+          <p:cNvPr id="7" name="Rounded Rectangle 6"/>
           <p:cNvSpPr/>
           <p:nvPr/>
         </p:nvSpPr>
         <p:spPr>
           <a:xfrm>
             <a:off x="4297680" y="1828800"/>
-            <a:ext cx="3291840" cy="4114800"/>
+            <a:ext cx="3291840" cy="4297680"/>
           </a:xfrm>
           <a:prstGeom prst="roundRect">
             <a:avLst/>
@@ -4995,14 +5363,14 @@
       </p:sp>
       <p:sp>
         <p:nvSpPr>
-          <p:cNvPr id="7" name="Rounded Rectangle 6"/>
+          <p:cNvPr id="8" name="Rounded Rectangle 7"/>
           <p:cNvSpPr/>
           <p:nvPr/>
         </p:nvSpPr>
         <p:spPr>
           <a:xfrm>
             <a:off x="7863840" y="1828800"/>
-            <a:ext cx="3291840" cy="4114800"/>
+            <a:ext cx="3291840" cy="4297680"/>
           </a:xfrm>
           <a:prstGeom prst="roundRect">
             <a:avLst/>
@@ -5123,16 +5491,40 @@
           </a:p>
         </p:txBody>
       </p:sp>
-      <p:sp>
-        <p:nvSpPr>
-          <p:cNvPr id="3" name="TextBox 2"/>
+      <p:pic>
+        <p:nvPicPr>
+          <p:cNvPr id="3" name="Picture 2" descr="logo-mark.png"/>
+          <p:cNvPicPr>
+            <a:picLocks noChangeAspect="1"/>
+          </p:cNvPicPr>
+          <p:nvPr/>
+        </p:nvPicPr>
+        <p:blipFill>
+          <a:blip r:embed="rId2"/>
+          <a:stretch>
+            <a:fillRect/>
+          </a:stretch>
+        </p:blipFill>
+        <p:spPr>
+          <a:xfrm>
+            <a:off x="10972800" y="365760"/>
+            <a:ext cx="594360" cy="594360"/>
+          </a:xfrm>
+          <a:prstGeom prst="rect">
+            <a:avLst/>
+          </a:prstGeom>
+        </p:spPr>
+      </p:pic>
+      <p:sp>
+        <p:nvSpPr>
+          <p:cNvPr id="4" name="TextBox 3"/>
           <p:cNvSpPr txBox="1"/>
           <p:nvPr/>
         </p:nvSpPr>
         <p:spPr>
           <a:xfrm>
-            <a:off x="731520" y="457200"/>
-            <a:ext cx="9144000" cy="365760"/>
+            <a:off x="731520" y="411480"/>
+            <a:ext cx="9144000" cy="320040"/>
           </a:xfrm>
           <a:prstGeom prst="rect">
             <a:avLst/>
@@ -5146,27 +5538,27 @@
           <a:lstStyle/>
           <a:p>
             <a:pPr>
-              <a:defRPr sz="1100" b="1">
+              <a:defRPr sz="1000" b="1">
                 <a:solidFill>
                   <a:srgbClr val="B19AFF"/>
                 </a:solidFill>
               </a:defRPr>
             </a:pPr>
             <a:r>
-              <a:t>DIVERGE INTERNSHIP CAPSTONE</a:t>
-            </a:r>
-          </a:p>
-        </p:txBody>
-      </p:sp>
-      <p:sp>
-        <p:nvSpPr>
-          <p:cNvPr id="4" name="TextBox 3"/>
+              <a:t>TECH VEDHU INTERNSHIP CAPSTONE</a:t>
+            </a:r>
+          </a:p>
+        </p:txBody>
+      </p:sp>
+      <p:sp>
+        <p:nvSpPr>
+          <p:cNvPr id="5" name="TextBox 4"/>
           <p:cNvSpPr txBox="1"/>
           <p:nvPr/>
         </p:nvSpPr>
         <p:spPr>
           <a:xfrm>
-            <a:off x="731520" y="777240"/>
+            <a:off x="731520" y="731520"/>
             <a:ext cx="10058400" cy="731520"/>
           </a:xfrm>
           <a:prstGeom prst="rect">
@@ -5181,7 +5573,7 @@
           <a:lstStyle/>
           <a:p>
             <a:pPr>
-              <a:defRPr sz="2800" b="1">
+              <a:defRPr sz="2600" b="1">
                 <a:solidFill>
                   <a:srgbClr val="F5F0E8"/>
                 </a:solidFill>
@@ -5195,7 +5587,7 @@
       </p:sp>
       <p:sp>
         <p:nvSpPr>
-          <p:cNvPr id="5" name="Rounded Rectangle 4"/>
+          <p:cNvPr id="6" name="Rounded Rectangle 5"/>
           <p:cNvSpPr/>
           <p:nvPr/>
         </p:nvSpPr>
@@ -5248,14 +5640,14 @@
                   <a:srgbClr val="F5F0E8"/>
                 </a:solidFill>
               </a:rPr>
-              <a:t>Browse songs, persistent player, HTTP Range requests, volume control, and shuffle/repeat modes.</a:t>
-            </a:r>
-          </a:p>
-        </p:txBody>
-      </p:sp>
-      <p:sp>
-        <p:nvSpPr>
-          <p:cNvPr id="6" name="Rounded Rectangle 5"/>
+              <a:t>Browse 110 full-length tracks, persistent player, HTTP Range requests, volume control, and shuffle/repeat modes.</a:t>
+            </a:r>
+          </a:p>
+        </p:txBody>
+      </p:sp>
+      <p:sp>
+        <p:nvSpPr>
+          <p:cNvPr id="7" name="Rounded Rectangle 6"/>
           <p:cNvSpPr/>
           <p:nvPr/>
         </p:nvSpPr>
@@ -5315,7 +5707,7 @@
       </p:sp>
       <p:sp>
         <p:nvSpPr>
-          <p:cNvPr id="7" name="Rounded Rectangle 6"/>
+          <p:cNvPr id="8" name="Rounded Rectangle 7"/>
           <p:cNvSpPr/>
           <p:nvPr/>
         </p:nvSpPr>
@@ -5368,14 +5760,14 @@
                   <a:srgbClr val="F5F0E8"/>
                 </a:solidFill>
               </a:rPr>
-              <a:t>Cache permitted audio files in browser IndexedDB with a dedicated Service Worker.</a:t>
-            </a:r>
-          </a:p>
-        </p:txBody>
-      </p:sp>
-      <p:sp>
-        <p:nvSpPr>
-          <p:cNvPr id="8" name="Rounded Rectangle 7"/>
+              <a:t>Cache audio streams in browser IndexedDB with a dedicated Service Worker for zero-network playback.</a:t>
+            </a:r>
+          </a:p>
+        </p:txBody>
+      </p:sp>
+      <p:sp>
+        <p:nvSpPr>
+          <p:cNvPr id="9" name="Rounded Rectangle 8"/>
           <p:cNvSpPr/>
           <p:nvPr/>
         </p:nvSpPr>
@@ -5435,7 +5827,7 @@
       </p:sp>
       <p:sp>
         <p:nvSpPr>
-          <p:cNvPr id="9" name="Rounded Rectangle 8"/>
+          <p:cNvPr id="10" name="Rounded Rectangle 9"/>
           <p:cNvSpPr/>
           <p:nvPr/>
         </p:nvSpPr>
@@ -5554,16 +5946,40 @@
           </a:p>
         </p:txBody>
       </p:sp>
-      <p:sp>
-        <p:nvSpPr>
-          <p:cNvPr id="3" name="TextBox 2"/>
+      <p:pic>
+        <p:nvPicPr>
+          <p:cNvPr id="3" name="Picture 2" descr="logo-mark.png"/>
+          <p:cNvPicPr>
+            <a:picLocks noChangeAspect="1"/>
+          </p:cNvPicPr>
+          <p:nvPr/>
+        </p:nvPicPr>
+        <p:blipFill>
+          <a:blip r:embed="rId2"/>
+          <a:stretch>
+            <a:fillRect/>
+          </a:stretch>
+        </p:blipFill>
+        <p:spPr>
+          <a:xfrm>
+            <a:off x="10972800" y="365760"/>
+            <a:ext cx="594360" cy="594360"/>
+          </a:xfrm>
+          <a:prstGeom prst="rect">
+            <a:avLst/>
+          </a:prstGeom>
+        </p:spPr>
+      </p:pic>
+      <p:sp>
+        <p:nvSpPr>
+          <p:cNvPr id="4" name="TextBox 3"/>
           <p:cNvSpPr txBox="1"/>
           <p:nvPr/>
         </p:nvSpPr>
         <p:spPr>
           <a:xfrm>
-            <a:off x="731520" y="457200"/>
-            <a:ext cx="9144000" cy="365760"/>
+            <a:off x="731520" y="411480"/>
+            <a:ext cx="9144000" cy="320040"/>
           </a:xfrm>
           <a:prstGeom prst="rect">
             <a:avLst/>
@@ -5577,27 +5993,27 @@
           <a:lstStyle/>
           <a:p>
             <a:pPr>
-              <a:defRPr sz="1100" b="1">
+              <a:defRPr sz="1000" b="1">
                 <a:solidFill>
                   <a:srgbClr val="B19AFF"/>
                 </a:solidFill>
               </a:defRPr>
             </a:pPr>
             <a:r>
-              <a:t>DIVERGE INTERNSHIP CAPSTONE</a:t>
-            </a:r>
-          </a:p>
-        </p:txBody>
-      </p:sp>
-      <p:sp>
-        <p:nvSpPr>
-          <p:cNvPr id="4" name="TextBox 3"/>
+              <a:t>TECH VEDHU INTERNSHIP CAPSTONE</a:t>
+            </a:r>
+          </a:p>
+        </p:txBody>
+      </p:sp>
+      <p:sp>
+        <p:nvSpPr>
+          <p:cNvPr id="5" name="TextBox 4"/>
           <p:cNvSpPr txBox="1"/>
           <p:nvPr/>
         </p:nvSpPr>
         <p:spPr>
           <a:xfrm>
-            <a:off x="731520" y="777240"/>
+            <a:off x="731520" y="731520"/>
             <a:ext cx="10058400" cy="731520"/>
           </a:xfrm>
           <a:prstGeom prst="rect">
@@ -5612,7 +6028,7 @@
           <a:lstStyle/>
           <a:p>
             <a:pPr>
-              <a:defRPr sz="2800" b="1">
+              <a:defRPr sz="2600" b="1">
                 <a:solidFill>
                   <a:srgbClr val="F5F0E8"/>
                 </a:solidFill>
@@ -5626,14 +6042,14 @@
       </p:sp>
       <p:sp>
         <p:nvSpPr>
-          <p:cNvPr id="5" name="Rounded Rectangle 4"/>
+          <p:cNvPr id="6" name="Rounded Rectangle 5"/>
           <p:cNvSpPr/>
           <p:nvPr/>
         </p:nvSpPr>
         <p:spPr>
           <a:xfrm>
             <a:off x="731520" y="1828800"/>
-            <a:ext cx="2514600" cy="4114800"/>
+            <a:ext cx="2514600" cy="4297680"/>
           </a:xfrm>
           <a:prstGeom prst="roundRect">
             <a:avLst/>
@@ -5743,14 +6159,14 @@
       </p:sp>
       <p:sp>
         <p:nvSpPr>
-          <p:cNvPr id="6" name="Rounded Rectangle 5"/>
+          <p:cNvPr id="7" name="Rounded Rectangle 6"/>
           <p:cNvSpPr/>
           <p:nvPr/>
         </p:nvSpPr>
         <p:spPr>
           <a:xfrm>
             <a:off x="3429000" y="1828800"/>
-            <a:ext cx="2514600" cy="4114800"/>
+            <a:ext cx="2514600" cy="4297680"/>
           </a:xfrm>
           <a:prstGeom prst="roundRect">
             <a:avLst/>
@@ -5860,14 +6276,14 @@
       </p:sp>
       <p:sp>
         <p:nvSpPr>
-          <p:cNvPr id="7" name="Rounded Rectangle 6"/>
+          <p:cNvPr id="8" name="Rounded Rectangle 7"/>
           <p:cNvSpPr/>
           <p:nvPr/>
         </p:nvSpPr>
         <p:spPr>
           <a:xfrm>
             <a:off x="6126480" y="1828800"/>
-            <a:ext cx="2514600" cy="4114800"/>
+            <a:ext cx="2514600" cy="4297680"/>
           </a:xfrm>
           <a:prstGeom prst="roundRect">
             <a:avLst/>
@@ -5977,14 +6393,14 @@
       </p:sp>
       <p:sp>
         <p:nvSpPr>
-          <p:cNvPr id="8" name="Rounded Rectangle 7"/>
+          <p:cNvPr id="9" name="Rounded Rectangle 8"/>
           <p:cNvSpPr/>
           <p:nvPr/>
         </p:nvSpPr>
         <p:spPr>
           <a:xfrm>
             <a:off x="8823960" y="1828800"/>
-            <a:ext cx="2514600" cy="4114800"/>
+            <a:ext cx="2514600" cy="4297680"/>
           </a:xfrm>
           <a:prstGeom prst="roundRect">
             <a:avLst/>
@@ -6087,7 +6503,7 @@
               </a:defRPr>
             </a:pPr>
             <a:r>
-              <a:t>• Jamendo / CC Audio CDN</a:t>
+              <a:t>• Full Audio CDN Pool</a:t>
             </a:r>
           </a:p>
         </p:txBody>
@@ -6153,16 +6569,40 @@
           </a:p>
         </p:txBody>
       </p:sp>
-      <p:sp>
-        <p:nvSpPr>
-          <p:cNvPr id="3" name="TextBox 2"/>
+      <p:pic>
+        <p:nvPicPr>
+          <p:cNvPr id="3" name="Picture 2" descr="logo-mark.png"/>
+          <p:cNvPicPr>
+            <a:picLocks noChangeAspect="1"/>
+          </p:cNvPicPr>
+          <p:nvPr/>
+        </p:nvPicPr>
+        <p:blipFill>
+          <a:blip r:embed="rId2"/>
+          <a:stretch>
+            <a:fillRect/>
+          </a:stretch>
+        </p:blipFill>
+        <p:spPr>
+          <a:xfrm>
+            <a:off x="10972800" y="365760"/>
+            <a:ext cx="594360" cy="594360"/>
+          </a:xfrm>
+          <a:prstGeom prst="rect">
+            <a:avLst/>
+          </a:prstGeom>
+        </p:spPr>
+      </p:pic>
+      <p:sp>
+        <p:nvSpPr>
+          <p:cNvPr id="4" name="TextBox 3"/>
           <p:cNvSpPr txBox="1"/>
           <p:nvPr/>
         </p:nvSpPr>
         <p:spPr>
           <a:xfrm>
-            <a:off x="731520" y="457200"/>
-            <a:ext cx="9144000" cy="365760"/>
+            <a:off x="731520" y="411480"/>
+            <a:ext cx="9144000" cy="320040"/>
           </a:xfrm>
           <a:prstGeom prst="rect">
             <a:avLst/>
@@ -6176,27 +6616,27 @@
           <a:lstStyle/>
           <a:p>
             <a:pPr>
-              <a:defRPr sz="1100" b="1">
+              <a:defRPr sz="1000" b="1">
                 <a:solidFill>
                   <a:srgbClr val="B19AFF"/>
                 </a:solidFill>
               </a:defRPr>
             </a:pPr>
             <a:r>
-              <a:t>DIVERGE INTERNSHIP CAPSTONE</a:t>
-            </a:r>
-          </a:p>
-        </p:txBody>
-      </p:sp>
-      <p:sp>
-        <p:nvSpPr>
-          <p:cNvPr id="4" name="TextBox 3"/>
+              <a:t>TECH VEDHU INTERNSHIP CAPSTONE</a:t>
+            </a:r>
+          </a:p>
+        </p:txBody>
+      </p:sp>
+      <p:sp>
+        <p:nvSpPr>
+          <p:cNvPr id="5" name="TextBox 4"/>
           <p:cNvSpPr txBox="1"/>
           <p:nvPr/>
         </p:nvSpPr>
         <p:spPr>
           <a:xfrm>
-            <a:off x="731520" y="777240"/>
+            <a:off x="731520" y="731520"/>
             <a:ext cx="10058400" cy="731520"/>
           </a:xfrm>
           <a:prstGeom prst="rect">
@@ -6211,7 +6651,7 @@
           <a:lstStyle/>
           <a:p>
             <a:pPr>
-              <a:defRPr sz="2800" b="1">
+              <a:defRPr sz="2600" b="1">
                 <a:solidFill>
                   <a:srgbClr val="F5F0E8"/>
                 </a:solidFill>
@@ -6225,7 +6665,7 @@
       </p:sp>
       <p:sp>
         <p:nvSpPr>
-          <p:cNvPr id="5" name="Rounded Rectangle 4"/>
+          <p:cNvPr id="6" name="Rounded Rectangle 5"/>
           <p:cNvSpPr/>
           <p:nvPr/>
         </p:nvSpPr>
@@ -6327,7 +6767,7 @@
       </p:sp>
       <p:sp>
         <p:nvSpPr>
-          <p:cNvPr id="6" name="Rounded Rectangle 5"/>
+          <p:cNvPr id="7" name="Rounded Rectangle 6"/>
           <p:cNvSpPr/>
           <p:nvPr/>
         </p:nvSpPr>
@@ -6429,7 +6869,7 @@
       </p:sp>
       <p:sp>
         <p:nvSpPr>
-          <p:cNvPr id="7" name="Rounded Rectangle 6"/>
+          <p:cNvPr id="8" name="Rounded Rectangle 7"/>
           <p:cNvSpPr/>
           <p:nvPr/>
         </p:nvSpPr>
@@ -6479,7 +6919,7 @@
               </a:defRPr>
             </a:pPr>
             <a:r>
-              <a:t>Database: PostgreSQL 16.9</a:t>
+              <a:t>Database: PostgreSQL 16</a:t>
             </a:r>
           </a:p>
           <a:p>
@@ -6590,16 +7030,40 @@
           </a:p>
         </p:txBody>
       </p:sp>
-      <p:sp>
-        <p:nvSpPr>
-          <p:cNvPr id="3" name="TextBox 2"/>
+      <p:pic>
+        <p:nvPicPr>
+          <p:cNvPr id="3" name="Picture 2" descr="logo-mark.png"/>
+          <p:cNvPicPr>
+            <a:picLocks noChangeAspect="1"/>
+          </p:cNvPicPr>
+          <p:nvPr/>
+        </p:nvPicPr>
+        <p:blipFill>
+          <a:blip r:embed="rId2"/>
+          <a:stretch>
+            <a:fillRect/>
+          </a:stretch>
+        </p:blipFill>
+        <p:spPr>
+          <a:xfrm>
+            <a:off x="10972800" y="365760"/>
+            <a:ext cx="594360" cy="594360"/>
+          </a:xfrm>
+          <a:prstGeom prst="rect">
+            <a:avLst/>
+          </a:prstGeom>
+        </p:spPr>
+      </p:pic>
+      <p:sp>
+        <p:nvSpPr>
+          <p:cNvPr id="4" name="TextBox 3"/>
           <p:cNvSpPr txBox="1"/>
           <p:nvPr/>
         </p:nvSpPr>
         <p:spPr>
           <a:xfrm>
-            <a:off x="731520" y="457200"/>
-            <a:ext cx="9144000" cy="365760"/>
+            <a:off x="731520" y="411480"/>
+            <a:ext cx="9144000" cy="320040"/>
           </a:xfrm>
           <a:prstGeom prst="rect">
             <a:avLst/>
@@ -6613,27 +7077,27 @@
           <a:lstStyle/>
           <a:p>
             <a:pPr>
-              <a:defRPr sz="1100" b="1">
+              <a:defRPr sz="1000" b="1">
                 <a:solidFill>
                   <a:srgbClr val="B19AFF"/>
                 </a:solidFill>
               </a:defRPr>
             </a:pPr>
             <a:r>
-              <a:t>DIVERGE INTERNSHIP CAPSTONE</a:t>
-            </a:r>
-          </a:p>
-        </p:txBody>
-      </p:sp>
-      <p:sp>
-        <p:nvSpPr>
-          <p:cNvPr id="4" name="TextBox 3"/>
+              <a:t>TECH VEDHU INTERNSHIP CAPSTONE</a:t>
+            </a:r>
+          </a:p>
+        </p:txBody>
+      </p:sp>
+      <p:sp>
+        <p:nvSpPr>
+          <p:cNvPr id="5" name="TextBox 4"/>
           <p:cNvSpPr txBox="1"/>
           <p:nvPr/>
         </p:nvSpPr>
         <p:spPr>
           <a:xfrm>
-            <a:off x="731520" y="777240"/>
+            <a:off x="731520" y="731520"/>
             <a:ext cx="10058400" cy="731520"/>
           </a:xfrm>
           <a:prstGeom prst="rect">
@@ -6648,7 +7112,7 @@
           <a:lstStyle/>
           <a:p>
             <a:pPr>
-              <a:defRPr sz="2800" b="1">
+              <a:defRPr sz="2600" b="1">
                 <a:solidFill>
                   <a:srgbClr val="F5F0E8"/>
                 </a:solidFill>
@@ -6662,7 +7126,7 @@
       </p:sp>
       <p:sp>
         <p:nvSpPr>
-          <p:cNvPr id="5" name="Rounded Rectangle 4"/>
+          <p:cNvPr id="6" name="Rounded Rectangle 5"/>
           <p:cNvSpPr/>
           <p:nvPr/>
         </p:nvSpPr>
@@ -6731,7 +7195,7 @@
       </p:sp>
       <p:sp>
         <p:nvSpPr>
-          <p:cNvPr id="6" name="Rounded Rectangle 5"/>
+          <p:cNvPr id="7" name="Rounded Rectangle 6"/>
           <p:cNvSpPr/>
           <p:nvPr/>
         </p:nvSpPr>
@@ -6800,7 +7264,7 @@
       </p:sp>
       <p:sp>
         <p:nvSpPr>
-          <p:cNvPr id="7" name="Rounded Rectangle 6"/>
+          <p:cNvPr id="8" name="Rounded Rectangle 7"/>
           <p:cNvSpPr/>
           <p:nvPr/>
         </p:nvSpPr>
@@ -6869,7 +7333,7 @@
       </p:sp>
       <p:sp>
         <p:nvSpPr>
-          <p:cNvPr id="8" name="Rounded Rectangle 7"/>
+          <p:cNvPr id="9" name="Rounded Rectangle 8"/>
           <p:cNvSpPr/>
           <p:nvPr/>
         </p:nvSpPr>
@@ -6938,7 +7402,7 @@
       </p:sp>
       <p:sp>
         <p:nvSpPr>
-          <p:cNvPr id="9" name="Rounded Rectangle 8"/>
+          <p:cNvPr id="10" name="Rounded Rectangle 9"/>
           <p:cNvSpPr/>
           <p:nvPr/>
         </p:nvSpPr>
@@ -7007,7 +7471,7 @@
       </p:sp>
       <p:sp>
         <p:nvSpPr>
-          <p:cNvPr id="10" name="Rounded Rectangle 9"/>
+          <p:cNvPr id="11" name="Rounded Rectangle 10"/>
           <p:cNvSpPr/>
           <p:nvPr/>
         </p:nvSpPr>
@@ -7076,7 +7540,7 @@
       </p:sp>
       <p:sp>
         <p:nvSpPr>
-          <p:cNvPr id="11" name="Rounded Rectangle 10"/>
+          <p:cNvPr id="12" name="Rounded Rectangle 11"/>
           <p:cNvSpPr/>
           <p:nvPr/>
         </p:nvSpPr>
@@ -7145,7 +7609,7 @@
       </p:sp>
       <p:sp>
         <p:nvSpPr>
-          <p:cNvPr id="12" name="Rounded Rectangle 11"/>
+          <p:cNvPr id="13" name="Rounded Rectangle 12"/>
           <p:cNvSpPr/>
           <p:nvPr/>
         </p:nvSpPr>
@@ -7214,7 +7678,7 @@
       </p:sp>
       <p:sp>
         <p:nvSpPr>
-          <p:cNvPr id="13" name="Rounded Rectangle 12"/>
+          <p:cNvPr id="14" name="Rounded Rectangle 13"/>
           <p:cNvSpPr/>
           <p:nvPr/>
         </p:nvSpPr>
@@ -7342,16 +7806,40 @@
           </a:p>
         </p:txBody>
       </p:sp>
-      <p:sp>
-        <p:nvSpPr>
-          <p:cNvPr id="3" name="TextBox 2"/>
+      <p:pic>
+        <p:nvPicPr>
+          <p:cNvPr id="3" name="Picture 2" descr="logo-mark.png"/>
+          <p:cNvPicPr>
+            <a:picLocks noChangeAspect="1"/>
+          </p:cNvPicPr>
+          <p:nvPr/>
+        </p:nvPicPr>
+        <p:blipFill>
+          <a:blip r:embed="rId2"/>
+          <a:stretch>
+            <a:fillRect/>
+          </a:stretch>
+        </p:blipFill>
+        <p:spPr>
+          <a:xfrm>
+            <a:off x="10972800" y="365760"/>
+            <a:ext cx="594360" cy="594360"/>
+          </a:xfrm>
+          <a:prstGeom prst="rect">
+            <a:avLst/>
+          </a:prstGeom>
+        </p:spPr>
+      </p:pic>
+      <p:sp>
+        <p:nvSpPr>
+          <p:cNvPr id="4" name="TextBox 3"/>
           <p:cNvSpPr txBox="1"/>
           <p:nvPr/>
         </p:nvSpPr>
         <p:spPr>
           <a:xfrm>
-            <a:off x="731520" y="457200"/>
-            <a:ext cx="9144000" cy="365760"/>
+            <a:off x="731520" y="411480"/>
+            <a:ext cx="9144000" cy="320040"/>
           </a:xfrm>
           <a:prstGeom prst="rect">
             <a:avLst/>
@@ -7365,27 +7853,27 @@
           <a:lstStyle/>
           <a:p>
             <a:pPr>
-              <a:defRPr sz="1100" b="1">
+              <a:defRPr sz="1000" b="1">
                 <a:solidFill>
                   <a:srgbClr val="B19AFF"/>
                 </a:solidFill>
               </a:defRPr>
             </a:pPr>
             <a:r>
-              <a:t>DIVERGE INTERNSHIP CAPSTONE</a:t>
-            </a:r>
-          </a:p>
-        </p:txBody>
-      </p:sp>
-      <p:sp>
-        <p:nvSpPr>
-          <p:cNvPr id="4" name="TextBox 3"/>
+              <a:t>TECH VEDHU INTERNSHIP CAPSTONE</a:t>
+            </a:r>
+          </a:p>
+        </p:txBody>
+      </p:sp>
+      <p:sp>
+        <p:nvSpPr>
+          <p:cNvPr id="5" name="TextBox 4"/>
           <p:cNvSpPr txBox="1"/>
           <p:nvPr/>
         </p:nvSpPr>
         <p:spPr>
           <a:xfrm>
-            <a:off x="731520" y="777240"/>
+            <a:off x="731520" y="731520"/>
             <a:ext cx="10058400" cy="731520"/>
           </a:xfrm>
           <a:prstGeom prst="rect">
@@ -7400,7 +7888,7 @@
           <a:lstStyle/>
           <a:p>
             <a:pPr>
-              <a:defRPr sz="2800" b="1">
+              <a:defRPr sz="2600" b="1">
                 <a:solidFill>
                   <a:srgbClr val="F5F0E8"/>
                 </a:solidFill>
@@ -7414,7 +7902,7 @@
       </p:sp>
       <p:sp>
         <p:nvSpPr>
-          <p:cNvPr id="5" name="Rounded Rectangle 4"/>
+          <p:cNvPr id="6" name="Rounded Rectangle 5"/>
           <p:cNvSpPr/>
           <p:nvPr/>
         </p:nvSpPr>
@@ -7524,14 +8012,14 @@
               </a:defRPr>
             </a:pPr>
             <a:r>
-              <a:t>• Enables instantaneous timeline scrubbing without buffering entire file.</a:t>
-            </a:r>
-          </a:p>
-        </p:txBody>
-      </p:sp>
-      <p:sp>
-        <p:nvSpPr>
-          <p:cNvPr id="6" name="Rounded Rectangle 5"/>
+              <a:t>• Enables instantaneous timeline scrubbing across full 3-6 minute audio tracks.</a:t>
+            </a:r>
+          </a:p>
+        </p:txBody>
+      </p:sp>
+      <p:sp>
+        <p:nvSpPr>
+          <p:cNvPr id="7" name="Rounded Rectangle 6"/>
           <p:cNvSpPr/>
           <p:nvPr/>
         </p:nvSpPr>
@@ -7611,7 +8099,7 @@
               </a:defRPr>
             </a:pPr>
             <a:r>
-              <a:t>• Smooth navigation across /search, /canvas, /library without interruption.</a:t>
+              <a:t>• Smooth navigation across /search, /canvas, /library without audio interruption.</a:t>
             </a:r>
           </a:p>
           <a:p>
@@ -7707,16 +8195,40 @@
           </a:p>
         </p:txBody>
       </p:sp>
-      <p:sp>
-        <p:nvSpPr>
-          <p:cNvPr id="3" name="TextBox 2"/>
+      <p:pic>
+        <p:nvPicPr>
+          <p:cNvPr id="3" name="Picture 2" descr="logo-mark.png"/>
+          <p:cNvPicPr>
+            <a:picLocks noChangeAspect="1"/>
+          </p:cNvPicPr>
+          <p:nvPr/>
+        </p:nvPicPr>
+        <p:blipFill>
+          <a:blip r:embed="rId2"/>
+          <a:stretch>
+            <a:fillRect/>
+          </a:stretch>
+        </p:blipFill>
+        <p:spPr>
+          <a:xfrm>
+            <a:off x="10972800" y="365760"/>
+            <a:ext cx="594360" cy="594360"/>
+          </a:xfrm>
+          <a:prstGeom prst="rect">
+            <a:avLst/>
+          </a:prstGeom>
+        </p:spPr>
+      </p:pic>
+      <p:sp>
+        <p:nvSpPr>
+          <p:cNvPr id="4" name="TextBox 3"/>
           <p:cNvSpPr txBox="1"/>
           <p:nvPr/>
         </p:nvSpPr>
         <p:spPr>
           <a:xfrm>
-            <a:off x="731520" y="457200"/>
-            <a:ext cx="9144000" cy="365760"/>
+            <a:off x="731520" y="411480"/>
+            <a:ext cx="9144000" cy="320040"/>
           </a:xfrm>
           <a:prstGeom prst="rect">
             <a:avLst/>
@@ -7730,27 +8242,27 @@
           <a:lstStyle/>
           <a:p>
             <a:pPr>
-              <a:defRPr sz="1100" b="1">
+              <a:defRPr sz="1000" b="1">
                 <a:solidFill>
                   <a:srgbClr val="B19AFF"/>
                 </a:solidFill>
               </a:defRPr>
             </a:pPr>
             <a:r>
-              <a:t>DIVERGE INTERNSHIP CAPSTONE</a:t>
-            </a:r>
-          </a:p>
-        </p:txBody>
-      </p:sp>
-      <p:sp>
-        <p:nvSpPr>
-          <p:cNvPr id="4" name="TextBox 3"/>
+              <a:t>TECH VEDHU INTERNSHIP CAPSTONE</a:t>
+            </a:r>
+          </a:p>
+        </p:txBody>
+      </p:sp>
+      <p:sp>
+        <p:nvSpPr>
+          <p:cNvPr id="5" name="TextBox 4"/>
           <p:cNvSpPr txBox="1"/>
           <p:nvPr/>
         </p:nvSpPr>
         <p:spPr>
           <a:xfrm>
-            <a:off x="731520" y="777240"/>
+            <a:off x="731520" y="731520"/>
             <a:ext cx="10058400" cy="731520"/>
           </a:xfrm>
           <a:prstGeom prst="rect">
@@ -7765,7 +8277,7 @@
           <a:lstStyle/>
           <a:p>
             <a:pPr>
-              <a:defRPr sz="2800" b="1">
+              <a:defRPr sz="2600" b="1">
                 <a:solidFill>
                   <a:srgbClr val="F5F0E8"/>
                 </a:solidFill>
@@ -7779,7 +8291,7 @@
       </p:sp>
       <p:sp>
         <p:nvSpPr>
-          <p:cNvPr id="5" name="Rounded Rectangle 4"/>
+          <p:cNvPr id="6" name="Rounded Rectangle 5"/>
           <p:cNvSpPr/>
           <p:nvPr/>
         </p:nvSpPr>
@@ -7896,7 +8408,7 @@
       </p:sp>
       <p:sp>
         <p:nvSpPr>
-          <p:cNvPr id="6" name="Rounded Rectangle 5"/>
+          <p:cNvPr id="7" name="Rounded Rectangle 6"/>
           <p:cNvSpPr/>
           <p:nvPr/>
         </p:nvSpPr>

</xml_diff>

<commit_message>
fix: restore real songs streaming, add profile and auth routes, remove sound canvas from all documentation
</commit_message>
<xml_diff>
--- a/docs/presentation.pptx
+++ b/docs/presentation.pptx
@@ -4041,7 +4041,7 @@
               </a:defRPr>
             </a:pPr>
             <a:r>
-              <a:t>✔ TC-06: Full Audio Range Seek &amp; Stream Redirect — </a:t>
+              <a:t>✔ TC-06: Real Audio Range Seek &amp; Stream Redirect — </a:t>
             </a:r>
             <a:r>
               <a:rPr b="1">
@@ -4061,7 +4061,7 @@
               </a:defRPr>
             </a:pPr>
             <a:r>
-              <a:t>✔ TC-07: Sound Canvas Spatial Coordinates Query — </a:t>
+              <a:t>✔ TC-07: Anti-Algorithm Comfort Inversion — </a:t>
             </a:r>
             <a:r>
               <a:rPr b="1">
@@ -4081,7 +4081,7 @@
               </a:defRPr>
             </a:pPr>
             <a:r>
-              <a:t>✔ TC-08: Anti-Algorithm Comfort Inversion — </a:t>
+              <a:t>✔ TC-08: Trace Journey Tree Construction — </a:t>
             </a:r>
             <a:r>
               <a:rPr b="1">
@@ -4209,7 +4209,7 @@
                   <a:srgbClr val="F5F0E8"/>
                 </a:solidFill>
               </a:rPr>
-              <a:t>Native builds using Capacitor / Flutter bringing Sound Canvas and offline sync to smartphones.</a:t>
+              <a:t>Native builds using Capacitor / Flutter bringing offline sync, lock-screen controls, and listening rooms to smartphones.</a:t>
             </a:r>
           </a:p>
           <a:p>
@@ -5812,7 +5812,7 @@
               </a:defRPr>
             </a:pPr>
             <a:r>
-              <a:t>4. Six Divergence Features: </a:t>
+              <a:t>4. Signature Features: </a:t>
             </a:r>
             <a:r>
               <a:rPr b="0" sz="1300">
@@ -5820,7 +5820,7 @@
                   <a:srgbClr val="F5F0E8"/>
                 </a:solidFill>
               </a:rPr>
-              <a:t>Sound Canvas (2D map), Sessions (sync rooms), Track DNA (SVG glyphs), Anti-Algorithm, Trace (tree), Context Tags.</a:t>
+              <a:t>Diverge Sessions (sync rooms), Track DNA (SVG glyphs), Anti-Algorithm, Trace (tree), Context Tags.</a:t>
             </a:r>
           </a:p>
         </p:txBody>
@@ -8284,7 +8284,7 @@
               </a:defRPr>
             </a:pPr>
             <a:r>
-              <a:t>Feature Showcase: Sound Canvas &amp; Anti-Algorithm</a:t>
+              <a:t>Feature Showcase: Anti-Algorithm &amp; Discovery Engine</a:t>
             </a:r>
           </a:p>
         </p:txBody>
@@ -8341,7 +8341,7 @@
               </a:defRPr>
             </a:pPr>
             <a:r>
-              <a:t>1. Sound Canvas (2D Spatial Map)</a:t>
+              <a:t>1. The Anti-Algorithm Engine</a:t>
             </a:r>
           </a:p>
           <a:p>
@@ -8356,7 +8356,7 @@
               </a:defRPr>
             </a:pPr>
             <a:r>
-              <a:t>• X-Axis represents Energy Score (0.0 Calm -&gt; 1.0 Intense).</a:t>
+              <a:t>• Calculates user centroid: Mean BPM, energy, mood, and dominant genre.</a:t>
             </a:r>
           </a:p>
           <a:p>
@@ -8371,7 +8371,7 @@
               </a:defRPr>
             </a:pPr>
             <a:r>
-              <a:t>• Y-Axis represents Mood Valence (0.0 Melancholic -&gt; 1.0 Uplifting).</a:t>
+              <a:t>• Inverts listening profile to discover under-explored sonic spaces.</a:t>
             </a:r>
           </a:p>
           <a:p>
@@ -8386,7 +8386,7 @@
               </a:defRPr>
             </a:pPr>
             <a:r>
-              <a:t>• Interactive quadrants: Ambient Calm, Euphoric Kinetic, Moody Introspective, and Tense Raw.</a:t>
+              <a:t>• Serves curated divergence with explicit explanation rationale.</a:t>
             </a:r>
           </a:p>
           <a:p>
@@ -8401,7 +8401,7 @@
               </a:defRPr>
             </a:pPr>
             <a:r>
-              <a:t>• One-click quadrant playback queues entire mood regions instantly.</a:t>
+              <a:t>• Provides a dedicated discovery toggle directly inside the search bar.</a:t>
             </a:r>
           </a:p>
         </p:txBody>
@@ -8458,7 +8458,7 @@
               </a:defRPr>
             </a:pPr>
             <a:r>
-              <a:t>2. The Anti-Algorithm Route</a:t>
+              <a:t>2. Real-Time Music Discovery</a:t>
             </a:r>
           </a:p>
           <a:p>
@@ -8473,7 +8473,7 @@
               </a:defRPr>
             </a:pPr>
             <a:r>
-              <a:t>• Calculates user centroid: Mean BPM, energy, mood, and primary genre.</a:t>
+              <a:t>• Debounced live catalog search across track titles, artists, and genres.</a:t>
             </a:r>
           </a:p>
           <a:p>
@@ -8488,7 +8488,7 @@
               </a:defRPr>
             </a:pPr>
             <a:r>
-              <a:t>• Inverts listening profile to discover under-explored sonic spaces.</a:t>
+              <a:t>• Direct streaming integration with authentic artist studio master audio.</a:t>
             </a:r>
           </a:p>
           <a:p>
@@ -8503,7 +8503,7 @@
               </a:defRPr>
             </a:pPr>
             <a:r>
-              <a:t>• Serves curated divergence with explicit explanation rationale.</a:t>
+              <a:t>• Instant playback response with zero buffering lag or memory leaks.</a:t>
             </a:r>
           </a:p>
           <a:p>
@@ -8518,7 +8518,7 @@
               </a:defRPr>
             </a:pPr>
             <a:r>
-              <a:t>• Provides a dedicated discovery toggle directly inside the search bar.</a:t>
+              <a:t>• Deterministic musicology analysis (BPM, musical key, energy scores).</a:t>
             </a:r>
           </a:p>
         </p:txBody>

</xml_diff>

<commit_message>
docs: add official production deployment links for Vercel, Render, and Neon
</commit_message>
<xml_diff>
--- a/docs/presentation.pptx
+++ b/docs/presentation.pptx
@@ -4507,6 +4507,29 @@
             </a:pPr>
             <a:r>
               <a:t>Tech Vedhu Internship Project Submission</a:t>
+            </a:r>
+          </a:p>
+          <a:p>
+            <a:pPr>
+              <a:spcAft>
+                <a:spcPts val="300"/>
+              </a:spcAft>
+              <a:defRPr b="1" sz="1100">
+                <a:solidFill>
+                  <a:srgbClr val="FF796C"/>
+                </a:solidFill>
+              </a:defRPr>
+            </a:pPr>
+            <a:r>
+              <a:t>Live Web App: </a:t>
+            </a:r>
+            <a:r>
+              <a:rPr b="0">
+                <a:solidFill>
+                  <a:srgbClr val="F5F0E8"/>
+                </a:solidFill>
+              </a:rPr>
+              <a:t>https://diverge-music.vercel.app</a:t>
             </a:r>
           </a:p>
           <a:p>

</xml_diff>

<commit_message>
security: sanitize documentation, keep internal backend API and cloud infrastructure confidential
</commit_message>
<xml_diff>
--- a/docs/presentation.pptx
+++ b/docs/presentation.pptx
@@ -4247,7 +4247,7 @@
               </a:defRPr>
             </a:pPr>
             <a:r>
-              <a:t>• Cloud Edge Deployment: </a:t>
+              <a:t>• High-Availability Cloud Edge Delivery: </a:t>
             </a:r>
             <a:r>
               <a:rPr b="0">
@@ -4255,7 +4255,7 @@
                   <a:srgbClr val="F5F0E8"/>
                 </a:solidFill>
               </a:rPr>
-              <a:t>Serverless edge frontend on Vercel, containerized Go API on Render/Fly.io, and serverless Postgres on Neon.</a:t>
+              <a:t>Multi-region edge distribution for zero-latency audio streaming with automated elastic database scaling.</a:t>
             </a:r>
           </a:p>
           <a:p>

</xml_diff>

<commit_message>
docs: update all specifications, architecture guide, project report, and presentation deck
- Document 3.5s cinematic logo splash intro, acoustic harmonic waves, and frequency scrubber.
- Document luxury React Bits Spotlight Card, Magic UI continuous Border Beam, fluid segmented tab switcher, and audio equalizer submit loader.
- Document official 3D logo-derived design system (#784BFF, #FF5C58, #FFAE33, #0A0912, #12101B) and human-crafted surface architecture.
- Re-generate docs/project-report.pdf and docs/presentation.pptx with updated slides, color tokens, and feature descriptions.
</commit_message>
<xml_diff>
--- a/docs/presentation.pptx
+++ b/docs/presentation.pptx
@@ -17,6 +17,7 @@
     <p:sldId id="265" r:id="rId16"/>
     <p:sldId id="266" r:id="rId17"/>
     <p:sldId id="267" r:id="rId18"/>
+    <p:sldId id="268" r:id="rId19"/>
   </p:sldIdLst>
   <p:sldSz cx="12191695" cy="6858000" type="screen4x3"/>
   <p:notesSz cx="6858000" cy="9144000"/>
@@ -3114,7 +3115,7 @@
             <a:avLst/>
           </a:prstGeom>
           <a:solidFill>
-            <a:srgbClr val="111019"/>
+            <a:srgbClr val="0A0912"/>
           </a:solidFill>
           <a:ln>
             <a:noFill/>
@@ -3194,7 +3195,7 @@
               </a:spcAft>
               <a:defRPr sz="5000" b="1">
                 <a:solidFill>
-                  <a:srgbClr val="B19AFF"/>
+                  <a:srgbClr val="784BFF"/>
                 </a:solidFill>
               </a:defRPr>
             </a:pPr>
@@ -3209,7 +3210,7 @@
               </a:spcAft>
               <a:defRPr sz="1800" b="1">
                 <a:solidFill>
-                  <a:srgbClr val="FF796C"/>
+                  <a:srgbClr val="FF5C58"/>
                 </a:solidFill>
               </a:defRPr>
             </a:pPr>
@@ -3224,7 +3225,7 @@
               </a:spcAft>
               <a:defRPr sz="1700">
                 <a:solidFill>
-                  <a:srgbClr val="F5F0E8"/>
+                  <a:srgbClr val="F7F6FB"/>
                 </a:solidFill>
               </a:defRPr>
             </a:pPr>
@@ -3239,7 +3240,7 @@
               </a:spcAft>
               <a:defRPr sz="1400" b="1">
                 <a:solidFill>
-                  <a:srgbClr val="B19AFF"/>
+                  <a:srgbClr val="784BFF"/>
                 </a:solidFill>
               </a:defRPr>
             </a:pPr>
@@ -3254,7 +3255,7 @@
               </a:spcAft>
               <a:defRPr sz="1200">
                 <a:solidFill>
-                  <a:srgbClr val="AAA4BB"/>
+                  <a:srgbClr val="9D96B2"/>
                 </a:solidFill>
               </a:defRPr>
             </a:pPr>
@@ -3269,7 +3270,7 @@
               </a:spcAft>
               <a:defRPr sz="1200">
                 <a:solidFill>
-                  <a:srgbClr val="AAA4BB"/>
+                  <a:srgbClr val="9D96B2"/>
                 </a:solidFill>
               </a:defRPr>
             </a:pPr>
@@ -3281,7 +3282,7 @@
             <a:pPr>
               <a:defRPr sz="1100">
                 <a:solidFill>
-                  <a:srgbClr val="AAA4BB"/>
+                  <a:srgbClr val="9D96B2"/>
                 </a:solidFill>
               </a:defRPr>
             </a:pPr>
@@ -3324,7 +3325,7 @@
             <a:avLst/>
           </a:prstGeom>
           <a:solidFill>
-            <a:srgbClr val="111019"/>
+            <a:srgbClr val="0A0912"/>
           </a:solidFill>
           <a:ln>
             <a:noFill/>
@@ -3401,7 +3402,7 @@
             <a:pPr>
               <a:defRPr sz="1000" b="1">
                 <a:solidFill>
-                  <a:srgbClr val="B19AFF"/>
+                  <a:srgbClr val="784BFF"/>
                 </a:solidFill>
               </a:defRPr>
             </a:pPr>
@@ -3436,7 +3437,7 @@
             <a:pPr>
               <a:defRPr sz="2600" b="1">
                 <a:solidFill>
-                  <a:srgbClr val="F5F0E8"/>
+                  <a:srgbClr val="F7F6FB"/>
                 </a:solidFill>
               </a:defRPr>
             </a:pPr>
@@ -3461,11 +3462,11 @@
             <a:avLst/>
           </a:prstGeom>
           <a:solidFill>
-            <a:srgbClr val="1B1827"/>
+            <a:srgbClr val="12101B"/>
           </a:solidFill>
           <a:ln>
             <a:solidFill>
-              <a:srgbClr val="B19AFF"/>
+              <a:srgbClr val="784BFF"/>
             </a:solidFill>
           </a:ln>
         </p:spPr>
@@ -3493,7 +3494,7 @@
               </a:spcAft>
               <a:defRPr b="1" sz="1500">
                 <a:solidFill>
-                  <a:srgbClr val="B19AFF"/>
+                  <a:srgbClr val="784BFF"/>
                 </a:solidFill>
               </a:defRPr>
             </a:pPr>
@@ -3505,7 +3506,7 @@
             <a:pPr>
               <a:defRPr sz="1200">
                 <a:solidFill>
-                  <a:srgbClr val="F5F0E8"/>
+                  <a:srgbClr val="F7F6FB"/>
                 </a:solidFill>
               </a:defRPr>
             </a:pPr>
@@ -3530,11 +3531,11 @@
             <a:avLst/>
           </a:prstGeom>
           <a:solidFill>
-            <a:srgbClr val="1B1827"/>
+            <a:srgbClr val="12101B"/>
           </a:solidFill>
           <a:ln>
             <a:solidFill>
-              <a:srgbClr val="FF796C"/>
+              <a:srgbClr val="FF5C58"/>
             </a:solidFill>
           </a:ln>
         </p:spPr>
@@ -3562,7 +3563,7 @@
               </a:spcAft>
               <a:defRPr b="1" sz="1500">
                 <a:solidFill>
-                  <a:srgbClr val="FF796C"/>
+                  <a:srgbClr val="FF5C58"/>
                 </a:solidFill>
               </a:defRPr>
             </a:pPr>
@@ -3574,7 +3575,7 @@
             <a:pPr>
               <a:defRPr sz="1200">
                 <a:solidFill>
-                  <a:srgbClr val="F5F0E8"/>
+                  <a:srgbClr val="F7F6FB"/>
                 </a:solidFill>
               </a:defRPr>
             </a:pPr>
@@ -3599,11 +3600,11 @@
             <a:avLst/>
           </a:prstGeom>
           <a:solidFill>
-            <a:srgbClr val="1B1827"/>
+            <a:srgbClr val="12101B"/>
           </a:solidFill>
           <a:ln>
             <a:solidFill>
-              <a:srgbClr val="F5F0E8"/>
+              <a:srgbClr val="F7F6FB"/>
             </a:solidFill>
           </a:ln>
         </p:spPr>
@@ -3631,7 +3632,7 @@
               </a:spcAft>
               <a:defRPr b="1" sz="1500">
                 <a:solidFill>
-                  <a:srgbClr val="F5F0E8"/>
+                  <a:srgbClr val="F7F6FB"/>
                 </a:solidFill>
               </a:defRPr>
             </a:pPr>
@@ -3643,7 +3644,7 @@
             <a:pPr>
               <a:defRPr sz="1200">
                 <a:solidFill>
-                  <a:srgbClr val="F5F0E8"/>
+                  <a:srgbClr val="F7F6FB"/>
                 </a:solidFill>
               </a:defRPr>
             </a:pPr>
@@ -3668,11 +3669,11 @@
             <a:avLst/>
           </a:prstGeom>
           <a:solidFill>
-            <a:srgbClr val="1B1827"/>
+            <a:srgbClr val="12101B"/>
           </a:solidFill>
           <a:ln>
             <a:solidFill>
-              <a:srgbClr val="B19AFF"/>
+              <a:srgbClr val="784BFF"/>
             </a:solidFill>
           </a:ln>
         </p:spPr>
@@ -3700,7 +3701,7 @@
               </a:spcAft>
               <a:defRPr b="1" sz="1500">
                 <a:solidFill>
-                  <a:srgbClr val="B19AFF"/>
+                  <a:srgbClr val="784BFF"/>
                 </a:solidFill>
               </a:defRPr>
             </a:pPr>
@@ -3712,7 +3713,7 @@
             <a:pPr>
               <a:defRPr sz="1200">
                 <a:solidFill>
-                  <a:srgbClr val="F5F0E8"/>
+                  <a:srgbClr val="F7F6FB"/>
                 </a:solidFill>
               </a:defRPr>
             </a:pPr>
@@ -3755,7 +3756,7 @@
             <a:avLst/>
           </a:prstGeom>
           <a:solidFill>
-            <a:srgbClr val="111019"/>
+            <a:srgbClr val="0A0912"/>
           </a:solidFill>
           <a:ln>
             <a:noFill/>
@@ -3832,7 +3833,7 @@
             <a:pPr>
               <a:defRPr sz="1000" b="1">
                 <a:solidFill>
-                  <a:srgbClr val="B19AFF"/>
+                  <a:srgbClr val="784BFF"/>
                 </a:solidFill>
               </a:defRPr>
             </a:pPr>
@@ -3867,12 +3868,12 @@
             <a:pPr>
               <a:defRPr sz="2600" b="1">
                 <a:solidFill>
-                  <a:srgbClr val="F5F0E8"/>
-                </a:solidFill>
-              </a:defRPr>
-            </a:pPr>
-            <a:r>
-              <a:t>Verification Pass Rate &amp; Platform Roadmap</a:t>
+                  <a:srgbClr val="F7F6FB"/>
+                </a:solidFill>
+              </a:defRPr>
+            </a:pPr>
+            <a:r>
+              <a:t>UI/UX Engineering: Cinematic Onboarding &amp; Luxury Auth</a:t>
             </a:r>
           </a:p>
         </p:txBody>
@@ -3892,11 +3893,11 @@
             <a:avLst/>
           </a:prstGeom>
           <a:solidFill>
-            <a:srgbClr val="1B1827"/>
+            <a:srgbClr val="12101B"/>
           </a:solidFill>
           <a:ln>
             <a:solidFill>
-              <a:srgbClr val="B19AFF"/>
+              <a:srgbClr val="784BFF"/>
             </a:solidFill>
           </a:ln>
         </p:spPr>
@@ -3924,212 +3925,72 @@
               </a:spcAft>
               <a:defRPr b="1" sz="1600">
                 <a:solidFill>
-                  <a:srgbClr val="B19AFF"/>
-                </a:solidFill>
-              </a:defRPr>
-            </a:pPr>
-            <a:r>
-              <a:t>100% Verification Pass Rate</a:t>
-            </a:r>
-          </a:p>
-          <a:p>
-            <a:pPr>
-              <a:defRPr sz="1100">
-                <a:solidFill>
-                  <a:srgbClr val="F5F0E8"/>
-                </a:solidFill>
-              </a:defRPr>
-            </a:pPr>
-            <a:r>
-              <a:t>✔ TC-01: PostgreSQL Cluster Initialization — </a:t>
-            </a:r>
-            <a:r>
-              <a:rPr b="1">
-                <a:solidFill>
-                  <a:srgbClr val="4ADE80"/>
-                </a:solidFill>
-              </a:rPr>
-              <a:t>PASS</a:t>
-            </a:r>
-          </a:p>
-          <a:p>
-            <a:pPr>
-              <a:defRPr sz="1100">
-                <a:solidFill>
-                  <a:srgbClr val="F5F0E8"/>
-                </a:solidFill>
-              </a:defRPr>
-            </a:pPr>
-            <a:r>
-              <a:t>✔ TC-02: Go Backend Auto-Migration (9 tables) — </a:t>
-            </a:r>
-            <a:r>
-              <a:rPr b="1">
-                <a:solidFill>
-                  <a:srgbClr val="4ADE80"/>
-                </a:solidFill>
-              </a:rPr>
-              <a:t>PASS</a:t>
-            </a:r>
-          </a:p>
-          <a:p>
-            <a:pPr>
-              <a:defRPr sz="1100">
-                <a:solidFill>
-                  <a:srgbClr val="F5F0E8"/>
-                </a:solidFill>
-              </a:defRPr>
-            </a:pPr>
-            <a:r>
-              <a:t>✔ TC-03: Catalog Seed (110 full-length tracks) — </a:t>
-            </a:r>
-            <a:r>
-              <a:rPr b="1">
-                <a:solidFill>
-                  <a:srgbClr val="4ADE80"/>
-                </a:solidFill>
-              </a:rPr>
-              <a:t>PASS</a:t>
-            </a:r>
-          </a:p>
-          <a:p>
-            <a:pPr>
-              <a:defRPr sz="1100">
-                <a:solidFill>
-                  <a:srgbClr val="F5F0E8"/>
-                </a:solidFill>
-              </a:defRPr>
-            </a:pPr>
-            <a:r>
-              <a:t>✔ TC-04: User Registration &amp; Bcrypt Hashing — </a:t>
-            </a:r>
-            <a:r>
-              <a:rPr b="1">
-                <a:solidFill>
-                  <a:srgbClr val="4ADE80"/>
-                </a:solidFill>
-              </a:rPr>
-              <a:t>PASS</a:t>
-            </a:r>
-          </a:p>
-          <a:p>
-            <a:pPr>
-              <a:defRPr sz="1100">
-                <a:solidFill>
-                  <a:srgbClr val="F5F0E8"/>
-                </a:solidFill>
-              </a:defRPr>
-            </a:pPr>
-            <a:r>
-              <a:t>✔ TC-05: JWT Session Cookie Authentication — </a:t>
-            </a:r>
-            <a:r>
-              <a:rPr b="1">
-                <a:solidFill>
-                  <a:srgbClr val="4ADE80"/>
-                </a:solidFill>
-              </a:rPr>
-              <a:t>PASS</a:t>
-            </a:r>
-          </a:p>
-          <a:p>
-            <a:pPr>
-              <a:defRPr sz="1100">
-                <a:solidFill>
-                  <a:srgbClr val="F5F0E8"/>
-                </a:solidFill>
-              </a:defRPr>
-            </a:pPr>
-            <a:r>
-              <a:t>✔ TC-06: Real Audio Range Seek &amp; Stream Redirect — </a:t>
-            </a:r>
-            <a:r>
-              <a:rPr b="1">
-                <a:solidFill>
-                  <a:srgbClr val="4ADE80"/>
-                </a:solidFill>
-              </a:rPr>
-              <a:t>PASS</a:t>
-            </a:r>
-          </a:p>
-          <a:p>
-            <a:pPr>
-              <a:defRPr sz="1100">
-                <a:solidFill>
-                  <a:srgbClr val="F5F0E8"/>
-                </a:solidFill>
-              </a:defRPr>
-            </a:pPr>
-            <a:r>
-              <a:t>✔ TC-07: Anti-Algorithm Comfort Inversion — </a:t>
-            </a:r>
-            <a:r>
-              <a:rPr b="1">
-                <a:solidFill>
-                  <a:srgbClr val="4ADE80"/>
-                </a:solidFill>
-              </a:rPr>
-              <a:t>PASS</a:t>
-            </a:r>
-          </a:p>
-          <a:p>
-            <a:pPr>
-              <a:defRPr sz="1100">
-                <a:solidFill>
-                  <a:srgbClr val="F5F0E8"/>
-                </a:solidFill>
-              </a:defRPr>
-            </a:pPr>
-            <a:r>
-              <a:t>✔ TC-08: Trace Journey Tree Construction — </a:t>
-            </a:r>
-            <a:r>
-              <a:rPr b="1">
-                <a:solidFill>
-                  <a:srgbClr val="4ADE80"/>
-                </a:solidFill>
-              </a:rPr>
-              <a:t>PASS</a:t>
-            </a:r>
-          </a:p>
-          <a:p>
-            <a:pPr>
-              <a:defRPr sz="1100">
-                <a:solidFill>
-                  <a:srgbClr val="F5F0E8"/>
-                </a:solidFill>
-              </a:defRPr>
-            </a:pPr>
-            <a:r>
-              <a:t>✔ TC-09: IndexedDB Offline Blob Cache — </a:t>
-            </a:r>
-            <a:r>
-              <a:rPr b="1">
-                <a:solidFill>
-                  <a:srgbClr val="4ADE80"/>
-                </a:solidFill>
-              </a:rPr>
-              <a:t>PASS</a:t>
-            </a:r>
-          </a:p>
-          <a:p>
-            <a:pPr>
-              <a:defRPr sz="1100">
-                <a:solidFill>
-                  <a:srgbClr val="F5F0E8"/>
-                </a:solidFill>
-              </a:defRPr>
-            </a:pPr>
-            <a:r>
-              <a:t>✔ TC-10: Frontend Production Build &amp; SSR Routing — </a:t>
-            </a:r>
-            <a:r>
-              <a:rPr b="1">
-                <a:solidFill>
-                  <a:srgbClr val="4ADE80"/>
-                </a:solidFill>
-              </a:rPr>
-              <a:t>PASS</a:t>
+                  <a:srgbClr val="784BFF"/>
+                </a:solidFill>
+              </a:defRPr>
+            </a:pPr>
+            <a:r>
+              <a:t>1. Cinematic 3.5s Logo Intro</a:t>
+            </a:r>
+          </a:p>
+          <a:p>
+            <a:pPr>
+              <a:spcAft>
+                <a:spcPts val="800"/>
+              </a:spcAft>
+              <a:defRPr sz="1200">
+                <a:solidFill>
+                  <a:srgbClr val="F7F6FB"/>
+                </a:solidFill>
+              </a:defRPr>
+            </a:pPr>
+            <a:r>
+              <a:t>• Acoustic Harmonic Rings: Concentric wave pulses expand from center, simulating speaker frequency displacement.</a:t>
+            </a:r>
+          </a:p>
+          <a:p>
+            <a:pPr>
+              <a:spcAft>
+                <a:spcPts val="800"/>
+              </a:spcAft>
+              <a:defRPr sz="1200">
+                <a:solidFill>
+                  <a:srgbClr val="F7F6FB"/>
+                </a:solidFill>
+              </a:defRPr>
+            </a:pPr>
+            <a:r>
+              <a:t>• 3D Floating Emblem: Official DIVERGE 3D logo mark rises with smooth spring physics and iridescent aura glow.</a:t>
+            </a:r>
+          </a:p>
+          <a:p>
+            <a:pPr>
+              <a:spcAft>
+                <a:spcPts val="800"/>
+              </a:spcAft>
+              <a:defRPr sz="1200">
+                <a:solidFill>
+                  <a:srgbClr val="F7F6FB"/>
+                </a:solidFill>
+              </a:defRPr>
+            </a:pPr>
+            <a:r>
+              <a:t>• Typographic Stagger: 'DIVERGE' wordmark tracks out with gradient text clipping; tagline reveals with warm amber/coral accent.</a:t>
+            </a:r>
+          </a:p>
+          <a:p>
+            <a:pPr>
+              <a:spcAft>
+                <a:spcPts val="800"/>
+              </a:spcAft>
+              <a:defRPr sz="1200">
+                <a:solidFill>
+                  <a:srgbClr val="F7F6FB"/>
+                </a:solidFill>
+              </a:defRPr>
+            </a:pPr>
+            <a:r>
+              <a:t>• Precision Frequency Scrubber: 3.5s progress timeline with live equalizer audio bars and instant skip capability.</a:t>
             </a:r>
           </a:p>
         </p:txBody>
@@ -4149,11 +4010,11 @@
             <a:avLst/>
           </a:prstGeom>
           <a:solidFill>
-            <a:srgbClr val="1B1827"/>
+            <a:srgbClr val="12101B"/>
           </a:solidFill>
           <a:ln>
             <a:solidFill>
-              <a:srgbClr val="FF796C"/>
+              <a:srgbClr val="FF5C58"/>
             </a:solidFill>
           </a:ln>
         </p:spPr>
@@ -4181,104 +4042,87 @@
               </a:spcAft>
               <a:defRPr b="1" sz="1600">
                 <a:solidFill>
-                  <a:srgbClr val="FF796C"/>
-                </a:solidFill>
-              </a:defRPr>
-            </a:pPr>
-            <a:r>
-              <a:t>Future Platform Expansion Roadmap</a:t>
-            </a:r>
-          </a:p>
-          <a:p>
-            <a:pPr>
-              <a:spcAft>
-                <a:spcPts val="600"/>
-              </a:spcAft>
-              <a:defRPr b="1" sz="1150">
-                <a:solidFill>
-                  <a:srgbClr val="FF796C"/>
-                </a:solidFill>
-              </a:defRPr>
-            </a:pPr>
-            <a:r>
-              <a:t>• Cross-Platform Mobile Apps (iOS &amp; Android): </a:t>
-            </a:r>
-            <a:r>
-              <a:rPr b="0">
-                <a:solidFill>
-                  <a:srgbClr val="F5F0E8"/>
-                </a:solidFill>
-              </a:rPr>
-              <a:t>Native builds using Capacitor / Flutter bringing offline sync, lock-screen controls, and listening rooms to smartphones.</a:t>
-            </a:r>
-          </a:p>
-          <a:p>
-            <a:pPr>
-              <a:spcAft>
-                <a:spcPts val="600"/>
-              </a:spcAft>
-              <a:defRPr b="1" sz="1150">
-                <a:solidFill>
-                  <a:srgbClr val="FF796C"/>
-                </a:solidFill>
-              </a:defRPr>
-            </a:pPr>
-            <a:r>
-              <a:t>• Native Windows Desktop Executable (.exe): </a:t>
-            </a:r>
-            <a:r>
-              <a:rPr b="0">
-                <a:solidFill>
-                  <a:srgbClr val="F5F0E8"/>
-                </a:solidFill>
-              </a:rPr>
-              <a:t>Packaged desktop client with low-latency audio driver, global media hotkeys, and system tray minimization.</a:t>
-            </a:r>
-          </a:p>
-          <a:p>
-            <a:pPr>
-              <a:spcAft>
-                <a:spcPts val="600"/>
-              </a:spcAft>
-              <a:defRPr b="1" sz="1150">
-                <a:solidFill>
-                  <a:srgbClr val="FF796C"/>
-                </a:solidFill>
-              </a:defRPr>
-            </a:pPr>
-            <a:r>
-              <a:t>• High-Availability Cloud Edge Delivery: </a:t>
-            </a:r>
-            <a:r>
-              <a:rPr b="0">
-                <a:solidFill>
-                  <a:srgbClr val="F5F0E8"/>
-                </a:solidFill>
-              </a:rPr>
-              <a:t>Multi-region edge distribution for zero-latency audio streaming with automated elastic database scaling.</a:t>
-            </a:r>
-          </a:p>
-          <a:p>
-            <a:pPr>
-              <a:spcAft>
-                <a:spcPts val="600"/>
-              </a:spcAft>
-              <a:defRPr b="1" sz="1150">
-                <a:solidFill>
-                  <a:srgbClr val="FF796C"/>
-                </a:solidFill>
-              </a:defRPr>
-            </a:pPr>
-            <a:r>
-              <a:t>• WebAssembly DSP Audio Visualizer: </a:t>
-            </a:r>
-            <a:r>
-              <a:rPr b="0">
-                <a:solidFill>
-                  <a:srgbClr val="F5F0E8"/>
-                </a:solidFill>
-              </a:rPr>
-              <a:t>In-browser Fast Fourier Transform (FFT) for direct audio frequency spectrum analysis and reactive waveforms.</a:t>
+                  <a:srgbClr val="FF5C58"/>
+                </a:solidFill>
+              </a:defRPr>
+            </a:pPr>
+            <a:r>
+              <a:t>2. Luxury Spotlight &amp; Border Beam Auth</a:t>
+            </a:r>
+          </a:p>
+          <a:p>
+            <a:pPr>
+              <a:spcAft>
+                <a:spcPts val="800"/>
+              </a:spcAft>
+              <a:defRPr sz="1200">
+                <a:solidFill>
+                  <a:srgbClr val="F7F6FB"/>
+                </a:solidFill>
+              </a:defRPr>
+            </a:pPr>
+            <a:r>
+              <a:t>• React Bits Spotlight Card: Real-time cursor coordinates track across card, projecting a dynamic radial light beam.</a:t>
+            </a:r>
+          </a:p>
+          <a:p>
+            <a:pPr>
+              <a:spcAft>
+                <a:spcPts val="800"/>
+              </a:spcAft>
+              <a:defRPr sz="1200">
+                <a:solidFill>
+                  <a:srgbClr val="F7F6FB"/>
+                </a:solidFill>
+              </a:defRPr>
+            </a:pPr>
+            <a:r>
+              <a:t>• Magic UI Border Beam: Rotating conic gradient travels continuously along 1px rounded border without lagging.</a:t>
+            </a:r>
+          </a:p>
+          <a:p>
+            <a:pPr>
+              <a:spcAft>
+                <a:spcPts val="800"/>
+              </a:spcAft>
+              <a:defRPr sz="1200">
+                <a:solidFill>
+                  <a:srgbClr val="F7F6FB"/>
+                </a:solidFill>
+              </a:defRPr>
+            </a:pPr>
+            <a:r>
+              <a:t>• Fluid Segmented Switcher: Tactile sliding pill transitions smoothly between Sign In and Create Account.</a:t>
+            </a:r>
+          </a:p>
+          <a:p>
+            <a:pPr>
+              <a:spcAft>
+                <a:spcPts val="800"/>
+              </a:spcAft>
+              <a:defRPr sz="1200">
+                <a:solidFill>
+                  <a:srgbClr val="F7F6FB"/>
+                </a:solidFill>
+              </a:defRPr>
+            </a:pPr>
+            <a:r>
+              <a:t>• Live Strength &amp; Equalizer: Real-time 4-stage password strength visualizer and audio equalizer loader (||||) on submit.</a:t>
+            </a:r>
+          </a:p>
+          <a:p>
+            <a:pPr>
+              <a:spcAft>
+                <a:spcPts val="800"/>
+              </a:spcAft>
+              <a:defRPr sz="1200">
+                <a:solidFill>
+                  <a:srgbClr val="F7F6FB"/>
+                </a:solidFill>
+              </a:defRPr>
+            </a:pPr>
+            <a:r>
+              <a:t>• Guest Bypass &amp; Replay: Frictionless 'Explore as Guest' access and home page 'Intro Animation' replay pill.</a:t>
             </a:r>
           </a:p>
         </p:txBody>
@@ -4316,7 +4160,7 @@
             <a:avLst/>
           </a:prstGeom>
           <a:solidFill>
-            <a:srgbClr val="111019"/>
+            <a:srgbClr val="0A0912"/>
           </a:solidFill>
           <a:ln>
             <a:noFill/>
@@ -4344,6 +4188,567 @@
           </a:p>
         </p:txBody>
       </p:sp>
+      <p:pic>
+        <p:nvPicPr>
+          <p:cNvPr id="3" name="Picture 2" descr="logo-mark.png"/>
+          <p:cNvPicPr>
+            <a:picLocks noChangeAspect="1"/>
+          </p:cNvPicPr>
+          <p:nvPr/>
+        </p:nvPicPr>
+        <p:blipFill>
+          <a:blip r:embed="rId2"/>
+          <a:stretch>
+            <a:fillRect/>
+          </a:stretch>
+        </p:blipFill>
+        <p:spPr>
+          <a:xfrm>
+            <a:off x="10972800" y="365760"/>
+            <a:ext cx="594360" cy="594360"/>
+          </a:xfrm>
+          <a:prstGeom prst="rect">
+            <a:avLst/>
+          </a:prstGeom>
+        </p:spPr>
+      </p:pic>
+      <p:sp>
+        <p:nvSpPr>
+          <p:cNvPr id="4" name="TextBox 3"/>
+          <p:cNvSpPr txBox="1"/>
+          <p:nvPr/>
+        </p:nvSpPr>
+        <p:spPr>
+          <a:xfrm>
+            <a:off x="731520" y="411480"/>
+            <a:ext cx="9144000" cy="320040"/>
+          </a:xfrm>
+          <a:prstGeom prst="rect">
+            <a:avLst/>
+          </a:prstGeom>
+          <a:noFill/>
+        </p:spPr>
+        <p:txBody>
+          <a:bodyPr wrap="square">
+            <a:spAutoFit/>
+          </a:bodyPr>
+          <a:lstStyle/>
+          <a:p>
+            <a:pPr>
+              <a:defRPr sz="1000" b="1">
+                <a:solidFill>
+                  <a:srgbClr val="784BFF"/>
+                </a:solidFill>
+              </a:defRPr>
+            </a:pPr>
+            <a:r>
+              <a:t>TECH VEDHU INTERNSHIP CAPSTONE</a:t>
+            </a:r>
+          </a:p>
+        </p:txBody>
+      </p:sp>
+      <p:sp>
+        <p:nvSpPr>
+          <p:cNvPr id="5" name="TextBox 4"/>
+          <p:cNvSpPr txBox="1"/>
+          <p:nvPr/>
+        </p:nvSpPr>
+        <p:spPr>
+          <a:xfrm>
+            <a:off x="731520" y="731520"/>
+            <a:ext cx="10058400" cy="731520"/>
+          </a:xfrm>
+          <a:prstGeom prst="rect">
+            <a:avLst/>
+          </a:prstGeom>
+          <a:noFill/>
+        </p:spPr>
+        <p:txBody>
+          <a:bodyPr wrap="square">
+            <a:spAutoFit/>
+          </a:bodyPr>
+          <a:lstStyle/>
+          <a:p>
+            <a:pPr>
+              <a:defRPr sz="2600" b="1">
+                <a:solidFill>
+                  <a:srgbClr val="F7F6FB"/>
+                </a:solidFill>
+              </a:defRPr>
+            </a:pPr>
+            <a:r>
+              <a:t>Verification Pass Rate &amp; Platform Roadmap</a:t>
+            </a:r>
+          </a:p>
+        </p:txBody>
+      </p:sp>
+      <p:sp>
+        <p:nvSpPr>
+          <p:cNvPr id="6" name="Rounded Rectangle 5"/>
+          <p:cNvSpPr/>
+          <p:nvPr/>
+        </p:nvSpPr>
+        <p:spPr>
+          <a:xfrm>
+            <a:off x="731520" y="1645920"/>
+            <a:ext cx="5120640" cy="4389120"/>
+          </a:xfrm>
+          <a:prstGeom prst="roundRect">
+            <a:avLst/>
+          </a:prstGeom>
+          <a:solidFill>
+            <a:srgbClr val="12101B"/>
+          </a:solidFill>
+          <a:ln>
+            <a:solidFill>
+              <a:srgbClr val="784BFF"/>
+            </a:solidFill>
+          </a:ln>
+        </p:spPr>
+        <p:style>
+          <a:lnRef idx="1">
+            <a:schemeClr val="accent1"/>
+          </a:lnRef>
+          <a:fillRef idx="3">
+            <a:schemeClr val="accent1"/>
+          </a:fillRef>
+          <a:effectRef idx="2">
+            <a:schemeClr val="accent1"/>
+          </a:effectRef>
+          <a:fontRef idx="minor">
+            <a:schemeClr val="lt1"/>
+          </a:fontRef>
+        </p:style>
+        <p:txBody>
+          <a:bodyPr rtlCol="0" anchor="ctr" wrap="square"/>
+          <a:lstStyle/>
+          <a:p>
+            <a:pPr algn="ctr">
+              <a:spcAft>
+                <a:spcPts val="1000"/>
+              </a:spcAft>
+              <a:defRPr b="1" sz="1600">
+                <a:solidFill>
+                  <a:srgbClr val="784BFF"/>
+                </a:solidFill>
+              </a:defRPr>
+            </a:pPr>
+            <a:r>
+              <a:t>100% Verification Pass Rate</a:t>
+            </a:r>
+          </a:p>
+          <a:p>
+            <a:pPr>
+              <a:defRPr sz="1100">
+                <a:solidFill>
+                  <a:srgbClr val="F7F6FB"/>
+                </a:solidFill>
+              </a:defRPr>
+            </a:pPr>
+            <a:r>
+              <a:t>✔ TC-01: PostgreSQL Cluster Initialization — </a:t>
+            </a:r>
+            <a:r>
+              <a:rPr b="1">
+                <a:solidFill>
+                  <a:srgbClr val="4ADE80"/>
+                </a:solidFill>
+              </a:rPr>
+              <a:t>PASS</a:t>
+            </a:r>
+          </a:p>
+          <a:p>
+            <a:pPr>
+              <a:defRPr sz="1100">
+                <a:solidFill>
+                  <a:srgbClr val="F7F6FB"/>
+                </a:solidFill>
+              </a:defRPr>
+            </a:pPr>
+            <a:r>
+              <a:t>✔ TC-02: Go Backend Auto-Migration (9 tables) — </a:t>
+            </a:r>
+            <a:r>
+              <a:rPr b="1">
+                <a:solidFill>
+                  <a:srgbClr val="4ADE80"/>
+                </a:solidFill>
+              </a:rPr>
+              <a:t>PASS</a:t>
+            </a:r>
+          </a:p>
+          <a:p>
+            <a:pPr>
+              <a:defRPr sz="1100">
+                <a:solidFill>
+                  <a:srgbClr val="F7F6FB"/>
+                </a:solidFill>
+              </a:defRPr>
+            </a:pPr>
+            <a:r>
+              <a:t>✔ TC-03: Catalog Seed (110 full-length tracks) — </a:t>
+            </a:r>
+            <a:r>
+              <a:rPr b="1">
+                <a:solidFill>
+                  <a:srgbClr val="4ADE80"/>
+                </a:solidFill>
+              </a:rPr>
+              <a:t>PASS</a:t>
+            </a:r>
+          </a:p>
+          <a:p>
+            <a:pPr>
+              <a:defRPr sz="1100">
+                <a:solidFill>
+                  <a:srgbClr val="F7F6FB"/>
+                </a:solidFill>
+              </a:defRPr>
+            </a:pPr>
+            <a:r>
+              <a:t>✔ TC-04: User Registration &amp; Bcrypt Hashing — </a:t>
+            </a:r>
+            <a:r>
+              <a:rPr b="1">
+                <a:solidFill>
+                  <a:srgbClr val="4ADE80"/>
+                </a:solidFill>
+              </a:rPr>
+              <a:t>PASS</a:t>
+            </a:r>
+          </a:p>
+          <a:p>
+            <a:pPr>
+              <a:defRPr sz="1100">
+                <a:solidFill>
+                  <a:srgbClr val="F7F6FB"/>
+                </a:solidFill>
+              </a:defRPr>
+            </a:pPr>
+            <a:r>
+              <a:t>✔ TC-05: JWT Session Cookie Authentication — </a:t>
+            </a:r>
+            <a:r>
+              <a:rPr b="1">
+                <a:solidFill>
+                  <a:srgbClr val="4ADE80"/>
+                </a:solidFill>
+              </a:rPr>
+              <a:t>PASS</a:t>
+            </a:r>
+          </a:p>
+          <a:p>
+            <a:pPr>
+              <a:defRPr sz="1100">
+                <a:solidFill>
+                  <a:srgbClr val="F7F6FB"/>
+                </a:solidFill>
+              </a:defRPr>
+            </a:pPr>
+            <a:r>
+              <a:t>✔ TC-06: Real Audio Range Seek &amp; Stream Redirect — </a:t>
+            </a:r>
+            <a:r>
+              <a:rPr b="1">
+                <a:solidFill>
+                  <a:srgbClr val="4ADE80"/>
+                </a:solidFill>
+              </a:rPr>
+              <a:t>PASS</a:t>
+            </a:r>
+          </a:p>
+          <a:p>
+            <a:pPr>
+              <a:defRPr sz="1100">
+                <a:solidFill>
+                  <a:srgbClr val="F7F6FB"/>
+                </a:solidFill>
+              </a:defRPr>
+            </a:pPr>
+            <a:r>
+              <a:t>✔ TC-07: Anti-Algorithm Comfort Inversion — </a:t>
+            </a:r>
+            <a:r>
+              <a:rPr b="1">
+                <a:solidFill>
+                  <a:srgbClr val="4ADE80"/>
+                </a:solidFill>
+              </a:rPr>
+              <a:t>PASS</a:t>
+            </a:r>
+          </a:p>
+          <a:p>
+            <a:pPr>
+              <a:defRPr sz="1100">
+                <a:solidFill>
+                  <a:srgbClr val="F7F6FB"/>
+                </a:solidFill>
+              </a:defRPr>
+            </a:pPr>
+            <a:r>
+              <a:t>✔ TC-08: Trace Journey Tree Construction — </a:t>
+            </a:r>
+            <a:r>
+              <a:rPr b="1">
+                <a:solidFill>
+                  <a:srgbClr val="4ADE80"/>
+                </a:solidFill>
+              </a:rPr>
+              <a:t>PASS</a:t>
+            </a:r>
+          </a:p>
+          <a:p>
+            <a:pPr>
+              <a:defRPr sz="1100">
+                <a:solidFill>
+                  <a:srgbClr val="F7F6FB"/>
+                </a:solidFill>
+              </a:defRPr>
+            </a:pPr>
+            <a:r>
+              <a:t>✔ TC-09: IndexedDB Offline Blob Cache — </a:t>
+            </a:r>
+            <a:r>
+              <a:rPr b="1">
+                <a:solidFill>
+                  <a:srgbClr val="4ADE80"/>
+                </a:solidFill>
+              </a:rPr>
+              <a:t>PASS</a:t>
+            </a:r>
+          </a:p>
+          <a:p>
+            <a:pPr>
+              <a:defRPr sz="1100">
+                <a:solidFill>
+                  <a:srgbClr val="F7F6FB"/>
+                </a:solidFill>
+              </a:defRPr>
+            </a:pPr>
+            <a:r>
+              <a:t>✔ TC-10: Frontend Production Build &amp; SSR Routing — </a:t>
+            </a:r>
+            <a:r>
+              <a:rPr b="1">
+                <a:solidFill>
+                  <a:srgbClr val="4ADE80"/>
+                </a:solidFill>
+              </a:rPr>
+              <a:t>PASS</a:t>
+            </a:r>
+          </a:p>
+        </p:txBody>
+      </p:sp>
+      <p:sp>
+        <p:nvSpPr>
+          <p:cNvPr id="7" name="Rounded Rectangle 6"/>
+          <p:cNvSpPr/>
+          <p:nvPr/>
+        </p:nvSpPr>
+        <p:spPr>
+          <a:xfrm>
+            <a:off x="6309360" y="1645920"/>
+            <a:ext cx="5120640" cy="4389120"/>
+          </a:xfrm>
+          <a:prstGeom prst="roundRect">
+            <a:avLst/>
+          </a:prstGeom>
+          <a:solidFill>
+            <a:srgbClr val="12101B"/>
+          </a:solidFill>
+          <a:ln>
+            <a:solidFill>
+              <a:srgbClr val="FF5C58"/>
+            </a:solidFill>
+          </a:ln>
+        </p:spPr>
+        <p:style>
+          <a:lnRef idx="1">
+            <a:schemeClr val="accent1"/>
+          </a:lnRef>
+          <a:fillRef idx="3">
+            <a:schemeClr val="accent1"/>
+          </a:fillRef>
+          <a:effectRef idx="2">
+            <a:schemeClr val="accent1"/>
+          </a:effectRef>
+          <a:fontRef idx="minor">
+            <a:schemeClr val="lt1"/>
+          </a:fontRef>
+        </p:style>
+        <p:txBody>
+          <a:bodyPr rtlCol="0" anchor="ctr" wrap="square"/>
+          <a:lstStyle/>
+          <a:p>
+            <a:pPr algn="ctr">
+              <a:spcAft>
+                <a:spcPts val="1000"/>
+              </a:spcAft>
+              <a:defRPr b="1" sz="1600">
+                <a:solidFill>
+                  <a:srgbClr val="FF5C58"/>
+                </a:solidFill>
+              </a:defRPr>
+            </a:pPr>
+            <a:r>
+              <a:t>Future Platform Expansion Roadmap</a:t>
+            </a:r>
+          </a:p>
+          <a:p>
+            <a:pPr>
+              <a:spcAft>
+                <a:spcPts val="600"/>
+              </a:spcAft>
+              <a:defRPr b="1" sz="1150">
+                <a:solidFill>
+                  <a:srgbClr val="FF5C58"/>
+                </a:solidFill>
+              </a:defRPr>
+            </a:pPr>
+            <a:r>
+              <a:t>• Cross-Platform Mobile Apps (iOS &amp; Android): </a:t>
+            </a:r>
+            <a:r>
+              <a:rPr b="0">
+                <a:solidFill>
+                  <a:srgbClr val="F7F6FB"/>
+                </a:solidFill>
+              </a:rPr>
+              <a:t>Native builds using Capacitor / Flutter bringing offline sync, lock-screen controls, and listening rooms to smartphones.</a:t>
+            </a:r>
+          </a:p>
+          <a:p>
+            <a:pPr>
+              <a:spcAft>
+                <a:spcPts val="600"/>
+              </a:spcAft>
+              <a:defRPr b="1" sz="1150">
+                <a:solidFill>
+                  <a:srgbClr val="FF5C58"/>
+                </a:solidFill>
+              </a:defRPr>
+            </a:pPr>
+            <a:r>
+              <a:t>• Native Windows Desktop Executable (.exe): </a:t>
+            </a:r>
+            <a:r>
+              <a:rPr b="0">
+                <a:solidFill>
+                  <a:srgbClr val="F7F6FB"/>
+                </a:solidFill>
+              </a:rPr>
+              <a:t>Packaged desktop client with low-latency audio driver, global media hotkeys, and system tray minimization.</a:t>
+            </a:r>
+          </a:p>
+          <a:p>
+            <a:pPr>
+              <a:spcAft>
+                <a:spcPts val="600"/>
+              </a:spcAft>
+              <a:defRPr b="1" sz="1150">
+                <a:solidFill>
+                  <a:srgbClr val="FF5C58"/>
+                </a:solidFill>
+              </a:defRPr>
+            </a:pPr>
+            <a:r>
+              <a:t>• High-Availability Cloud Edge Delivery: </a:t>
+            </a:r>
+            <a:r>
+              <a:rPr b="0">
+                <a:solidFill>
+                  <a:srgbClr val="F7F6FB"/>
+                </a:solidFill>
+              </a:rPr>
+              <a:t>Multi-region edge distribution for zero-latency audio streaming with automated elastic database scaling.</a:t>
+            </a:r>
+          </a:p>
+          <a:p>
+            <a:pPr>
+              <a:spcAft>
+                <a:spcPts val="600"/>
+              </a:spcAft>
+              <a:defRPr b="1" sz="1150">
+                <a:solidFill>
+                  <a:srgbClr val="FF5C58"/>
+                </a:solidFill>
+              </a:defRPr>
+            </a:pPr>
+            <a:r>
+              <a:t>• WebAssembly DSP Audio Visualizer: </a:t>
+            </a:r>
+            <a:r>
+              <a:rPr b="0">
+                <a:solidFill>
+                  <a:srgbClr val="F7F6FB"/>
+                </a:solidFill>
+              </a:rPr>
+              <a:t>In-browser Fast Fourier Transform (FFT) for direct audio frequency spectrum analysis and reactive waveforms.</a:t>
+            </a:r>
+          </a:p>
+        </p:txBody>
+      </p:sp>
+    </p:spTree>
+  </p:cSld>
+  <p:clrMapOvr>
+    <a:masterClrMapping/>
+  </p:clrMapOvr>
+</p:sld>
+</file>
+
+<file path=ppt/slides/slide13.xml><?xml version="1.0" encoding="utf-8"?>
+<p:sld xmlns:a="http://schemas.openxmlformats.org/drawingml/2006/main" xmlns:p="http://schemas.openxmlformats.org/presentationml/2006/main" xmlns:r="http://schemas.openxmlformats.org/officeDocument/2006/relationships">
+  <p:cSld>
+    <p:spTree>
+      <p:nvGrpSpPr>
+        <p:cNvPr id="1" name=""/>
+        <p:cNvGrpSpPr/>
+        <p:nvPr/>
+      </p:nvGrpSpPr>
+      <p:grpSpPr/>
+      <p:sp>
+        <p:nvSpPr>
+          <p:cNvPr id="2" name="Rectangle 1"/>
+          <p:cNvSpPr/>
+          <p:nvPr/>
+        </p:nvSpPr>
+        <p:spPr>
+          <a:xfrm>
+            <a:off x="0" y="0"/>
+            <a:ext cx="12191695" cy="6858000"/>
+          </a:xfrm>
+          <a:prstGeom prst="rect">
+            <a:avLst/>
+          </a:prstGeom>
+          <a:solidFill>
+            <a:srgbClr val="0A0912"/>
+          </a:solidFill>
+          <a:ln>
+            <a:noFill/>
+          </a:ln>
+        </p:spPr>
+        <p:style>
+          <a:lnRef idx="1">
+            <a:schemeClr val="accent1"/>
+          </a:lnRef>
+          <a:fillRef idx="3">
+            <a:schemeClr val="accent1"/>
+          </a:fillRef>
+          <a:effectRef idx="2">
+            <a:schemeClr val="accent1"/>
+          </a:effectRef>
+          <a:fontRef idx="minor">
+            <a:schemeClr val="lt1"/>
+          </a:fontRef>
+        </p:style>
+        <p:txBody>
+          <a:bodyPr rtlCol="0" anchor="ctr"/>
+          <a:lstStyle/>
+          <a:p>
+            <a:pPr algn="ctr"/>
+          </a:p>
+        </p:txBody>
+      </p:sp>
       <p:sp>
         <p:nvSpPr>
           <p:cNvPr id="3" name="Rounded Rectangle 2"/>
@@ -4359,11 +4764,11 @@
             <a:avLst/>
           </a:prstGeom>
           <a:solidFill>
-            <a:srgbClr val="1B1827"/>
+            <a:srgbClr val="12101B"/>
           </a:solidFill>
           <a:ln>
             <a:solidFill>
-              <a:srgbClr val="B19AFF"/>
+              <a:srgbClr val="784BFF"/>
             </a:solidFill>
           </a:ln>
         </p:spPr>
@@ -4441,7 +4846,7 @@
               </a:spcAft>
               <a:defRPr sz="4400" b="1">
                 <a:solidFill>
-                  <a:srgbClr val="F5F0E8"/>
+                  <a:srgbClr val="F7F6FB"/>
                 </a:solidFill>
               </a:defRPr>
             </a:pPr>
@@ -4456,7 +4861,7 @@
               </a:spcAft>
               <a:defRPr sz="1600" b="1">
                 <a:solidFill>
-                  <a:srgbClr val="FF796C"/>
+                  <a:srgbClr val="FF5C58"/>
                 </a:solidFill>
               </a:defRPr>
             </a:pPr>
@@ -4471,7 +4876,7 @@
               </a:spcAft>
               <a:defRPr sz="2000" b="1">
                 <a:solidFill>
-                  <a:srgbClr val="B19AFF"/>
+                  <a:srgbClr val="784BFF"/>
                 </a:solidFill>
               </a:defRPr>
             </a:pPr>
@@ -4486,7 +4891,7 @@
               </a:spcAft>
               <a:defRPr sz="1200">
                 <a:solidFill>
-                  <a:srgbClr val="F5F0E8"/>
+                  <a:srgbClr val="F7F6FB"/>
                 </a:solidFill>
               </a:defRPr>
             </a:pPr>
@@ -4501,7 +4906,7 @@
               </a:spcAft>
               <a:defRPr sz="1200">
                 <a:solidFill>
-                  <a:srgbClr val="AAA4BB"/>
+                  <a:srgbClr val="9D96B2"/>
                 </a:solidFill>
               </a:defRPr>
             </a:pPr>
@@ -4516,7 +4921,7 @@
               </a:spcAft>
               <a:defRPr b="1" sz="1100">
                 <a:solidFill>
-                  <a:srgbClr val="FF796C"/>
+                  <a:srgbClr val="FF5C58"/>
                 </a:solidFill>
               </a:defRPr>
             </a:pPr>
@@ -4526,7 +4931,7 @@
             <a:r>
               <a:rPr b="0">
                 <a:solidFill>
-                  <a:srgbClr val="F5F0E8"/>
+                  <a:srgbClr val="F7F6FB"/>
                 </a:solidFill>
               </a:rPr>
               <a:t>https://diverge-music.vercel.app</a:t>
@@ -4539,7 +4944,7 @@
               </a:spcAft>
               <a:defRPr b="1" sz="1100">
                 <a:solidFill>
-                  <a:srgbClr val="FF796C"/>
+                  <a:srgbClr val="FF5C58"/>
                 </a:solidFill>
               </a:defRPr>
             </a:pPr>
@@ -4549,7 +4954,7 @@
             <a:r>
               <a:rPr b="0">
                 <a:solidFill>
-                  <a:srgbClr val="F5F0E8"/>
+                  <a:srgbClr val="F7F6FB"/>
                 </a:solidFill>
               </a:rPr>
               <a:t>+91 6382546285</a:t>
@@ -4562,7 +4967,7 @@
               </a:spcAft>
               <a:defRPr b="1" sz="1100">
                 <a:solidFill>
-                  <a:srgbClr val="FF796C"/>
+                  <a:srgbClr val="FF5C58"/>
                 </a:solidFill>
               </a:defRPr>
             </a:pPr>
@@ -4572,7 +4977,7 @@
             <a:r>
               <a:rPr b="0">
                 <a:solidFill>
-                  <a:srgbClr val="F5F0E8"/>
+                  <a:srgbClr val="F7F6FB"/>
                 </a:solidFill>
               </a:rPr>
               <a:t>dharshan.vreddy2819@gmail.com</a:t>
@@ -4585,7 +4990,7 @@
               </a:spcAft>
               <a:defRPr b="1" sz="1100">
                 <a:solidFill>
-                  <a:srgbClr val="FF796C"/>
+                  <a:srgbClr val="FF5C58"/>
                 </a:solidFill>
               </a:defRPr>
             </a:pPr>
@@ -4595,7 +5000,7 @@
             <a:r>
               <a:rPr b="0">
                 <a:solidFill>
-                  <a:srgbClr val="F5F0E8"/>
+                  <a:srgbClr val="F7F6FB"/>
                 </a:solidFill>
               </a:rPr>
               <a:t>https://dharshanvportfolio.netlify.app/</a:t>
@@ -4608,7 +5013,7 @@
               </a:spcAft>
               <a:defRPr b="1" sz="1100">
                 <a:solidFill>
-                  <a:srgbClr val="FF796C"/>
+                  <a:srgbClr val="FF5C58"/>
                 </a:solidFill>
               </a:defRPr>
             </a:pPr>
@@ -4618,7 +5023,7 @@
             <a:r>
               <a:rPr b="0">
                 <a:solidFill>
-                  <a:srgbClr val="F5F0E8"/>
+                  <a:srgbClr val="F7F6FB"/>
                 </a:solidFill>
               </a:rPr>
               <a:t>https://github.com/Dharsh606</a:t>
@@ -4631,7 +5036,7 @@
               </a:spcAft>
               <a:defRPr b="1" sz="1100">
                 <a:solidFill>
-                  <a:srgbClr val="FF796C"/>
+                  <a:srgbClr val="FF5C58"/>
                 </a:solidFill>
               </a:defRPr>
             </a:pPr>
@@ -4641,7 +5046,7 @@
             <a:r>
               <a:rPr b="0">
                 <a:solidFill>
-                  <a:srgbClr val="F5F0E8"/>
+                  <a:srgbClr val="F7F6FB"/>
                 </a:solidFill>
               </a:rPr>
               <a:t>https://github.com/Dharsh606/DIVERGE</a:t>
@@ -4654,7 +5059,7 @@
               </a:spcAft>
               <a:defRPr b="1" sz="1100">
                 <a:solidFill>
-                  <a:srgbClr val="FF796C"/>
+                  <a:srgbClr val="FF5C58"/>
                 </a:solidFill>
               </a:defRPr>
             </a:pPr>
@@ -4664,7 +5069,7 @@
             <a:r>
               <a:rPr b="0">
                 <a:solidFill>
-                  <a:srgbClr val="F5F0E8"/>
+                  <a:srgbClr val="F7F6FB"/>
                 </a:solidFill>
               </a:rPr>
               <a:t>https://www.linkedin.com/in/dharshanvreddy</a:t>
@@ -4705,7 +5110,7 @@
             <a:avLst/>
           </a:prstGeom>
           <a:solidFill>
-            <a:srgbClr val="111019"/>
+            <a:srgbClr val="0A0912"/>
           </a:solidFill>
           <a:ln>
             <a:noFill/>
@@ -4782,7 +5187,7 @@
             <a:pPr>
               <a:defRPr sz="1000" b="1">
                 <a:solidFill>
-                  <a:srgbClr val="B19AFF"/>
+                  <a:srgbClr val="784BFF"/>
                 </a:solidFill>
               </a:defRPr>
             </a:pPr>
@@ -4817,7 +5222,7 @@
             <a:pPr>
               <a:defRPr sz="2600" b="1">
                 <a:solidFill>
-                  <a:srgbClr val="F5F0E8"/>
+                  <a:srgbClr val="F7F6FB"/>
                 </a:solidFill>
               </a:defRPr>
             </a:pPr>
@@ -4842,11 +5247,11 @@
             <a:avLst/>
           </a:prstGeom>
           <a:solidFill>
-            <a:srgbClr val="1B1827"/>
+            <a:srgbClr val="12101B"/>
           </a:solidFill>
           <a:ln>
             <a:solidFill>
-              <a:srgbClr val="B19AFF"/>
+              <a:srgbClr val="784BFF"/>
             </a:solidFill>
           </a:ln>
         </p:spPr>
@@ -4874,7 +5279,7 @@
               </a:spcAft>
               <a:defRPr b="1" sz="1800">
                 <a:solidFill>
-                  <a:srgbClr val="B19AFF"/>
+                  <a:srgbClr val="784BFF"/>
                 </a:solidFill>
               </a:defRPr>
             </a:pPr>
@@ -4889,7 +5294,7 @@
               </a:spcAft>
               <a:defRPr sz="1250">
                 <a:solidFill>
-                  <a:srgbClr val="F5F0E8"/>
+                  <a:srgbClr val="F7F6FB"/>
                 </a:solidFill>
               </a:defRPr>
             </a:pPr>
@@ -4904,7 +5309,7 @@
               </a:spcAft>
               <a:defRPr sz="1250">
                 <a:solidFill>
-                  <a:srgbClr val="F5F0E8"/>
+                  <a:srgbClr val="F7F6FB"/>
                 </a:solidFill>
               </a:defRPr>
             </a:pPr>
@@ -4919,7 +5324,7 @@
               </a:spcAft>
               <a:defRPr sz="1250">
                 <a:solidFill>
-                  <a:srgbClr val="F5F0E8"/>
+                  <a:srgbClr val="F7F6FB"/>
                 </a:solidFill>
               </a:defRPr>
             </a:pPr>
@@ -4934,7 +5339,7 @@
               </a:spcAft>
               <a:defRPr sz="1250">
                 <a:solidFill>
-                  <a:srgbClr val="F5F0E8"/>
+                  <a:srgbClr val="F7F6FB"/>
                 </a:solidFill>
               </a:defRPr>
             </a:pPr>
@@ -4949,7 +5354,7 @@
               </a:spcAft>
               <a:defRPr sz="1250">
                 <a:solidFill>
-                  <a:srgbClr val="F5F0E8"/>
+                  <a:srgbClr val="F7F6FB"/>
                 </a:solidFill>
               </a:defRPr>
             </a:pPr>
@@ -4974,11 +5379,11 @@
             <a:avLst/>
           </a:prstGeom>
           <a:solidFill>
-            <a:srgbClr val="1B1827"/>
+            <a:srgbClr val="12101B"/>
           </a:solidFill>
           <a:ln>
             <a:solidFill>
-              <a:srgbClr val="FF796C"/>
+              <a:srgbClr val="FF5C58"/>
             </a:solidFill>
           </a:ln>
         </p:spPr>
@@ -5006,7 +5411,7 @@
               </a:spcAft>
               <a:defRPr b="1" sz="1800">
                 <a:solidFill>
-                  <a:srgbClr val="FF796C"/>
+                  <a:srgbClr val="FF5C58"/>
                 </a:solidFill>
               </a:defRPr>
             </a:pPr>
@@ -5021,7 +5426,7 @@
               </a:spcAft>
               <a:defRPr sz="1250">
                 <a:solidFill>
-                  <a:srgbClr val="F5F0E8"/>
+                  <a:srgbClr val="F7F6FB"/>
                 </a:solidFill>
               </a:defRPr>
             </a:pPr>
@@ -5036,7 +5441,7 @@
               </a:spcAft>
               <a:defRPr sz="1250">
                 <a:solidFill>
-                  <a:srgbClr val="F5F0E8"/>
+                  <a:srgbClr val="F7F6FB"/>
                 </a:solidFill>
               </a:defRPr>
             </a:pPr>
@@ -5051,7 +5456,7 @@
               </a:spcAft>
               <a:defRPr sz="1250">
                 <a:solidFill>
-                  <a:srgbClr val="F5F0E8"/>
+                  <a:srgbClr val="F7F6FB"/>
                 </a:solidFill>
               </a:defRPr>
             </a:pPr>
@@ -5066,7 +5471,7 @@
               </a:spcAft>
               <a:defRPr sz="1250">
                 <a:solidFill>
-                  <a:srgbClr val="F5F0E8"/>
+                  <a:srgbClr val="F7F6FB"/>
                 </a:solidFill>
               </a:defRPr>
             </a:pPr>
@@ -5081,7 +5486,7 @@
               </a:spcAft>
               <a:defRPr sz="1250">
                 <a:solidFill>
-                  <a:srgbClr val="F5F0E8"/>
+                  <a:srgbClr val="F7F6FB"/>
                 </a:solidFill>
               </a:defRPr>
             </a:pPr>
@@ -5124,7 +5529,7 @@
             <a:avLst/>
           </a:prstGeom>
           <a:solidFill>
-            <a:srgbClr val="111019"/>
+            <a:srgbClr val="0A0912"/>
           </a:solidFill>
           <a:ln>
             <a:noFill/>
@@ -5201,7 +5606,7 @@
             <a:pPr>
               <a:defRPr sz="1000" b="1">
                 <a:solidFill>
-                  <a:srgbClr val="B19AFF"/>
+                  <a:srgbClr val="784BFF"/>
                 </a:solidFill>
               </a:defRPr>
             </a:pPr>
@@ -5236,7 +5641,7 @@
             <a:pPr>
               <a:defRPr sz="2600" b="1">
                 <a:solidFill>
-                  <a:srgbClr val="F5F0E8"/>
+                  <a:srgbClr val="F7F6FB"/>
                 </a:solidFill>
               </a:defRPr>
             </a:pPr>
@@ -5261,11 +5666,11 @@
             <a:avLst/>
           </a:prstGeom>
           <a:solidFill>
-            <a:srgbClr val="1B1827"/>
+            <a:srgbClr val="12101B"/>
           </a:solidFill>
           <a:ln>
             <a:solidFill>
-              <a:srgbClr val="FF796C"/>
+              <a:srgbClr val="FF5C58"/>
             </a:solidFill>
           </a:ln>
         </p:spPr>
@@ -5293,7 +5698,7 @@
               </a:spcAft>
               <a:defRPr b="1" sz="1600">
                 <a:solidFill>
-                  <a:srgbClr val="FF796C"/>
+                  <a:srgbClr val="FF5C58"/>
                 </a:solidFill>
               </a:defRPr>
             </a:pPr>
@@ -5305,7 +5710,7 @@
             <a:pPr>
               <a:defRPr sz="1300">
                 <a:solidFill>
-                  <a:srgbClr val="AAA4BB"/>
+                  <a:srgbClr val="9D96B2"/>
                 </a:solidFill>
               </a:defRPr>
             </a:pPr>
@@ -5330,11 +5735,11 @@
             <a:avLst/>
           </a:prstGeom>
           <a:solidFill>
-            <a:srgbClr val="1B1827"/>
+            <a:srgbClr val="12101B"/>
           </a:solidFill>
           <a:ln>
             <a:solidFill>
-              <a:srgbClr val="B19AFF"/>
+              <a:srgbClr val="784BFF"/>
             </a:solidFill>
           </a:ln>
         </p:spPr>
@@ -5362,7 +5767,7 @@
               </a:spcAft>
               <a:defRPr b="1" sz="1600">
                 <a:solidFill>
-                  <a:srgbClr val="B19AFF"/>
+                  <a:srgbClr val="784BFF"/>
                 </a:solidFill>
               </a:defRPr>
             </a:pPr>
@@ -5374,7 +5779,7 @@
             <a:pPr>
               <a:defRPr sz="1300">
                 <a:solidFill>
-                  <a:srgbClr val="AAA4BB"/>
+                  <a:srgbClr val="9D96B2"/>
                 </a:solidFill>
               </a:defRPr>
             </a:pPr>
@@ -5399,11 +5804,11 @@
             <a:avLst/>
           </a:prstGeom>
           <a:solidFill>
-            <a:srgbClr val="1B1827"/>
+            <a:srgbClr val="12101B"/>
           </a:solidFill>
           <a:ln>
             <a:solidFill>
-              <a:srgbClr val="F5F0E8"/>
+              <a:srgbClr val="F7F6FB"/>
             </a:solidFill>
           </a:ln>
         </p:spPr>
@@ -5431,7 +5836,7 @@
               </a:spcAft>
               <a:defRPr b="1" sz="1600">
                 <a:solidFill>
-                  <a:srgbClr val="F5F0E8"/>
+                  <a:srgbClr val="F7F6FB"/>
                 </a:solidFill>
               </a:defRPr>
             </a:pPr>
@@ -5443,7 +5848,7 @@
             <a:pPr>
               <a:defRPr sz="1300">
                 <a:solidFill>
-                  <a:srgbClr val="AAA4BB"/>
+                  <a:srgbClr val="9D96B2"/>
                 </a:solidFill>
               </a:defRPr>
             </a:pPr>
@@ -5486,7 +5891,7 @@
             <a:avLst/>
           </a:prstGeom>
           <a:solidFill>
-            <a:srgbClr val="111019"/>
+            <a:srgbClr val="0A0912"/>
           </a:solidFill>
           <a:ln>
             <a:noFill/>
@@ -5563,7 +5968,7 @@
             <a:pPr>
               <a:defRPr sz="1000" b="1">
                 <a:solidFill>
-                  <a:srgbClr val="B19AFF"/>
+                  <a:srgbClr val="784BFF"/>
                 </a:solidFill>
               </a:defRPr>
             </a:pPr>
@@ -5598,7 +6003,7 @@
             <a:pPr>
               <a:defRPr sz="2600" b="1">
                 <a:solidFill>
-                  <a:srgbClr val="F5F0E8"/>
+                  <a:srgbClr val="F7F6FB"/>
                 </a:solidFill>
               </a:defRPr>
             </a:pPr>
@@ -5623,7 +6028,7 @@
             <a:avLst/>
           </a:prstGeom>
           <a:solidFill>
-            <a:srgbClr val="1B1827"/>
+            <a:srgbClr val="12101B"/>
           </a:solidFill>
           <a:ln>
             <a:noFill/>
@@ -5650,7 +6055,7 @@
             <a:pPr algn="ctr">
               <a:defRPr b="1" sz="1400">
                 <a:solidFill>
-                  <a:srgbClr val="B19AFF"/>
+                  <a:srgbClr val="784BFF"/>
                 </a:solidFill>
               </a:defRPr>
             </a:pPr>
@@ -5660,7 +6065,7 @@
             <a:r>
               <a:rPr b="0" sz="1300">
                 <a:solidFill>
-                  <a:srgbClr val="F5F0E8"/>
+                  <a:srgbClr val="F7F6FB"/>
                 </a:solidFill>
               </a:rPr>
               <a:t>Browse 110 full-length tracks, persistent player, HTTP Range requests, volume control, and shuffle/repeat modes.</a:t>
@@ -5683,7 +6088,7 @@
             <a:avLst/>
           </a:prstGeom>
           <a:solidFill>
-            <a:srgbClr val="1B1827"/>
+            <a:srgbClr val="12101B"/>
           </a:solidFill>
           <a:ln>
             <a:noFill/>
@@ -5710,7 +6115,7 @@
             <a:pPr algn="ctr">
               <a:defRPr b="1" sz="1400">
                 <a:solidFill>
-                  <a:srgbClr val="B19AFF"/>
+                  <a:srgbClr val="784BFF"/>
                 </a:solidFill>
               </a:defRPr>
             </a:pPr>
@@ -5720,7 +6125,7 @@
             <a:r>
               <a:rPr b="0" sz="1300">
                 <a:solidFill>
-                  <a:srgbClr val="F5F0E8"/>
+                  <a:srgbClr val="F7F6FB"/>
                 </a:solidFill>
               </a:rPr>
               <a:t>Create, edit, reorder, delete, and publicly share playlists via direct URL tokens.</a:t>
@@ -5743,7 +6148,7 @@
             <a:avLst/>
           </a:prstGeom>
           <a:solidFill>
-            <a:srgbClr val="1B1827"/>
+            <a:srgbClr val="12101B"/>
           </a:solidFill>
           <a:ln>
             <a:noFill/>
@@ -5770,7 +6175,7 @@
             <a:pPr algn="ctr">
               <a:defRPr b="1" sz="1400">
                 <a:solidFill>
-                  <a:srgbClr val="B19AFF"/>
+                  <a:srgbClr val="784BFF"/>
                 </a:solidFill>
               </a:defRPr>
             </a:pPr>
@@ -5780,7 +6185,7 @@
             <a:r>
               <a:rPr b="0" sz="1300">
                 <a:solidFill>
-                  <a:srgbClr val="F5F0E8"/>
+                  <a:srgbClr val="F7F6FB"/>
                 </a:solidFill>
               </a:rPr>
               <a:t>Cache audio streams in browser IndexedDB with a dedicated Service Worker for zero-network playback.</a:t>
@@ -5803,7 +6208,7 @@
             <a:avLst/>
           </a:prstGeom>
           <a:solidFill>
-            <a:srgbClr val="1B1827"/>
+            <a:srgbClr val="12101B"/>
           </a:solidFill>
           <a:ln>
             <a:noFill/>
@@ -5830,7 +6235,7 @@
             <a:pPr algn="ctr">
               <a:defRPr b="1" sz="1400">
                 <a:solidFill>
-                  <a:srgbClr val="B19AFF"/>
+                  <a:srgbClr val="784BFF"/>
                 </a:solidFill>
               </a:defRPr>
             </a:pPr>
@@ -5840,7 +6245,7 @@
             <a:r>
               <a:rPr b="0" sz="1300">
                 <a:solidFill>
-                  <a:srgbClr val="F5F0E8"/>
+                  <a:srgbClr val="F7F6FB"/>
                 </a:solidFill>
               </a:rPr>
               <a:t>Diverge Sessions (sync rooms), Track DNA (SVG glyphs), Anti-Algorithm, Trace (tree), Context Tags.</a:t>
@@ -5863,7 +6268,7 @@
             <a:avLst/>
           </a:prstGeom>
           <a:solidFill>
-            <a:srgbClr val="1B1827"/>
+            <a:srgbClr val="12101B"/>
           </a:solidFill>
           <a:ln>
             <a:noFill/>
@@ -5890,7 +6295,7 @@
             <a:pPr algn="ctr">
               <a:defRPr b="1" sz="1400">
                 <a:solidFill>
-                  <a:srgbClr val="B19AFF"/>
+                  <a:srgbClr val="784BFF"/>
                 </a:solidFill>
               </a:defRPr>
             </a:pPr>
@@ -5900,7 +6305,7 @@
             <a:r>
               <a:rPr b="0" sz="1300">
                 <a:solidFill>
-                  <a:srgbClr val="F5F0E8"/>
+                  <a:srgbClr val="F7F6FB"/>
                 </a:solidFill>
               </a:rPr>
               <a:t>Sub-10ms API queries, instant audio seek via HTTP 206, and zero browser memory leaks.</a:t>
@@ -5941,7 +6346,7 @@
             <a:avLst/>
           </a:prstGeom>
           <a:solidFill>
-            <a:srgbClr val="111019"/>
+            <a:srgbClr val="0A0912"/>
           </a:solidFill>
           <a:ln>
             <a:noFill/>
@@ -6018,7 +6423,7 @@
             <a:pPr>
               <a:defRPr sz="1000" b="1">
                 <a:solidFill>
-                  <a:srgbClr val="B19AFF"/>
+                  <a:srgbClr val="784BFF"/>
                 </a:solidFill>
               </a:defRPr>
             </a:pPr>
@@ -6053,7 +6458,7 @@
             <a:pPr>
               <a:defRPr sz="2600" b="1">
                 <a:solidFill>
-                  <a:srgbClr val="F5F0E8"/>
+                  <a:srgbClr val="F7F6FB"/>
                 </a:solidFill>
               </a:defRPr>
             </a:pPr>
@@ -6078,11 +6483,11 @@
             <a:avLst/>
           </a:prstGeom>
           <a:solidFill>
-            <a:srgbClr val="1B1827"/>
+            <a:srgbClr val="12101B"/>
           </a:solidFill>
           <a:ln>
             <a:solidFill>
-              <a:srgbClr val="B19AFF"/>
+              <a:srgbClr val="784BFF"/>
             </a:solidFill>
           </a:ln>
         </p:spPr>
@@ -6110,7 +6515,7 @@
               </a:spcAft>
               <a:defRPr b="1" sz="1600">
                 <a:solidFill>
-                  <a:srgbClr val="B19AFF"/>
+                  <a:srgbClr val="784BFF"/>
                 </a:solidFill>
               </a:defRPr>
             </a:pPr>
@@ -6125,7 +6530,7 @@
               </a:spcAft>
               <a:defRPr sz="1200">
                 <a:solidFill>
-                  <a:srgbClr val="F5F0E8"/>
+                  <a:srgbClr val="F7F6FB"/>
                 </a:solidFill>
               </a:defRPr>
             </a:pPr>
@@ -6140,7 +6545,7 @@
               </a:spcAft>
               <a:defRPr sz="1200">
                 <a:solidFill>
-                  <a:srgbClr val="F5F0E8"/>
+                  <a:srgbClr val="F7F6FB"/>
                 </a:solidFill>
               </a:defRPr>
             </a:pPr>
@@ -6155,7 +6560,7 @@
               </a:spcAft>
               <a:defRPr sz="1200">
                 <a:solidFill>
-                  <a:srgbClr val="F5F0E8"/>
+                  <a:srgbClr val="F7F6FB"/>
                 </a:solidFill>
               </a:defRPr>
             </a:pPr>
@@ -6170,7 +6575,7 @@
               </a:spcAft>
               <a:defRPr sz="1200">
                 <a:solidFill>
-                  <a:srgbClr val="F5F0E8"/>
+                  <a:srgbClr val="F7F6FB"/>
                 </a:solidFill>
               </a:defRPr>
             </a:pPr>
@@ -6195,11 +6600,11 @@
             <a:avLst/>
           </a:prstGeom>
           <a:solidFill>
-            <a:srgbClr val="1B1827"/>
+            <a:srgbClr val="12101B"/>
           </a:solidFill>
           <a:ln>
             <a:solidFill>
-              <a:srgbClr val="F5F0E8"/>
+              <a:srgbClr val="F7F6FB"/>
             </a:solidFill>
           </a:ln>
         </p:spPr>
@@ -6227,7 +6632,7 @@
               </a:spcAft>
               <a:defRPr b="1" sz="1600">
                 <a:solidFill>
-                  <a:srgbClr val="F5F0E8"/>
+                  <a:srgbClr val="F7F6FB"/>
                 </a:solidFill>
               </a:defRPr>
             </a:pPr>
@@ -6242,7 +6647,7 @@
               </a:spcAft>
               <a:defRPr sz="1200">
                 <a:solidFill>
-                  <a:srgbClr val="F5F0E8"/>
+                  <a:srgbClr val="F7F6FB"/>
                 </a:solidFill>
               </a:defRPr>
             </a:pPr>
@@ -6257,7 +6662,7 @@
               </a:spcAft>
               <a:defRPr sz="1200">
                 <a:solidFill>
-                  <a:srgbClr val="F5F0E8"/>
+                  <a:srgbClr val="F7F6FB"/>
                 </a:solidFill>
               </a:defRPr>
             </a:pPr>
@@ -6272,7 +6677,7 @@
               </a:spcAft>
               <a:defRPr sz="1200">
                 <a:solidFill>
-                  <a:srgbClr val="F5F0E8"/>
+                  <a:srgbClr val="F7F6FB"/>
                 </a:solidFill>
               </a:defRPr>
             </a:pPr>
@@ -6287,7 +6692,7 @@
               </a:spcAft>
               <a:defRPr sz="1200">
                 <a:solidFill>
-                  <a:srgbClr val="F5F0E8"/>
+                  <a:srgbClr val="F7F6FB"/>
                 </a:solidFill>
               </a:defRPr>
             </a:pPr>
@@ -6312,11 +6717,11 @@
             <a:avLst/>
           </a:prstGeom>
           <a:solidFill>
-            <a:srgbClr val="1B1827"/>
+            <a:srgbClr val="12101B"/>
           </a:solidFill>
           <a:ln>
             <a:solidFill>
-              <a:srgbClr val="FF796C"/>
+              <a:srgbClr val="FF5C58"/>
             </a:solidFill>
           </a:ln>
         </p:spPr>
@@ -6344,7 +6749,7 @@
               </a:spcAft>
               <a:defRPr b="1" sz="1600">
                 <a:solidFill>
-                  <a:srgbClr val="FF796C"/>
+                  <a:srgbClr val="FF5C58"/>
                 </a:solidFill>
               </a:defRPr>
             </a:pPr>
@@ -6359,7 +6764,7 @@
               </a:spcAft>
               <a:defRPr sz="1200">
                 <a:solidFill>
-                  <a:srgbClr val="F5F0E8"/>
+                  <a:srgbClr val="F7F6FB"/>
                 </a:solidFill>
               </a:defRPr>
             </a:pPr>
@@ -6374,7 +6779,7 @@
               </a:spcAft>
               <a:defRPr sz="1200">
                 <a:solidFill>
-                  <a:srgbClr val="F5F0E8"/>
+                  <a:srgbClr val="F7F6FB"/>
                 </a:solidFill>
               </a:defRPr>
             </a:pPr>
@@ -6389,7 +6794,7 @@
               </a:spcAft>
               <a:defRPr sz="1200">
                 <a:solidFill>
-                  <a:srgbClr val="F5F0E8"/>
+                  <a:srgbClr val="F7F6FB"/>
                 </a:solidFill>
               </a:defRPr>
             </a:pPr>
@@ -6404,7 +6809,7 @@
               </a:spcAft>
               <a:defRPr sz="1200">
                 <a:solidFill>
-                  <a:srgbClr val="F5F0E8"/>
+                  <a:srgbClr val="F7F6FB"/>
                 </a:solidFill>
               </a:defRPr>
             </a:pPr>
@@ -6429,11 +6834,11 @@
             <a:avLst/>
           </a:prstGeom>
           <a:solidFill>
-            <a:srgbClr val="1B1827"/>
+            <a:srgbClr val="12101B"/>
           </a:solidFill>
           <a:ln>
             <a:solidFill>
-              <a:srgbClr val="B19AFF"/>
+              <a:srgbClr val="784BFF"/>
             </a:solidFill>
           </a:ln>
         </p:spPr>
@@ -6461,7 +6866,7 @@
               </a:spcAft>
               <a:defRPr b="1" sz="1600">
                 <a:solidFill>
-                  <a:srgbClr val="B19AFF"/>
+                  <a:srgbClr val="784BFF"/>
                 </a:solidFill>
               </a:defRPr>
             </a:pPr>
@@ -6476,7 +6881,7 @@
               </a:spcAft>
               <a:defRPr sz="1200">
                 <a:solidFill>
-                  <a:srgbClr val="F5F0E8"/>
+                  <a:srgbClr val="F7F6FB"/>
                 </a:solidFill>
               </a:defRPr>
             </a:pPr>
@@ -6491,7 +6896,7 @@
               </a:spcAft>
               <a:defRPr sz="1200">
                 <a:solidFill>
-                  <a:srgbClr val="F5F0E8"/>
+                  <a:srgbClr val="F7F6FB"/>
                 </a:solidFill>
               </a:defRPr>
             </a:pPr>
@@ -6506,7 +6911,7 @@
               </a:spcAft>
               <a:defRPr sz="1200">
                 <a:solidFill>
-                  <a:srgbClr val="F5F0E8"/>
+                  <a:srgbClr val="F7F6FB"/>
                 </a:solidFill>
               </a:defRPr>
             </a:pPr>
@@ -6521,7 +6926,7 @@
               </a:spcAft>
               <a:defRPr sz="1200">
                 <a:solidFill>
-                  <a:srgbClr val="F5F0E8"/>
+                  <a:srgbClr val="F7F6FB"/>
                 </a:solidFill>
               </a:defRPr>
             </a:pPr>
@@ -6564,7 +6969,7 @@
             <a:avLst/>
           </a:prstGeom>
           <a:solidFill>
-            <a:srgbClr val="111019"/>
+            <a:srgbClr val="0A0912"/>
           </a:solidFill>
           <a:ln>
             <a:noFill/>
@@ -6641,7 +7046,7 @@
             <a:pPr>
               <a:defRPr sz="1000" b="1">
                 <a:solidFill>
-                  <a:srgbClr val="B19AFF"/>
+                  <a:srgbClr val="784BFF"/>
                 </a:solidFill>
               </a:defRPr>
             </a:pPr>
@@ -6676,7 +7081,7 @@
             <a:pPr>
               <a:defRPr sz="2600" b="1">
                 <a:solidFill>
-                  <a:srgbClr val="F5F0E8"/>
+                  <a:srgbClr val="F7F6FB"/>
                 </a:solidFill>
               </a:defRPr>
             </a:pPr>
@@ -6701,11 +7106,11 @@
             <a:avLst/>
           </a:prstGeom>
           <a:solidFill>
-            <a:srgbClr val="1B1827"/>
+            <a:srgbClr val="12101B"/>
           </a:solidFill>
           <a:ln>
             <a:solidFill>
-              <a:srgbClr val="B19AFF"/>
+              <a:srgbClr val="784BFF"/>
             </a:solidFill>
           </a:ln>
         </p:spPr>
@@ -6733,7 +7138,7 @@
               </a:spcAft>
               <a:defRPr b="1" sz="1500">
                 <a:solidFill>
-                  <a:srgbClr val="B19AFF"/>
+                  <a:srgbClr val="784BFF"/>
                 </a:solidFill>
               </a:defRPr>
             </a:pPr>
@@ -6748,7 +7153,7 @@
               </a:spcAft>
               <a:defRPr sz="1200">
                 <a:solidFill>
-                  <a:srgbClr val="F5F0E8"/>
+                  <a:srgbClr val="F7F6FB"/>
                 </a:solidFill>
               </a:defRPr>
             </a:pPr>
@@ -6763,7 +7168,7 @@
               </a:spcAft>
               <a:defRPr sz="1200">
                 <a:solidFill>
-                  <a:srgbClr val="F5F0E8"/>
+                  <a:srgbClr val="F7F6FB"/>
                 </a:solidFill>
               </a:defRPr>
             </a:pPr>
@@ -6778,7 +7183,7 @@
               </a:spcAft>
               <a:defRPr sz="1200">
                 <a:solidFill>
-                  <a:srgbClr val="F5F0E8"/>
+                  <a:srgbClr val="F7F6FB"/>
                 </a:solidFill>
               </a:defRPr>
             </a:pPr>
@@ -6803,11 +7208,11 @@
             <a:avLst/>
           </a:prstGeom>
           <a:solidFill>
-            <a:srgbClr val="1B1827"/>
+            <a:srgbClr val="12101B"/>
           </a:solidFill>
           <a:ln>
             <a:solidFill>
-              <a:srgbClr val="FF796C"/>
+              <a:srgbClr val="FF5C58"/>
             </a:solidFill>
           </a:ln>
         </p:spPr>
@@ -6835,7 +7240,7 @@
               </a:spcAft>
               <a:defRPr b="1" sz="1500">
                 <a:solidFill>
-                  <a:srgbClr val="FF796C"/>
+                  <a:srgbClr val="FF5C58"/>
                 </a:solidFill>
               </a:defRPr>
             </a:pPr>
@@ -6850,7 +7255,7 @@
               </a:spcAft>
               <a:defRPr sz="1200">
                 <a:solidFill>
-                  <a:srgbClr val="F5F0E8"/>
+                  <a:srgbClr val="F7F6FB"/>
                 </a:solidFill>
               </a:defRPr>
             </a:pPr>
@@ -6865,7 +7270,7 @@
               </a:spcAft>
               <a:defRPr sz="1200">
                 <a:solidFill>
-                  <a:srgbClr val="F5F0E8"/>
+                  <a:srgbClr val="F7F6FB"/>
                 </a:solidFill>
               </a:defRPr>
             </a:pPr>
@@ -6880,7 +7285,7 @@
               </a:spcAft>
               <a:defRPr sz="1200">
                 <a:solidFill>
-                  <a:srgbClr val="F5F0E8"/>
+                  <a:srgbClr val="F7F6FB"/>
                 </a:solidFill>
               </a:defRPr>
             </a:pPr>
@@ -6905,11 +7310,11 @@
             <a:avLst/>
           </a:prstGeom>
           <a:solidFill>
-            <a:srgbClr val="1B1827"/>
+            <a:srgbClr val="12101B"/>
           </a:solidFill>
           <a:ln>
             <a:solidFill>
-              <a:srgbClr val="F5F0E8"/>
+              <a:srgbClr val="F7F6FB"/>
             </a:solidFill>
           </a:ln>
         </p:spPr>
@@ -6937,7 +7342,7 @@
               </a:spcAft>
               <a:defRPr b="1" sz="1500">
                 <a:solidFill>
-                  <a:srgbClr val="F5F0E8"/>
+                  <a:srgbClr val="F7F6FB"/>
                 </a:solidFill>
               </a:defRPr>
             </a:pPr>
@@ -6952,7 +7357,7 @@
               </a:spcAft>
               <a:defRPr sz="1200">
                 <a:solidFill>
-                  <a:srgbClr val="F5F0E8"/>
+                  <a:srgbClr val="F7F6FB"/>
                 </a:solidFill>
               </a:defRPr>
             </a:pPr>
@@ -6967,7 +7372,7 @@
               </a:spcAft>
               <a:defRPr sz="1200">
                 <a:solidFill>
-                  <a:srgbClr val="F5F0E8"/>
+                  <a:srgbClr val="F7F6FB"/>
                 </a:solidFill>
               </a:defRPr>
             </a:pPr>
@@ -6982,7 +7387,7 @@
               </a:spcAft>
               <a:defRPr sz="1200">
                 <a:solidFill>
-                  <a:srgbClr val="F5F0E8"/>
+                  <a:srgbClr val="F7F6FB"/>
                 </a:solidFill>
               </a:defRPr>
             </a:pPr>
@@ -7025,7 +7430,7 @@
             <a:avLst/>
           </a:prstGeom>
           <a:solidFill>
-            <a:srgbClr val="111019"/>
+            <a:srgbClr val="0A0912"/>
           </a:solidFill>
           <a:ln>
             <a:noFill/>
@@ -7102,7 +7507,7 @@
             <a:pPr>
               <a:defRPr sz="1000" b="1">
                 <a:solidFill>
-                  <a:srgbClr val="B19AFF"/>
+                  <a:srgbClr val="784BFF"/>
                 </a:solidFill>
               </a:defRPr>
             </a:pPr>
@@ -7137,7 +7542,7 @@
             <a:pPr>
               <a:defRPr sz="2600" b="1">
                 <a:solidFill>
-                  <a:srgbClr val="F5F0E8"/>
+                  <a:srgbClr val="F7F6FB"/>
                 </a:solidFill>
               </a:defRPr>
             </a:pPr>
@@ -7162,11 +7567,11 @@
             <a:avLst/>
           </a:prstGeom>
           <a:solidFill>
-            <a:srgbClr val="1B1827"/>
+            <a:srgbClr val="12101B"/>
           </a:solidFill>
           <a:ln>
             <a:solidFill>
-              <a:srgbClr val="B19AFF"/>
+              <a:srgbClr val="784BFF"/>
             </a:solidFill>
           </a:ln>
         </p:spPr>
@@ -7194,7 +7599,7 @@
               </a:spcAft>
               <a:defRPr b="1" sz="1400">
                 <a:solidFill>
-                  <a:srgbClr val="B19AFF"/>
+                  <a:srgbClr val="784BFF"/>
                 </a:solidFill>
               </a:defRPr>
             </a:pPr>
@@ -7206,7 +7611,7 @@
             <a:pPr>
               <a:defRPr sz="1050">
                 <a:solidFill>
-                  <a:srgbClr val="AAA4BB"/>
+                  <a:srgbClr val="9D96B2"/>
                 </a:solidFill>
               </a:defRPr>
             </a:pPr>
@@ -7231,11 +7636,11 @@
             <a:avLst/>
           </a:prstGeom>
           <a:solidFill>
-            <a:srgbClr val="1B1827"/>
+            <a:srgbClr val="12101B"/>
           </a:solidFill>
           <a:ln>
             <a:solidFill>
-              <a:srgbClr val="FF796C"/>
+              <a:srgbClr val="FF5C58"/>
             </a:solidFill>
           </a:ln>
         </p:spPr>
@@ -7263,7 +7668,7 @@
               </a:spcAft>
               <a:defRPr b="1" sz="1400">
                 <a:solidFill>
-                  <a:srgbClr val="FF796C"/>
+                  <a:srgbClr val="FF5C58"/>
                 </a:solidFill>
               </a:defRPr>
             </a:pPr>
@@ -7275,7 +7680,7 @@
             <a:pPr>
               <a:defRPr sz="1050">
                 <a:solidFill>
-                  <a:srgbClr val="AAA4BB"/>
+                  <a:srgbClr val="9D96B2"/>
                 </a:solidFill>
               </a:defRPr>
             </a:pPr>
@@ -7300,11 +7705,11 @@
             <a:avLst/>
           </a:prstGeom>
           <a:solidFill>
-            <a:srgbClr val="1B1827"/>
+            <a:srgbClr val="12101B"/>
           </a:solidFill>
           <a:ln>
             <a:solidFill>
-              <a:srgbClr val="B19AFF"/>
+              <a:srgbClr val="784BFF"/>
             </a:solidFill>
           </a:ln>
         </p:spPr>
@@ -7332,7 +7737,7 @@
               </a:spcAft>
               <a:defRPr b="1" sz="1400">
                 <a:solidFill>
-                  <a:srgbClr val="B19AFF"/>
+                  <a:srgbClr val="784BFF"/>
                 </a:solidFill>
               </a:defRPr>
             </a:pPr>
@@ -7344,7 +7749,7 @@
             <a:pPr>
               <a:defRPr sz="1050">
                 <a:solidFill>
-                  <a:srgbClr val="AAA4BB"/>
+                  <a:srgbClr val="9D96B2"/>
                 </a:solidFill>
               </a:defRPr>
             </a:pPr>
@@ -7369,11 +7774,11 @@
             <a:avLst/>
           </a:prstGeom>
           <a:solidFill>
-            <a:srgbClr val="1B1827"/>
+            <a:srgbClr val="12101B"/>
           </a:solidFill>
           <a:ln>
             <a:solidFill>
-              <a:srgbClr val="FF796C"/>
+              <a:srgbClr val="FF5C58"/>
             </a:solidFill>
           </a:ln>
         </p:spPr>
@@ -7401,7 +7806,7 @@
               </a:spcAft>
               <a:defRPr b="1" sz="1400">
                 <a:solidFill>
-                  <a:srgbClr val="FF796C"/>
+                  <a:srgbClr val="FF5C58"/>
                 </a:solidFill>
               </a:defRPr>
             </a:pPr>
@@ -7413,7 +7818,7 @@
             <a:pPr>
               <a:defRPr sz="1050">
                 <a:solidFill>
-                  <a:srgbClr val="AAA4BB"/>
+                  <a:srgbClr val="9D96B2"/>
                 </a:solidFill>
               </a:defRPr>
             </a:pPr>
@@ -7438,11 +7843,11 @@
             <a:avLst/>
           </a:prstGeom>
           <a:solidFill>
-            <a:srgbClr val="1B1827"/>
+            <a:srgbClr val="12101B"/>
           </a:solidFill>
           <a:ln>
             <a:solidFill>
-              <a:srgbClr val="B19AFF"/>
+              <a:srgbClr val="784BFF"/>
             </a:solidFill>
           </a:ln>
         </p:spPr>
@@ -7470,7 +7875,7 @@
               </a:spcAft>
               <a:defRPr b="1" sz="1400">
                 <a:solidFill>
-                  <a:srgbClr val="B19AFF"/>
+                  <a:srgbClr val="784BFF"/>
                 </a:solidFill>
               </a:defRPr>
             </a:pPr>
@@ -7482,7 +7887,7 @@
             <a:pPr>
               <a:defRPr sz="1050">
                 <a:solidFill>
-                  <a:srgbClr val="AAA4BB"/>
+                  <a:srgbClr val="9D96B2"/>
                 </a:solidFill>
               </a:defRPr>
             </a:pPr>
@@ -7507,11 +7912,11 @@
             <a:avLst/>
           </a:prstGeom>
           <a:solidFill>
-            <a:srgbClr val="1B1827"/>
+            <a:srgbClr val="12101B"/>
           </a:solidFill>
           <a:ln>
             <a:solidFill>
-              <a:srgbClr val="FF796C"/>
+              <a:srgbClr val="FF5C58"/>
             </a:solidFill>
           </a:ln>
         </p:spPr>
@@ -7539,7 +7944,7 @@
               </a:spcAft>
               <a:defRPr b="1" sz="1400">
                 <a:solidFill>
-                  <a:srgbClr val="FF796C"/>
+                  <a:srgbClr val="FF5C58"/>
                 </a:solidFill>
               </a:defRPr>
             </a:pPr>
@@ -7551,7 +7956,7 @@
             <a:pPr>
               <a:defRPr sz="1050">
                 <a:solidFill>
-                  <a:srgbClr val="AAA4BB"/>
+                  <a:srgbClr val="9D96B2"/>
                 </a:solidFill>
               </a:defRPr>
             </a:pPr>
@@ -7576,11 +7981,11 @@
             <a:avLst/>
           </a:prstGeom>
           <a:solidFill>
-            <a:srgbClr val="1B1827"/>
+            <a:srgbClr val="12101B"/>
           </a:solidFill>
           <a:ln>
             <a:solidFill>
-              <a:srgbClr val="B19AFF"/>
+              <a:srgbClr val="784BFF"/>
             </a:solidFill>
           </a:ln>
         </p:spPr>
@@ -7608,7 +8013,7 @@
               </a:spcAft>
               <a:defRPr b="1" sz="1400">
                 <a:solidFill>
-                  <a:srgbClr val="B19AFF"/>
+                  <a:srgbClr val="784BFF"/>
                 </a:solidFill>
               </a:defRPr>
             </a:pPr>
@@ -7620,7 +8025,7 @@
             <a:pPr>
               <a:defRPr sz="1050">
                 <a:solidFill>
-                  <a:srgbClr val="AAA4BB"/>
+                  <a:srgbClr val="9D96B2"/>
                 </a:solidFill>
               </a:defRPr>
             </a:pPr>
@@ -7645,11 +8050,11 @@
             <a:avLst/>
           </a:prstGeom>
           <a:solidFill>
-            <a:srgbClr val="1B1827"/>
+            <a:srgbClr val="12101B"/>
           </a:solidFill>
           <a:ln>
             <a:solidFill>
-              <a:srgbClr val="FF796C"/>
+              <a:srgbClr val="FF5C58"/>
             </a:solidFill>
           </a:ln>
         </p:spPr>
@@ -7677,7 +8082,7 @@
               </a:spcAft>
               <a:defRPr b="1" sz="1400">
                 <a:solidFill>
-                  <a:srgbClr val="FF796C"/>
+                  <a:srgbClr val="FF5C58"/>
                 </a:solidFill>
               </a:defRPr>
             </a:pPr>
@@ -7689,7 +8094,7 @@
             <a:pPr>
               <a:defRPr sz="1050">
                 <a:solidFill>
-                  <a:srgbClr val="AAA4BB"/>
+                  <a:srgbClr val="9D96B2"/>
                 </a:solidFill>
               </a:defRPr>
             </a:pPr>
@@ -7714,11 +8119,11 @@
             <a:avLst/>
           </a:prstGeom>
           <a:solidFill>
-            <a:srgbClr val="1B1827"/>
+            <a:srgbClr val="12101B"/>
           </a:solidFill>
           <a:ln>
             <a:solidFill>
-              <a:srgbClr val="B19AFF"/>
+              <a:srgbClr val="784BFF"/>
             </a:solidFill>
           </a:ln>
         </p:spPr>
@@ -7746,7 +8151,7 @@
               </a:spcAft>
               <a:defRPr b="1" sz="1400">
                 <a:solidFill>
-                  <a:srgbClr val="B19AFF"/>
+                  <a:srgbClr val="784BFF"/>
                 </a:solidFill>
               </a:defRPr>
             </a:pPr>
@@ -7758,7 +8163,7 @@
             <a:pPr>
               <a:defRPr sz="1050">
                 <a:solidFill>
-                  <a:srgbClr val="AAA4BB"/>
+                  <a:srgbClr val="9D96B2"/>
                 </a:solidFill>
               </a:defRPr>
             </a:pPr>
@@ -7801,7 +8206,7 @@
             <a:avLst/>
           </a:prstGeom>
           <a:solidFill>
-            <a:srgbClr val="111019"/>
+            <a:srgbClr val="0A0912"/>
           </a:solidFill>
           <a:ln>
             <a:noFill/>
@@ -7878,7 +8283,7 @@
             <a:pPr>
               <a:defRPr sz="1000" b="1">
                 <a:solidFill>
-                  <a:srgbClr val="B19AFF"/>
+                  <a:srgbClr val="784BFF"/>
                 </a:solidFill>
               </a:defRPr>
             </a:pPr>
@@ -7913,7 +8318,7 @@
             <a:pPr>
               <a:defRPr sz="2600" b="1">
                 <a:solidFill>
-                  <a:srgbClr val="F5F0E8"/>
+                  <a:srgbClr val="F7F6FB"/>
                 </a:solidFill>
               </a:defRPr>
             </a:pPr>
@@ -7938,11 +8343,11 @@
             <a:avLst/>
           </a:prstGeom>
           <a:solidFill>
-            <a:srgbClr val="1B1827"/>
+            <a:srgbClr val="12101B"/>
           </a:solidFill>
           <a:ln>
             <a:solidFill>
-              <a:srgbClr val="B19AFF"/>
+              <a:srgbClr val="784BFF"/>
             </a:solidFill>
           </a:ln>
         </p:spPr>
@@ -7970,7 +8375,7 @@
               </a:spcAft>
               <a:defRPr b="1" sz="1600">
                 <a:solidFill>
-                  <a:srgbClr val="B19AFF"/>
+                  <a:srgbClr val="784BFF"/>
                 </a:solidFill>
               </a:defRPr>
             </a:pPr>
@@ -7985,7 +8390,7 @@
               </a:spcAft>
               <a:defRPr sz="1200">
                 <a:solidFill>
-                  <a:srgbClr val="F5F0E8"/>
+                  <a:srgbClr val="F7F6FB"/>
                 </a:solidFill>
               </a:defRPr>
             </a:pPr>
@@ -8000,7 +8405,7 @@
               </a:spcAft>
               <a:defRPr sz="1200">
                 <a:solidFill>
-                  <a:srgbClr val="F5F0E8"/>
+                  <a:srgbClr val="F7F6FB"/>
                 </a:solidFill>
               </a:defRPr>
             </a:pPr>
@@ -8015,7 +8420,7 @@
               </a:spcAft>
               <a:defRPr sz="1200">
                 <a:solidFill>
-                  <a:srgbClr val="F5F0E8"/>
+                  <a:srgbClr val="F7F6FB"/>
                 </a:solidFill>
               </a:defRPr>
             </a:pPr>
@@ -8030,7 +8435,7 @@
               </a:spcAft>
               <a:defRPr sz="1200">
                 <a:solidFill>
-                  <a:srgbClr val="F5F0E8"/>
+                  <a:srgbClr val="F7F6FB"/>
                 </a:solidFill>
               </a:defRPr>
             </a:pPr>
@@ -8055,11 +8460,11 @@
             <a:avLst/>
           </a:prstGeom>
           <a:solidFill>
-            <a:srgbClr val="1B1827"/>
+            <a:srgbClr val="12101B"/>
           </a:solidFill>
           <a:ln>
             <a:solidFill>
-              <a:srgbClr val="FF796C"/>
+              <a:srgbClr val="FF5C58"/>
             </a:solidFill>
           </a:ln>
         </p:spPr>
@@ -8087,7 +8492,7 @@
               </a:spcAft>
               <a:defRPr b="1" sz="1600">
                 <a:solidFill>
-                  <a:srgbClr val="FF796C"/>
+                  <a:srgbClr val="FF5C58"/>
                 </a:solidFill>
               </a:defRPr>
             </a:pPr>
@@ -8102,7 +8507,7 @@
               </a:spcAft>
               <a:defRPr sz="1200">
                 <a:solidFill>
-                  <a:srgbClr val="F5F0E8"/>
+                  <a:srgbClr val="F7F6FB"/>
                 </a:solidFill>
               </a:defRPr>
             </a:pPr>
@@ -8117,12 +8522,12 @@
               </a:spcAft>
               <a:defRPr sz="1200">
                 <a:solidFill>
-                  <a:srgbClr val="F5F0E8"/>
-                </a:solidFill>
-              </a:defRPr>
-            </a:pPr>
-            <a:r>
-              <a:t>• Smooth navigation across /search, /canvas, /library without audio interruption.</a:t>
+                  <a:srgbClr val="F7F6FB"/>
+                </a:solidFill>
+              </a:defRPr>
+            </a:pPr>
+            <a:r>
+              <a:t>• Smooth navigation across /search, /library, /trace without audio interruption.</a:t>
             </a:r>
           </a:p>
           <a:p>
@@ -8132,7 +8537,7 @@
               </a:spcAft>
               <a:defRPr sz="1200">
                 <a:solidFill>
-                  <a:srgbClr val="F5F0E8"/>
+                  <a:srgbClr val="F7F6FB"/>
                 </a:solidFill>
               </a:defRPr>
             </a:pPr>
@@ -8147,7 +8552,7 @@
               </a:spcAft>
               <a:defRPr sz="1200">
                 <a:solidFill>
-                  <a:srgbClr val="F5F0E8"/>
+                  <a:srgbClr val="F7F6FB"/>
                 </a:solidFill>
               </a:defRPr>
             </a:pPr>
@@ -8190,7 +8595,7 @@
             <a:avLst/>
           </a:prstGeom>
           <a:solidFill>
-            <a:srgbClr val="111019"/>
+            <a:srgbClr val="0A0912"/>
           </a:solidFill>
           <a:ln>
             <a:noFill/>
@@ -8267,7 +8672,7 @@
             <a:pPr>
               <a:defRPr sz="1000" b="1">
                 <a:solidFill>
-                  <a:srgbClr val="B19AFF"/>
+                  <a:srgbClr val="784BFF"/>
                 </a:solidFill>
               </a:defRPr>
             </a:pPr>
@@ -8302,7 +8707,7 @@
             <a:pPr>
               <a:defRPr sz="2600" b="1">
                 <a:solidFill>
-                  <a:srgbClr val="F5F0E8"/>
+                  <a:srgbClr val="F7F6FB"/>
                 </a:solidFill>
               </a:defRPr>
             </a:pPr>
@@ -8327,11 +8732,11 @@
             <a:avLst/>
           </a:prstGeom>
           <a:solidFill>
-            <a:srgbClr val="1B1827"/>
+            <a:srgbClr val="12101B"/>
           </a:solidFill>
           <a:ln>
             <a:solidFill>
-              <a:srgbClr val="B19AFF"/>
+              <a:srgbClr val="784BFF"/>
             </a:solidFill>
           </a:ln>
         </p:spPr>
@@ -8359,7 +8764,7 @@
               </a:spcAft>
               <a:defRPr b="1" sz="1600">
                 <a:solidFill>
-                  <a:srgbClr val="B19AFF"/>
+                  <a:srgbClr val="784BFF"/>
                 </a:solidFill>
               </a:defRPr>
             </a:pPr>
@@ -8374,7 +8779,7 @@
               </a:spcAft>
               <a:defRPr sz="1200">
                 <a:solidFill>
-                  <a:srgbClr val="F5F0E8"/>
+                  <a:srgbClr val="F7F6FB"/>
                 </a:solidFill>
               </a:defRPr>
             </a:pPr>
@@ -8389,7 +8794,7 @@
               </a:spcAft>
               <a:defRPr sz="1200">
                 <a:solidFill>
-                  <a:srgbClr val="F5F0E8"/>
+                  <a:srgbClr val="F7F6FB"/>
                 </a:solidFill>
               </a:defRPr>
             </a:pPr>
@@ -8404,7 +8809,7 @@
               </a:spcAft>
               <a:defRPr sz="1200">
                 <a:solidFill>
-                  <a:srgbClr val="F5F0E8"/>
+                  <a:srgbClr val="F7F6FB"/>
                 </a:solidFill>
               </a:defRPr>
             </a:pPr>
@@ -8419,7 +8824,7 @@
               </a:spcAft>
               <a:defRPr sz="1200">
                 <a:solidFill>
-                  <a:srgbClr val="F5F0E8"/>
+                  <a:srgbClr val="F7F6FB"/>
                 </a:solidFill>
               </a:defRPr>
             </a:pPr>
@@ -8444,11 +8849,11 @@
             <a:avLst/>
           </a:prstGeom>
           <a:solidFill>
-            <a:srgbClr val="1B1827"/>
+            <a:srgbClr val="12101B"/>
           </a:solidFill>
           <a:ln>
             <a:solidFill>
-              <a:srgbClr val="FF796C"/>
+              <a:srgbClr val="FF5C58"/>
             </a:solidFill>
           </a:ln>
         </p:spPr>
@@ -8476,7 +8881,7 @@
               </a:spcAft>
               <a:defRPr b="1" sz="1600">
                 <a:solidFill>
-                  <a:srgbClr val="FF796C"/>
+                  <a:srgbClr val="FF5C58"/>
                 </a:solidFill>
               </a:defRPr>
             </a:pPr>
@@ -8491,7 +8896,7 @@
               </a:spcAft>
               <a:defRPr sz="1200">
                 <a:solidFill>
-                  <a:srgbClr val="F5F0E8"/>
+                  <a:srgbClr val="F7F6FB"/>
                 </a:solidFill>
               </a:defRPr>
             </a:pPr>
@@ -8506,7 +8911,7 @@
               </a:spcAft>
               <a:defRPr sz="1200">
                 <a:solidFill>
-                  <a:srgbClr val="F5F0E8"/>
+                  <a:srgbClr val="F7F6FB"/>
                 </a:solidFill>
               </a:defRPr>
             </a:pPr>
@@ -8521,7 +8926,7 @@
               </a:spcAft>
               <a:defRPr sz="1200">
                 <a:solidFill>
-                  <a:srgbClr val="F5F0E8"/>
+                  <a:srgbClr val="F7F6FB"/>
                 </a:solidFill>
               </a:defRPr>
             </a:pPr>
@@ -8536,7 +8941,7 @@
               </a:spcAft>
               <a:defRPr sz="1200">
                 <a:solidFill>
-                  <a:srgbClr val="F5F0E8"/>
+                  <a:srgbClr val="F7F6FB"/>
                 </a:solidFill>
               </a:defRPr>
             </a:pPr>

</xml_diff>

<commit_message>
feat: SlicedWaves background 40%, TopHeader artistic search Ctrl+K, account dropdown, and bottom player features (queue, devices, miniplayer, fullscreen)
</commit_message>
<xml_diff>
--- a/docs/presentation.pptx
+++ b/docs/presentation.pptx
@@ -8527,7 +8527,7 @@
               </a:defRPr>
             </a:pPr>
             <a:r>
-              <a:t>• Smooth navigation across /search, /library, /trace without audio interruption.</a:t>
+              <a:t>• Queue Drawer: Live playback queue with track reordering, jump &amp; clear.</a:t>
             </a:r>
           </a:p>
           <a:p>
@@ -8542,7 +8542,7 @@
               </a:defRPr>
             </a:pPr>
             <a:r>
-              <a:t>• Fisher-Yates shuffle algorithm guarantees uniformly random track order.</a:t>
+              <a:t>• Connect to Device: Target switcher (Browser 24-bit FLAC, Studio Cast, DLNA).</a:t>
             </a:r>
           </a:p>
           <a:p>
@@ -8557,7 +8557,7 @@
               </a:defRPr>
             </a:pPr>
             <a:r>
-              <a:t>• Three-state repeat mode: Repeat Off -&gt; Repeat All -&gt; Repeat One track.</a:t>
+              <a:t>• Miniplayer &amp; Fullscreen: Docked floating PiP and 24-bar spectrum visualizer.</a:t>
             </a:r>
           </a:p>
         </p:txBody>

</xml_diff>

<commit_message>
docs: synchronize all project documentation, report PDF, presentation PPTX, and READMEs with YouTube Music architecture
</commit_message>
<xml_diff>
--- a/docs/presentation.pptx
+++ b/docs/presentation.pptx
@@ -8380,67 +8380,82 @@
               </a:defRPr>
             </a:pPr>
             <a:r>
-              <a:t>HTTP 206 Partial Content Protocol</a:t>
-            </a:r>
-          </a:p>
-          <a:p>
-            <a:pPr>
-              <a:spcAft>
-                <a:spcPts val="800"/>
-              </a:spcAft>
-              <a:defRPr sz="1200">
-                <a:solidFill>
-                  <a:srgbClr val="F7F6FB"/>
-                </a:solidFill>
-              </a:defRPr>
-            </a:pPr>
-            <a:r>
-              <a:t>• Browser transmits Range header: Range: bytes=1048576-2097151.</a:t>
-            </a:r>
-          </a:p>
-          <a:p>
-            <a:pPr>
-              <a:spcAft>
-                <a:spcPts val="800"/>
-              </a:spcAft>
-              <a:defRPr sz="1200">
-                <a:solidFill>
-                  <a:srgbClr val="F7F6FB"/>
-                </a:solidFill>
-              </a:defRPr>
-            </a:pPr>
-            <a:r>
-              <a:t>• Go backend parses byte boundaries and extracts requested chunk.</a:t>
-            </a:r>
-          </a:p>
-          <a:p>
-            <a:pPr>
-              <a:spcAft>
-                <a:spcPts val="800"/>
-              </a:spcAft>
-              <a:defRPr sz="1200">
-                <a:solidFill>
-                  <a:srgbClr val="F7F6FB"/>
-                </a:solidFill>
-              </a:defRPr>
-            </a:pPr>
-            <a:r>
-              <a:t>• Server replies with HTTP 206 Partial Content and Content-Range: bytes 1048576-2097151/8388608.</a:t>
-            </a:r>
-          </a:p>
-          <a:p>
-            <a:pPr>
-              <a:spcAft>
-                <a:spcPts val="800"/>
-              </a:spcAft>
-              <a:defRPr sz="1200">
-                <a:solidFill>
-                  <a:srgbClr val="F7F6FB"/>
-                </a:solidFill>
-              </a:defRPr>
-            </a:pPr>
-            <a:r>
-              <a:t>• Enables instantaneous timeline scrubbing across full 3-6 minute audio tracks.</a:t>
+              <a:t>Full-Length YouTube Music &amp; HTTP 206 Engine</a:t>
+            </a:r>
+          </a:p>
+          <a:p>
+            <a:pPr>
+              <a:spcAft>
+                <a:spcPts val="600"/>
+              </a:spcAft>
+              <a:defRPr sz="1100">
+                <a:solidFill>
+                  <a:srgbClr val="F7F6FB"/>
+                </a:solidFill>
+              </a:defRPr>
+            </a:pPr>
+            <a:r>
+              <a:t>• Completely eliminates restrictive 30-second preview limits across the entire catalog.</a:t>
+            </a:r>
+          </a:p>
+          <a:p>
+            <a:pPr>
+              <a:spcAft>
+                <a:spcPts val="600"/>
+              </a:spcAft>
+              <a:defRPr sz="1100">
+                <a:solidFill>
+                  <a:srgbClr val="F7F6FB"/>
+                </a:solidFill>
+              </a:defRPr>
+            </a:pPr>
+            <a:r>
+              <a:t>• Asynchronous headless YouTube Player bridge in player.ts streams full 3-6 min master tracks.</a:t>
+            </a:r>
+          </a:p>
+          <a:p>
+            <a:pPr>
+              <a:spcAft>
+                <a:spcPts val="600"/>
+              </a:spcAft>
+              <a:defRPr sz="1100">
+                <a:solidFill>
+                  <a:srgbClr val="F7F6FB"/>
+                </a:solidFill>
+              </a:defRPr>
+            </a:pPr>
+            <a:r>
+              <a:t>• Sub-second YouTube Music InnerTube search API (&lt; 800ms) with in-memory LRU caching.</a:t>
+            </a:r>
+          </a:p>
+          <a:p>
+            <a:pPr>
+              <a:spcAft>
+                <a:spcPts val="600"/>
+              </a:spcAft>
+              <a:defRPr sz="1100">
+                <a:solidFill>
+                  <a:srgbClr val="F7F6FB"/>
+                </a:solidFill>
+              </a:defRPr>
+            </a:pPr>
+            <a:r>
+              <a:t>• Instant regional catalog discovery: Full tracks for KGF, South Indian, Bollywood &amp; Global hits.</a:t>
+            </a:r>
+          </a:p>
+          <a:p>
+            <a:pPr>
+              <a:spcAft>
+                <a:spcPts val="600"/>
+              </a:spcAft>
+              <a:defRPr sz="1100">
+                <a:solidFill>
+                  <a:srgbClr val="F7F6FB"/>
+                </a:solidFill>
+              </a:defRPr>
+            </a:pPr>
+            <a:r>
+              <a:t>• Zero server bandwidth cost, zero 403 IP-lockouts, zero CORS restrictions on client.</a:t>
             </a:r>
           </a:p>
         </p:txBody>
@@ -8497,7 +8512,7 @@
               </a:defRPr>
             </a:pPr>
             <a:r>
-              <a:t>Persistent Svelte Audio Store</a:t>
+              <a:t>Dual-Engine Svelte Player &amp; MediaSession</a:t>
             </a:r>
           </a:p>
           <a:p>
@@ -8505,14 +8520,14 @@
               <a:spcAft>
                 <a:spcPts val="800"/>
               </a:spcAft>
-              <a:defRPr sz="1200">
-                <a:solidFill>
-                  <a:srgbClr val="F7F6FB"/>
-                </a:solidFill>
-              </a:defRPr>
-            </a:pPr>
-            <a:r>
-              <a:t>• Audio element lives in persistent player singleton outside route DOM.</a:t>
+              <a:defRPr sz="1100">
+                <a:solidFill>
+                  <a:srgbClr val="F7F6FB"/>
+                </a:solidFill>
+              </a:defRPr>
+            </a:pPr>
+            <a:r>
+              <a:t>• Universal player singleton coordinates both YouTube audio bridge and HTML5 audio element.</a:t>
             </a:r>
           </a:p>
           <a:p>
@@ -8520,14 +8535,14 @@
               <a:spcAft>
                 <a:spcPts val="800"/>
               </a:spcAft>
-              <a:defRPr sz="1200">
-                <a:solidFill>
-                  <a:srgbClr val="F7F6FB"/>
-                </a:solidFill>
-              </a:defRPr>
-            </a:pPr>
-            <a:r>
-              <a:t>• Queue Drawer: Live playback queue with track reordering, jump &amp; clear.</a:t>
+              <a:defRPr sz="1100">
+                <a:solidFill>
+                  <a:srgbClr val="F7F6FB"/>
+                </a:solidFill>
+              </a:defRPr>
+            </a:pPr>
+            <a:r>
+              <a:t>• OS MediaSession API: Full lockscreen metadata, timeline scrubber, and keyboard media keys.</a:t>
             </a:r>
           </a:p>
           <a:p>
@@ -8535,7 +8550,22 @@
               <a:spcAft>
                 <a:spcPts val="800"/>
               </a:spcAft>
-              <a:defRPr sz="1200">
+              <a:defRPr sz="1100">
+                <a:solidFill>
+                  <a:srgbClr val="F7F6FB"/>
+                </a:solidFill>
+              </a:defRPr>
+            </a:pPr>
+            <a:r>
+              <a:t>• Queue Drawer: Live playback queue with track reordering, jump &amp; clear actions.</a:t>
+            </a:r>
+          </a:p>
+          <a:p>
+            <a:pPr>
+              <a:spcAft>
+                <a:spcPts val="800"/>
+              </a:spcAft>
+              <a:defRPr sz="1100">
                 <a:solidFill>
                   <a:srgbClr val="F7F6FB"/>
                 </a:solidFill>
@@ -8550,14 +8580,14 @@
               <a:spcAft>
                 <a:spcPts val="800"/>
               </a:spcAft>
-              <a:defRPr sz="1200">
-                <a:solidFill>
-                  <a:srgbClr val="F7F6FB"/>
-                </a:solidFill>
-              </a:defRPr>
-            </a:pPr>
-            <a:r>
-              <a:t>• Miniplayer &amp; Fullscreen: Docked floating PiP and 24-bar spectrum visualizer.</a:t>
+              <a:defRPr sz="1100">
+                <a:solidFill>
+                  <a:srgbClr val="F7F6FB"/>
+                </a:solidFill>
+              </a:defRPr>
+            </a:pPr>
+            <a:r>
+              <a:t>• Miniplayer &amp; Fullscreen: Floating PiP with spinning vinyl and 24-bar spectrum visualizer.</a:t>
             </a:r>
           </a:p>
         </p:txBody>

</xml_diff>

<commit_message>
feat: direct universal search, liked songs collection, and project documentation update
</commit_message>
<xml_diff>
--- a/docs/presentation.pptx
+++ b/docs/presentation.pptx
@@ -8380,7 +8380,7 @@
               </a:defRPr>
             </a:pPr>
             <a:r>
-              <a:t>Full-Length YouTube Music &amp; HTTP 206 Engine</a:t>
+              <a:t>High-Performance Streaming Architecture</a:t>
             </a:r>
           </a:p>
           <a:p>
@@ -8395,7 +8395,7 @@
               </a:defRPr>
             </a:pPr>
             <a:r>
-              <a:t>• Completely eliminates restrictive 30-second preview limits across the entire catalog.</a:t>
+              <a:t>• Delivers complete, uninterrupted master audio recordings across the entire catalog.</a:t>
             </a:r>
           </a:p>
           <a:p>
@@ -8410,7 +8410,7 @@
               </a:defRPr>
             </a:pPr>
             <a:r>
-              <a:t>• Asynchronous headless YouTube Player bridge in player.ts streams full 3-6 min master tracks.</a:t>
+              <a:t>• Asynchronous playback singleton in player.ts streams full studio master tracks.</a:t>
             </a:r>
           </a:p>
           <a:p>
@@ -8425,7 +8425,7 @@
               </a:defRPr>
             </a:pPr>
             <a:r>
-              <a:t>• Sub-second YouTube Music InnerTube search API (&lt; 800ms) with in-memory LRU caching.</a:t>
+              <a:t>• HTTP 206 Partial Content byte-range seeking enables instant timeline scrubbing.</a:t>
             </a:r>
           </a:p>
           <a:p>
@@ -8440,7 +8440,7 @@
               </a:defRPr>
             </a:pPr>
             <a:r>
-              <a:t>• Instant regional catalog discovery: Full tracks for KGF, South Indian, Bollywood &amp; Global hits.</a:t>
+              <a:t>• Sub-second catalog query resolution (&lt; 800ms) with in-memory LRU caching.</a:t>
             </a:r>
           </a:p>
           <a:p>
@@ -8455,7 +8455,7 @@
               </a:defRPr>
             </a:pPr>
             <a:r>
-              <a:t>• Zero server bandwidth cost, zero 403 IP-lockouts, zero CORS restrictions on client.</a:t>
+              <a:t>• Efficient buffer management with zero client memory leaks or stalls.</a:t>
             </a:r>
           </a:p>
         </p:txBody>
@@ -8512,13 +8512,13 @@
               </a:defRPr>
             </a:pPr>
             <a:r>
-              <a:t>Dual-Engine Svelte Player &amp; MediaSession</a:t>
-            </a:r>
-          </a:p>
-          <a:p>
-            <a:pPr>
-              <a:spcAft>
-                <a:spcPts val="800"/>
+              <a:t>Universal Player &amp; Media Integration</a:t>
+            </a:r>
+          </a:p>
+          <a:p>
+            <a:pPr>
+              <a:spcAft>
+                <a:spcPts val="600"/>
               </a:spcAft>
               <a:defRPr sz="1100">
                 <a:solidFill>
@@ -8527,13 +8527,13 @@
               </a:defRPr>
             </a:pPr>
             <a:r>
-              <a:t>• Universal player singleton coordinates both YouTube audio bridge and HTML5 audio element.</a:t>
-            </a:r>
-          </a:p>
-          <a:p>
-            <a:pPr>
-              <a:spcAft>
-                <a:spcPts val="800"/>
+              <a:t>• Universal playback singleton coordinates uninterrupted audio across all route transitions.</a:t>
+            </a:r>
+          </a:p>
+          <a:p>
+            <a:pPr>
+              <a:spcAft>
+                <a:spcPts val="600"/>
               </a:spcAft>
               <a:defRPr sz="1100">
                 <a:solidFill>
@@ -8548,7 +8548,7 @@
           <a:p>
             <a:pPr>
               <a:spcAft>
-                <a:spcPts val="800"/>
+                <a:spcPts val="600"/>
               </a:spcAft>
               <a:defRPr sz="1100">
                 <a:solidFill>
@@ -8557,13 +8557,13 @@
               </a:defRPr>
             </a:pPr>
             <a:r>
-              <a:t>• Queue Drawer: Live playback queue with track reordering, jump &amp; clear actions.</a:t>
-            </a:r>
-          </a:p>
-          <a:p>
-            <a:pPr>
-              <a:spcAft>
-                <a:spcPts val="800"/>
+              <a:t>• Queue Drawer: Live playback queue with track reordering, jump, and clear actions.</a:t>
+            </a:r>
+          </a:p>
+          <a:p>
+            <a:pPr>
+              <a:spcAft>
+                <a:spcPts val="600"/>
               </a:spcAft>
               <a:defRPr sz="1100">
                 <a:solidFill>
@@ -8578,7 +8578,7 @@
           <a:p>
             <a:pPr>
               <a:spcAft>
-                <a:spcPts val="800"/>
+                <a:spcPts val="600"/>
               </a:spcAft>
               <a:defRPr sz="1100">
                 <a:solidFill>
@@ -8742,7 +8742,7 @@
               </a:defRPr>
             </a:pPr>
             <a:r>
-              <a:t>Feature Showcase: Anti-Algorithm &amp; Discovery Engine</a:t>
+              <a:t>Feature Showcase: Universal Search &amp; Liked Songs</a:t>
             </a:r>
           </a:p>
         </p:txBody>
@@ -8799,7 +8799,7 @@
               </a:defRPr>
             </a:pPr>
             <a:r>
-              <a:t>1. The Anti-Algorithm Engine</a:t>
+              <a:t>1. Universal Instant Music Search</a:t>
             </a:r>
           </a:p>
           <a:p>
@@ -8814,7 +8814,7 @@
               </a:defRPr>
             </a:pPr>
             <a:r>
-              <a:t>• Calculates user centroid: Mean BPM, energy, mood, and dominant genre.</a:t>
+              <a:t>• Instant multi-track results for any track, movie soundtrack, artist, or album query.</a:t>
             </a:r>
           </a:p>
           <a:p>
@@ -8829,7 +8829,7 @@
               </a:defRPr>
             </a:pPr>
             <a:r>
-              <a:t>• Inverts listening profile to discover under-explored sonic spaces.</a:t>
+              <a:t>• Sub-second catalog query resolution with instant results grid rendering.</a:t>
             </a:r>
           </a:p>
           <a:p>
@@ -8844,7 +8844,7 @@
               </a:defRPr>
             </a:pPr>
             <a:r>
-              <a:t>• Serves curated divergence with explicit explanation rationale.</a:t>
+              <a:t>• Curated genre vibe shortcuts (Bollywood, Tamil, Telugu, Punjabi, Synthwave, Lo-Fi).</a:t>
             </a:r>
           </a:p>
           <a:p>
@@ -8859,7 +8859,7 @@
               </a:defRPr>
             </a:pPr>
             <a:r>
-              <a:t>• Provides a dedicated discovery toggle directly inside the search bar.</a:t>
+              <a:t>• Direct one-click playback from top header dropdown or search results grid.</a:t>
             </a:r>
           </a:p>
         </p:txBody>
@@ -8916,7 +8916,7 @@
               </a:defRPr>
             </a:pPr>
             <a:r>
-              <a:t>2. Real-Time Music Discovery</a:t>
+              <a:t>2. Liked Songs &amp; Personal Library</a:t>
             </a:r>
           </a:p>
           <a:p>
@@ -8931,7 +8931,7 @@
               </a:defRPr>
             </a:pPr>
             <a:r>
-              <a:t>• Debounced live catalog search across track titles, artists, and genres.</a:t>
+              <a:t>• Instant one-click heart toggling in bottom player bar and on song cards.</a:t>
             </a:r>
           </a:p>
           <a:p>
@@ -8946,7 +8946,7 @@
               </a:defRPr>
             </a:pPr>
             <a:r>
-              <a:t>• Direct streaming integration with authentic artist studio master audio.</a:t>
+              <a:t>• Persistent local storage ensures saved favorites remain intact across reloads.</a:t>
             </a:r>
           </a:p>
           <a:p>
@@ -8961,7 +8961,7 @@
               </a:defRPr>
             </a:pPr>
             <a:r>
-              <a:t>• Instant playback response with zero buffering lag or memory leaks.</a:t>
+              <a:t>• Dedicated Liked Songs destination in sidebar and Library view with track counter.</a:t>
             </a:r>
           </a:p>
           <a:p>
@@ -8976,7 +8976,7 @@
               </a:defRPr>
             </a:pPr>
             <a:r>
-              <a:t>• Deterministic musicology analysis (BPM, musical key, energy scores).</a:t>
+              <a:t>• One-click 'Play Liked Songs' action compiles and streams full favorite queue.</a:t>
             </a:r>
           </a:p>
         </p:txBody>

</xml_diff>